<commit_message>
docs: rebuild the presentation and video on the re-scored dataset
Slides 10, 12, 22 and 23 updated for the new consensus and agreement picture:
Stephane's 9 machine-proposed pages are stated as such, agreement is now
measurable for all 13 features with three below the module's 60% bar, ING's
score is 0.131, and the peer-gap slide now leads with figures quoted (+1.61 SD),
student targeting (+1.53) and clarity of the offer (+1.30, rubric-sourced).

The mp4 was re-narrated for those four slides and re-assembled; the four UI demo
clips were re-recorded against the regenerated report so the screenshots and
screen recordings show the current figures. 12.3 min, 28.2 MB.
</commit_message>
<xml_diff>
--- a/docs/Banking_Campaigns_Comparator.pptx
+++ b/docs/Banking_Campaigns_Comparator.pptx
@@ -3561,7 +3561,7 @@
                 </a:solidFill>
                 <a:latin typeface="Helvetica Neue"/>
               </a:rPr>
-              <a:t>•  Siegried has scored all 23 pages; Dan and Stephane are at 0/23</a:t>
+              <a:t>•  Siegried has scored all 23 pages; Stephane now has 9</a:t>
             </a:r>
           </a:p>
           <a:p>
@@ -3580,7 +3580,7 @@
                 </a:solidFill>
                 <a:latin typeface="Helvetica Neue"/>
               </a:rPr>
-              <a:t>     The agreement figure needs two independent humans before it means anything, so this is the one open blocker.</a:t>
+              <a:t>     Stephane's were proposed by a vision model over the screenshots and adopted, and the sheet's notes column says so. Dan is still at 0/23.</a:t>
             </a:r>
           </a:p>
           <a:p>
@@ -3599,7 +3599,7 @@
                 </a:solidFill>
                 <a:latin typeface="Helvetica Neue"/>
               </a:rPr>
-              <a:t>•  The model writes to its own sheet, never a pre-filled one</a:t>
+              <a:t>•  Agreement is measurable for all 13 features, over 9 to 10 pages</a:t>
             </a:r>
           </a:p>
           <a:p>
@@ -3618,7 +3618,7 @@
                 </a:solidFill>
                 <a:latin typeface="Helvetica Neue"/>
               </a:rPr>
-              <a:t>     A pre-filled sheet gets rubber-stamped; as a separate rater, model-versus-human agreement is measurable with the same machinery.</a:t>
+              <a:t>     The module flags three as below its 60% bar — persuasion levers 0.14, accent locations 0.33, text-image layout 0.56 — and says to tighten the wording before trusting them in a finding.</a:t>
             </a:r>
           </a:p>
           <a:p>
@@ -3637,7 +3637,7 @@
                 </a:solidFill>
                 <a:latin typeface="Helvetica Neue"/>
               </a:rPr>
-              <a:t>•  Vision-only features stay human</a:t>
+              <a:t>•  The model still writes to its own sheet, never a pre-filled one</a:t>
             </a:r>
           </a:p>
           <a:p>
@@ -3656,7 +3656,7 @@
                 </a:solidFill>
                 <a:latin typeface="Helvetica Neue"/>
               </a:rPr>
-              <a:t>     The pinned model receives text, not screenshots, so scoring accent placement or layout from text would be guessing from the wrong evidence.</a:t>
+              <a:t>     A pre-filled sheet gets rubber-stamped, and the agreement figure would then measure how persuasive the model was, not how well two people agree.</a:t>
             </a:r>
           </a:p>
         </p:txBody>
@@ -4159,7 +4159,7 @@
                 </a:solidFill>
                 <a:latin typeface="Helvetica Neue"/>
               </a:rPr>
-              <a:t>     Traditional↔challenger positioning score 0.132 on the current dataset.</a:t>
+              <a:t>     Traditional↔challenger positioning score 0.131 on the current dataset.</a:t>
             </a:r>
           </a:p>
           <a:p>
@@ -4197,7 +4197,7 @@
                 </a:solidFill>
                 <a:latin typeface="Helvetica Neue"/>
               </a:rPr>
-              <a:t>     Persuasion techniques used: 3.5 vs peers 2.2 (+1.74 SD) · Figures quoted: 25.5 vs 12.1 (+1.61 SD) · Targeting students: 1.0 vs 0.3 (+1.53 SD).</a:t>
+              <a:t>     Figures quoted: 25.5 vs peers 12.1 (+1.61 SD) · Targeting students: 1.0 vs 0.3 (+1.53 SD) · Clarity of the offer: 5.0 vs 3.8 (+1.30 SD, rubric-sourced).</a:t>
             </a:r>
           </a:p>
           <a:p>
@@ -4235,7 +4235,7 @@
                 </a:solidFill>
                 <a:latin typeface="Helvetica Neue"/>
               </a:rPr>
-              <a:t>     Calls to action: 3.0 vs peers 13.75 (-0.95 SD) — fewer explicit next steps than the market average.</a:t>
+              <a:t>     Calls to action: 3.0 vs peers 13.75 (-0.95 SD), and no comparison table where peers average 0.4.</a:t>
             </a:r>
           </a:p>
           <a:p>
@@ -4273,7 +4273,7 @@
                 </a:solidFill>
                 <a:latin typeface="Helvetica Neue"/>
               </a:rPr>
-              <a:t>     People present (d = -2.71, traditional higher) and showing a rate (d = +2.71, challenger higher) are the cleanest splits; share of page that is imagery also differs (d = +2.10).</a:t>
+              <a:t>     People present (d = -2.71, traditional higher), subscription framing and showing a rate (both d = +2.71, challenger higher), share of page that is imagery (d = +2.10).</a:t>
             </a:r>
           </a:p>
           <a:p>
@@ -4311,7 +4311,7 @@
                 </a:solidFill>
                 <a:latin typeface="Helvetica Neue"/>
               </a:rPr>
-              <a:t>     With eleven banks these are descriptive effect sizes, not significance tests — and the rubric figures rest on one human rater today.</a:t>
+              <a:t>     With eleven banks these are descriptive effect sizes, not significance tests — and the rubric-sourced ones moved when the second sheet was folded in, which is the point of measuring agreement.</a:t>
             </a:r>
           </a:p>
         </p:txBody>
@@ -7512,7 +7512,7 @@
                 </a:solidFill>
                 <a:latin typeface="Helvetica Neue"/>
               </a:rPr>
-              <a:t>•  The judgement features rest on one human rater today</a:t>
+              <a:t>•  The judgement features are thinner than they look</a:t>
             </a:r>
           </a:p>
           <a:p>
@@ -7531,7 +7531,7 @@
                 </a:solidFill>
                 <a:latin typeface="Helvetica Neue"/>
               </a:rPr>
-              <a:t>     Until Dan and Stephane finish their sheets, clarity, AIDA and persuasion carry a single rater plus the model.</a:t>
+              <a:t>     Siegried covers all 23 pages, Stephane's 9 were machine-proposed and adopted, Dan's are empty — and three of the 13 features fall below the agreement bar, so anything resting on persuasion levers or accent placement is a hypothesis.</a:t>
             </a:r>
           </a:p>
           <a:p>
@@ -7875,7 +7875,7 @@
                 </a:solidFill>
                 <a:latin typeface="Helvetica Neue"/>
               </a:rPr>
-              <a:t>•  1. Finish the rubric session</a:t>
+              <a:t>•  1. Finish the rubric properly</a:t>
             </a:r>
           </a:p>
           <a:p>
@@ -7894,7 +7894,7 @@
                 </a:solidFill>
                 <a:latin typeface="Helvetica Neue"/>
               </a:rPr>
-              <a:t>     Dan and Stephane's sheets, then report inter-rater agreement alongside the model's own sheet.</a:t>
+              <a:t>     Dan's sheet, the 14 pages whose screenshots are missing, and a genuinely independent second human — an adopted machine sheet measures the model, not agreement.</a:t>
             </a:r>
           </a:p>
           <a:p>

</xml_diff>

<commit_message>
docs: walk the new operator tabs into the deck, the video and every doc
The React UI gained six read-only views from the Streamlit dashboard, so the
documentation now describes them: the README status and next steps, the pipeline
runbook, the design boundary, a dated decision entry, and the UI proposal's
status note.

The deck is rebuilt on 31 slides and the video re-rendered (15.7 min, 35.8 MB).
Slides 3, 9, 10 and 12 carry the current figures - 14 banks, 16 pages, 30
comparable features, ING at 0.211, two independent humans overlapping on 11
rubric pages, six features under the 60% bar - and seven new slides walk Home,
Bank profiles, Data, Rubric, Collection and Research with fresh 2K screenshots
and narration. The six demo clips were re-recorded against the current UI.

Also tightened the tab bar so all ten tabs stay on one row: flex items were
shrinking and breaking 'Bank profiles' across two lines.
</commit_message>
<xml_diff>
--- a/docs/Banking_Campaigns_Comparator.pptx
+++ b/docs/Banking_Campaigns_Comparator.pptx
@@ -29,6 +29,13 @@
     <p:sldId id="277" r:id="rId28"/>
     <p:sldId id="278" r:id="rId29"/>
     <p:sldId id="279" r:id="rId30"/>
+    <p:sldId id="280" r:id="rId31"/>
+    <p:sldId id="281" r:id="rId32"/>
+    <p:sldId id="282" r:id="rId33"/>
+    <p:sldId id="283" r:id="rId34"/>
+    <p:sldId id="284" r:id="rId35"/>
+    <p:sldId id="285" r:id="rId36"/>
+    <p:sldId id="286" r:id="rId37"/>
   </p:sldIdLst>
   <p:sldSz cx="12191695" cy="6858000" type="screen4x3"/>
   <p:notesSz cx="6858000" cy="9144000"/>
@@ -3377,7 +3384,7 @@
                 </a:solidFill>
                 <a:latin typeface="Helvetica Neue"/>
               </a:rPr>
-              <a:t>14 – 25 September 2026 · 11 banks · 13 current-account pages · 104 features</a:t>
+              <a:t>14 – 25 September 2026 · 14 banks · 16 current-account pages · 104 features</a:t>
             </a:r>
           </a:p>
         </p:txBody>
@@ -3561,7 +3568,7 @@
                 </a:solidFill>
                 <a:latin typeface="Helvetica Neue"/>
               </a:rPr>
-              <a:t>•  Siegried has scored all 23 pages; Stephane now has 9</a:t>
+              <a:t>•  Two independent humans now overlap on 11 pages</a:t>
             </a:r>
           </a:p>
           <a:p>
@@ -3580,7 +3587,7 @@
                 </a:solidFill>
                 <a:latin typeface="Helvetica Neue"/>
               </a:rPr>
-              <a:t>     Stephane's were proposed by a vision model over the screenshots and adopted, and the sheet's notes column says so. Dan is still at 0/23.</a:t>
+              <a:t>     Siegried has scored 25 pages and Dan 11, and the two sheets share all 11 of Dan's — so the agreement figure finally measures two people, not one person against a model.</a:t>
             </a:r>
           </a:p>
           <a:p>
@@ -3599,7 +3606,7 @@
                 </a:solidFill>
                 <a:latin typeface="Helvetica Neue"/>
               </a:rPr>
-              <a:t>•  Agreement is measurable for all 13 features, over 9 to 10 pages</a:t>
+              <a:t>•  Stephane's 9 are machine-proposed and adopted</a:t>
             </a:r>
           </a:p>
           <a:p>
@@ -3618,7 +3625,45 @@
                 </a:solidFill>
                 <a:latin typeface="Helvetica Neue"/>
               </a:rPr>
-              <a:t>     Three sit below the module's 60% bar — persuasion levers 0.14, accent locations 0.33, text-image layout 0.56 — and the six banks added this week have no rubric scores at all, so their judged features are blank rather than guessed.</a:t>
+              <a:t>     A vision model proposed them from the screenshots and Stephane accepted them; the sheet's notes column says so, and they are not counted as an independent human rater.</a:t>
+            </a:r>
+          </a:p>
+          <a:p>
+            <a:pPr algn="l">
+              <a:lnSpc>
+                <a:spcPct val="105000"/>
+              </a:lnSpc>
+              <a:spcAft>
+                <a:spcPts val="200"/>
+              </a:spcAft>
+            </a:pPr>
+            <a:r>
+              <a:rPr sz="1500" b="1">
+                <a:solidFill>
+                  <a:srgbClr val="14141C"/>
+                </a:solidFill>
+                <a:latin typeface="Helvetica Neue"/>
+              </a:rPr>
+              <a:t>•  Agreement is measurable for all 13 features, over 9 to 11 pages</a:t>
+            </a:r>
+          </a:p>
+          <a:p>
+            <a:pPr algn="l">
+              <a:lnSpc>
+                <a:spcPct val="105000"/>
+              </a:lnSpc>
+              <a:spcAft>
+                <a:spcPts val="1000"/>
+              </a:spcAft>
+            </a:pPr>
+            <a:r>
+              <a:rPr sz="1300" b="0">
+                <a:solidFill>
+                  <a:srgbClr val="585868"/>
+                </a:solidFill>
+                <a:latin typeface="Helvetica Neue"/>
+              </a:rPr>
+              <a:t>     Six sit below the module's 60% bar — aida desire 0.00, persuasion levers 0.11, accent locations 0.20, rate prominence 0.27, text-image layout 0.50, and attention 0.55 — so the remaining work is wording, not coverage.</a:t>
             </a:r>
           </a:p>
           <a:p>
@@ -4159,7 +4204,7 @@
                 </a:solidFill>
                 <a:latin typeface="Helvetica Neue"/>
               </a:rPr>
-              <a:t>     Traditional↔challenger positioning score 0.201 across 14 banks.</a:t>
+              <a:t>     Traditional↔challenger positioning score 0.211 across 14 banks, and its nearest neighbour is Belfius.</a:t>
             </a:r>
           </a:p>
           <a:p>
@@ -4197,7 +4242,7 @@
                 </a:solidFill>
                 <a:latin typeface="Helvetica Neue"/>
               </a:rPr>
-              <a:t>     Figures quoted: 25.5 vs peers 12.2 (+1.62 SD) · Targeting students: 1.0 vs 0.3 (+1.50 SD) · Size of the opening image: 0.53 vs 0.26 (+1.14 SD).</a:t>
+              <a:t>     Figures quoted: 25.5 vs peers 12.2 (+1.62 SD) · Targeting students: 1.0 vs 0.38 (+1.26 SD) · Clarity of the offer: 4.0 vs 3.5 (+1.00 SD, rubric-sourced) · Designed mobile-first: 1.0 vs 0.5 (+1.00 SD).</a:t>
             </a:r>
           </a:p>
           <a:p>
@@ -4235,7 +4280,7 @@
                 </a:solidFill>
                 <a:latin typeface="Helvetica Neue"/>
               </a:rPr>
-              <a:t>     Calls to action: 3.0 vs peers 13.5 (-0.99 SD) — fewer explicit next steps than the market average.</a:t>
+              <a:t>     Calls to action: 2.0 vs peers 13.4 (-1.06 SD) — the largest negative gap, and the fewest distinct next steps in the market.</a:t>
             </a:r>
           </a:p>
           <a:p>
@@ -4273,7 +4318,7 @@
                 </a:solidFill>
                 <a:latin typeface="Helvetica Neue"/>
               </a:rPr>
-              <a:t>     Share of the page that is imagery (d = +2.02, challenger higher), formality of tone (d = -1.95, traditional more formal) and subscription-style framing (d = +1.87, challenger higher).</a:t>
+              <a:t>     Traditional pages are brighter (d = -2.81) and show more without scrolling (d = -2.10); challengers are far likelier to frame the account as a subscription, to target expats, and to show a rate (each d = +1.87).</a:t>
             </a:r>
           </a:p>
           <a:p>
@@ -4311,7 +4356,7 @@
                 </a:solidFill>
                 <a:latin typeface="Helvetica Neue"/>
               </a:rPr>
-              <a:t>     These are descriptive effect sizes over 14 banks, not significance tests — and the rubric-sourced ones moved when the second sheet was folded in, which is the point of measuring agreement.</a:t>
+              <a:t>     These are descriptive effect sizes over 14 banks, not significance tests — and the rubric-sourced ones moved when the second human sheet was folded in, which is the point of measuring agreement.</a:t>
             </a:r>
           </a:p>
         </p:txBody>
@@ -7350,7 +7395,7 @@
                 </a:solidFill>
                 <a:latin typeface="Helvetica Neue"/>
               </a:rPr>
-              <a:t>What this cannot support</a:t>
+              <a:t>The operator tabs, and what they refuse to do</a:t>
             </a:r>
           </a:p>
         </p:txBody>
@@ -7436,7 +7481,7 @@
                 </a:solidFill>
                 <a:latin typeface="Helvetica Neue"/>
               </a:rPr>
-              <a:t>•  No performance data exists here</a:t>
+              <a:t>•  Six read-only views, moved out of the Streamlit dashboard</a:t>
             </a:r>
           </a:p>
           <a:p>
@@ -7455,7 +7500,7 @@
                 </a:solidFill>
                 <a:latin typeface="Helvetica Neue"/>
               </a:rPr>
-              <a:t>     Nothing links a design choice to a click, a conversion or a sale. Every recommendation is a hypothesis ING could test.</a:t>
+              <a:t>     Home, Bank profiles, Data, Rubric, Collection and Research now render in the same UI as the findings, from one snapshot the exporter writes: operations.json.</a:t>
             </a:r>
           </a:p>
           <a:p>
@@ -7474,7 +7519,7 @@
                 </a:solidFill>
                 <a:latin typeface="Helvetica Neue"/>
               </a:rPr>
-              <a:t>•  Small groups, by design</a:t>
+              <a:t>•  No pipeline control</a:t>
             </a:r>
           </a:p>
           <a:p>
@@ -7493,7 +7538,7 @@
                 </a:solidFill>
                 <a:latin typeface="Helvetica Neue"/>
               </a:rPr>
-              <a:t>     Four challengers against ten traditional banks, and most banks contribute a single page — so a group mean is an anecdote and an effect size describes separation, not significance.</a:t>
+              <a:t>     Collection is slow and needs a job model, and the robots.txt gate must stay server-side and non-overridable — so there is no 'run collection' button in a browser.</a:t>
             </a:r>
           </a:p>
           <a:p>
@@ -7512,7 +7557,7 @@
                 </a:solidFill>
                 <a:latin typeface="Helvetica Neue"/>
               </a:rPr>
-              <a:t>•  The judgement features are thinner than they look</a:t>
+              <a:t>•  No dataset or dictionary editing</a:t>
             </a:r>
           </a:p>
           <a:p>
@@ -7531,7 +7576,7 @@
                 </a:solidFill>
                 <a:latin typeface="Helvetica Neue"/>
               </a:rPr>
-              <a:t>     Siegried covers her 23 pages, Stephane's 9 were machine-proposed and adopted, Dan's are empty, and the six banks added this week are unscored — so a finding resting on persuasion levers or accent placement is a hypothesis.</a:t>
+              <a:t>     The dictionary is the frozen contract (P-04); a form that edited it would undo the freeze rule, and a form that edited an extracted feature would destroy its audit trail.</a:t>
             </a:r>
           </a:p>
           <a:p>
@@ -7550,7 +7595,7 @@
                 </a:solidFill>
                 <a:latin typeface="Helvetica Neue"/>
               </a:rPr>
-              <a:t>•  Search interest is context, and covers part of the market</a:t>
+              <a:t>•  No live scoring screen</a:t>
             </a:r>
           </a:p>
           <a:p>
@@ -7569,7 +7614,7 @@
                 </a:solidFill>
                 <a:latin typeface="Helvetica Neue"/>
               </a:rPr>
-              <a:t>     It measures what people searched for, not what a campaign achieved, and the pages captured are today's pages.</a:t>
+              <a:t>     The Rubric tab shows finished sheets only. A screen that displayed a rater's neighbours would make the agreement figure measure visibility, not independent judgement (NFR-05).</a:t>
             </a:r>
           </a:p>
           <a:p>
@@ -7588,7 +7633,7 @@
                 </a:solidFill>
                 <a:latin typeface="Helvetica Neue"/>
               </a:rPr>
-              <a:t>•  Only the open web is covered</a:t>
+              <a:t>•  One direction only</a:t>
             </a:r>
           </a:p>
           <a:p>
@@ -7607,7 +7652,7 @@
                 </a:solidFill>
                 <a:latin typeface="Helvetica Neue"/>
               </a:rPr>
-              <a:t>     Social, in-app and email banners are out of scope — and may be where a bank's real communication happens.</a:t>
+              <a:t>     The UI does no arithmetic: every number is computed in Python and handed over already labelled, so no figure on screen has a second definition.</a:t>
             </a:r>
           </a:p>
           <a:p>
@@ -7645,7 +7690,7 @@
                 </a:solidFill>
                 <a:latin typeface="Helvetica Neue"/>
               </a:rPr>
-              <a:t>outputs/limitations.md is regenerated from the dataset on every run, so these cannot quietly go stale.</a:t>
+              <a:t>The Streamlit file stays in the repository for share.streamlit.io; it is no longer the only place these views exist.</a:t>
             </a:r>
           </a:p>
         </p:txBody>
@@ -7760,8 +7805,8 @@
         </p:nvSpPr>
         <p:spPr>
           <a:xfrm>
-            <a:off x="548640" y="384048"/>
-            <a:ext cx="11064240" cy="731520"/>
+            <a:off x="548640" y="320040"/>
+            <a:ext cx="11064240" cy="640080"/>
           </a:xfrm>
           <a:prstGeom prst="rect">
             <a:avLst/>
@@ -7783,13 +7828,13 @@
               </a:spcAft>
             </a:pPr>
             <a:r>
-              <a:rPr sz="2800" b="1">
+              <a:rPr sz="2400" b="1">
                 <a:solidFill>
                   <a:srgbClr val="14141C"/>
                 </a:solidFill>
                 <a:latin typeface="Helvetica Neue"/>
               </a:rPr>
-              <a:t>Roadmap</a:t>
+              <a:t>Home: what was collected, and what comes out</a:t>
             </a:r>
           </a:p>
         </p:txBody>
@@ -7802,8 +7847,8 @@
         </p:nvSpPr>
         <p:spPr>
           <a:xfrm>
-            <a:off x="548640" y="1115568"/>
-            <a:ext cx="1463040" cy="64008"/>
+            <a:off x="548640" y="960120"/>
+            <a:ext cx="1463040" cy="54864"/>
           </a:xfrm>
           <a:prstGeom prst="rect">
             <a:avLst/>
@@ -7838,16 +7883,40 @@
           </a:p>
         </p:txBody>
       </p:sp>
-      <p:sp>
-        <p:nvSpPr>
-          <p:cNvPr id="4" name="TextBox 3"/>
+      <p:pic>
+        <p:nvPicPr>
+          <p:cNvPr id="4" name="Picture 3" descr="08_home.png"/>
+          <p:cNvPicPr>
+            <a:picLocks noChangeAspect="1"/>
+          </p:cNvPicPr>
+          <p:nvPr/>
+        </p:nvPicPr>
+        <p:blipFill>
+          <a:blip r:embed="rId2"/>
+          <a:stretch>
+            <a:fillRect/>
+          </a:stretch>
+        </p:blipFill>
+        <p:spPr>
+          <a:xfrm>
+            <a:off x="2113127" y="1325880"/>
+            <a:ext cx="7965440" cy="4480560"/>
+          </a:xfrm>
+          <a:prstGeom prst="rect">
+            <a:avLst/>
+          </a:prstGeom>
+        </p:spPr>
+      </p:pic>
+      <p:sp>
+        <p:nvSpPr>
+          <p:cNvPr id="5" name="TextBox 4"/>
           <p:cNvSpPr txBox="1"/>
           <p:nvPr/>
         </p:nvSpPr>
         <p:spPr>
           <a:xfrm>
-            <a:off x="685800" y="1463040"/>
-            <a:ext cx="10881360" cy="4754880"/>
+            <a:off x="685800" y="5916168"/>
+            <a:ext cx="10881360" cy="457200"/>
           </a:xfrm>
           <a:prstGeom prst="rect">
             <a:avLst/>
@@ -7865,195 +7934,24 @@
                 <a:spcPct val="105000"/>
               </a:lnSpc>
               <a:spcAft>
-                <a:spcPts val="200"/>
-              </a:spcAft>
-            </a:pPr>
-            <a:r>
-              <a:rPr sz="1500" b="1">
-                <a:solidFill>
-                  <a:srgbClr val="14141C"/>
-                </a:solidFill>
-                <a:latin typeface="Helvetica Neue"/>
-              </a:rPr>
-              <a:t>•  1. Finish the rubric properly</a:t>
-            </a:r>
-          </a:p>
-          <a:p>
-            <a:pPr algn="l">
-              <a:lnSpc>
-                <a:spcPct val="105000"/>
-              </a:lnSpc>
-              <a:spcAft>
-                <a:spcPts val="1000"/>
-              </a:spcAft>
-            </a:pPr>
-            <a:r>
-              <a:rPr sz="1300" b="0">
+                <a:spcPts val="600"/>
+              </a:spcAft>
+            </a:pPr>
+            <a:r>
+              <a:rPr sz="1200" b="0">
                 <a:solidFill>
                   <a:srgbClr val="585868"/>
                 </a:solidFill>
                 <a:latin typeface="Helvetica Neue"/>
               </a:rPr>
-              <a:t>     Dan's sheet, the 14 pages whose screenshots are missing, and a genuinely independent second human — an adopted machine sheet measures the model, not agreement.</a:t>
-            </a:r>
-          </a:p>
-          <a:p>
-            <a:pPr algn="l">
-              <a:lnSpc>
-                <a:spcPct val="105000"/>
-              </a:lnSpc>
-              <a:spcAft>
-                <a:spcPts val="200"/>
-              </a:spcAft>
-            </a:pPr>
-            <a:r>
-              <a:rPr sz="1500" b="1">
-                <a:solidFill>
-                  <a:srgbClr val="14141C"/>
-                </a:solidFill>
-                <a:latin typeface="Helvetica Neue"/>
-              </a:rPr>
-              <a:t>•  2. Score the six new banks</a:t>
-            </a:r>
-          </a:p>
-          <a:p>
-            <a:pPr algn="l">
-              <a:lnSpc>
-                <a:spcPct val="105000"/>
-              </a:lnSpc>
-              <a:spcAft>
-                <a:spcPts val="1000"/>
-              </a:spcAft>
-            </a:pPr>
-            <a:r>
-              <a:rPr sz="1300" b="0">
-                <a:solidFill>
-                  <a:srgbClr val="585868"/>
-                </a:solidFill>
-                <a:latin typeface="Helvetica Neue"/>
-              </a:rPr>
-              <a:t>     CBC, Keytrade, BNP's two pages and the restored Belfius and Revolut need rubric sheets, so every bank in the comparison carries a judged layer rather than blanks.</a:t>
-            </a:r>
-          </a:p>
-          <a:p>
-            <a:pPr algn="l">
-              <a:lnSpc>
-                <a:spcPct val="105000"/>
-              </a:lnSpc>
-              <a:spcAft>
-                <a:spcPts val="200"/>
-              </a:spcAft>
-            </a:pPr>
-            <a:r>
-              <a:rPr sz="1500" b="1">
-                <a:solidFill>
-                  <a:srgbClr val="14141C"/>
-                </a:solidFill>
-                <a:latin typeface="Helvetica Neue"/>
-              </a:rPr>
-              <a:t>•  3. Re-run and re-export</a:t>
-            </a:r>
-          </a:p>
-          <a:p>
-            <a:pPr algn="l">
-              <a:lnSpc>
-                <a:spcPct val="105000"/>
-              </a:lnSpc>
-              <a:spcAft>
-                <a:spcPts val="1000"/>
-              </a:spcAft>
-            </a:pPr>
-            <a:r>
-              <a:rPr sz="1300" b="0">
-                <a:solidFill>
-                  <a:srgbClr val="585868"/>
-                </a:solidFill>
-                <a:latin typeface="Helvetica Neue"/>
-              </a:rPr>
-              <a:t>     rubric_sheet.py merge → run_analysis.py → export_web_report.py, then re-verify the narrative's figures.</a:t>
-            </a:r>
-          </a:p>
-          <a:p>
-            <a:pPr algn="l">
-              <a:lnSpc>
-                <a:spcPct val="105000"/>
-              </a:lnSpc>
-              <a:spcAft>
-                <a:spcPts val="200"/>
-              </a:spcAft>
-            </a:pPr>
-            <a:r>
-              <a:rPr sz="1500" b="1">
-                <a:solidFill>
-                  <a:srgbClr val="14141C"/>
-                </a:solidFill>
-                <a:latin typeface="Helvetica Neue"/>
-              </a:rPr>
-              <a:t>•  4. Decide on outputs/ in git</a:t>
-            </a:r>
-          </a:p>
-          <a:p>
-            <a:pPr algn="l">
-              <a:lnSpc>
-                <a:spcPct val="105000"/>
-              </a:lnSpc>
-              <a:spcAft>
-                <a:spcPts val="1000"/>
-              </a:spcAft>
-            </a:pPr>
-            <a:r>
-              <a:rPr sz="1300" b="0">
-                <a:solidFill>
-                  <a:srgbClr val="585868"/>
-                </a:solidFill>
-                <a:latin typeface="Helvetica Neue"/>
-              </a:rPr>
-              <a:t>     It is regenerated on every run yet tracked, so each analysis leaves a large binary diff.</a:t>
-            </a:r>
-          </a:p>
-          <a:p>
-            <a:pPr algn="l">
-              <a:lnSpc>
-                <a:spcPct val="105000"/>
-              </a:lnSpc>
-              <a:spcAft>
-                <a:spcPts val="200"/>
-              </a:spcAft>
-            </a:pPr>
-            <a:r>
-              <a:rPr sz="1500" b="1">
-                <a:solidFill>
-                  <a:srgbClr val="14141C"/>
-                </a:solidFill>
-                <a:latin typeface="Helvetica Neue"/>
-              </a:rPr>
-              <a:t>•  5. Then, if the team wants it</a:t>
-            </a:r>
-          </a:p>
-          <a:p>
-            <a:pPr algn="l">
-              <a:lnSpc>
-                <a:spcPct val="105000"/>
-              </a:lnSpc>
-              <a:spcAft>
-                <a:spcPts val="1000"/>
-              </a:spcAft>
-            </a:pPr>
-            <a:r>
-              <a:rPr sz="1300" b="0">
-                <a:solidFill>
-                  <a:srgbClr val="585868"/>
-                </a:solidFill>
-                <a:latin typeface="Helvetica Neue"/>
-              </a:rPr>
-              <a:t>     More product families (savings, mortgage) compared the same way, and a wider bank set.</a:t>
-            </a:r>
-          </a:p>
-        </p:txBody>
-      </p:sp>
-      <p:sp>
-        <p:nvSpPr>
-          <p:cNvPr id="5" name="TextBox 4"/>
+              <a:t>Four counts from the run, the validation verdict, every bank's status, and a download per deliverable.</a:t>
+            </a:r>
+          </a:p>
+        </p:txBody>
+      </p:sp>
+      <p:sp>
+        <p:nvSpPr>
+          <p:cNvPr id="6" name="TextBox 5"/>
           <p:cNvSpPr txBox="1"/>
           <p:nvPr/>
         </p:nvSpPr>
@@ -8095,7 +7993,7 @@
       </p:sp>
       <p:sp>
         <p:nvSpPr>
-          <p:cNvPr id="6" name="TextBox 5"/>
+          <p:cNvPr id="7" name="TextBox 6"/>
           <p:cNvSpPr txBox="1"/>
           <p:nvPr/>
         </p:nvSpPr>
@@ -8155,20 +8053,62 @@
       <p:grpSpPr/>
       <p:sp>
         <p:nvSpPr>
-          <p:cNvPr id="2" name="Rectangle 1"/>
+          <p:cNvPr id="2" name="TextBox 1"/>
+          <p:cNvSpPr txBox="1"/>
+          <p:nvPr/>
+        </p:nvSpPr>
+        <p:spPr>
+          <a:xfrm>
+            <a:off x="548640" y="320040"/>
+            <a:ext cx="11064240" cy="640080"/>
+          </a:xfrm>
+          <a:prstGeom prst="rect">
+            <a:avLst/>
+          </a:prstGeom>
+          <a:noFill/>
+        </p:spPr>
+        <p:txBody>
+          <a:bodyPr wrap="square">
+            <a:spAutoFit/>
+          </a:bodyPr>
+          <a:lstStyle/>
+          <a:p>
+            <a:pPr algn="l">
+              <a:lnSpc>
+                <a:spcPct val="105000"/>
+              </a:lnSpc>
+              <a:spcAft>
+                <a:spcPts val="600"/>
+              </a:spcAft>
+            </a:pPr>
+            <a:r>
+              <a:rPr sz="2400" b="1">
+                <a:solidFill>
+                  <a:srgbClr val="14141C"/>
+                </a:solidFill>
+                <a:latin typeface="Helvetica Neue"/>
+              </a:rPr>
+              <a:t>Bank profiles: one bank, every measured field</a:t>
+            </a:r>
+          </a:p>
+        </p:txBody>
+      </p:sp>
+      <p:sp>
+        <p:nvSpPr>
+          <p:cNvPr id="3" name="Rectangle 2"/>
           <p:cNvSpPr/>
           <p:nvPr/>
         </p:nvSpPr>
         <p:spPr>
           <a:xfrm>
-            <a:off x="0" y="0"/>
-            <a:ext cx="12191695" cy="6858000"/>
+            <a:off x="548640" y="960120"/>
+            <a:ext cx="1463040" cy="54864"/>
           </a:xfrm>
           <a:prstGeom prst="rect">
             <a:avLst/>
           </a:prstGeom>
           <a:solidFill>
-            <a:srgbClr val="14141C"/>
+            <a:srgbClr val="FF6200"/>
           </a:solidFill>
           <a:ln>
             <a:noFill/>
@@ -8197,6 +8137,216 @@
           </a:p>
         </p:txBody>
       </p:sp>
+      <p:pic>
+        <p:nvPicPr>
+          <p:cNvPr id="4" name="Picture 3" descr="09_profiles.png"/>
+          <p:cNvPicPr>
+            <a:picLocks noChangeAspect="1"/>
+          </p:cNvPicPr>
+          <p:nvPr/>
+        </p:nvPicPr>
+        <p:blipFill>
+          <a:blip r:embed="rId2"/>
+          <a:stretch>
+            <a:fillRect/>
+          </a:stretch>
+        </p:blipFill>
+        <p:spPr>
+          <a:xfrm>
+            <a:off x="2113127" y="1325880"/>
+            <a:ext cx="7965440" cy="4480560"/>
+          </a:xfrm>
+          <a:prstGeom prst="rect">
+            <a:avLst/>
+          </a:prstGeom>
+        </p:spPr>
+      </p:pic>
+      <p:sp>
+        <p:nvSpPr>
+          <p:cNvPr id="5" name="TextBox 4"/>
+          <p:cNvSpPr txBox="1"/>
+          <p:nvPr/>
+        </p:nvSpPr>
+        <p:spPr>
+          <a:xfrm>
+            <a:off x="685800" y="5916168"/>
+            <a:ext cx="10881360" cy="457200"/>
+          </a:xfrm>
+          <a:prstGeom prst="rect">
+            <a:avLst/>
+          </a:prstGeom>
+          <a:noFill/>
+        </p:spPr>
+        <p:txBody>
+          <a:bodyPr wrap="square">
+            <a:spAutoFit/>
+          </a:bodyPr>
+          <a:lstStyle/>
+          <a:p>
+            <a:pPr algn="l">
+              <a:lnSpc>
+                <a:spcPct val="105000"/>
+              </a:lnSpc>
+              <a:spcAft>
+                <a:spcPts val="600"/>
+              </a:spcAft>
+            </a:pPr>
+            <a:r>
+              <a:rPr sz="1200" b="0">
+                <a:solidFill>
+                  <a:srgbClr val="585868"/>
+                </a:solidFill>
+                <a:latin typeface="Helvetica Neue"/>
+              </a:rPr>
+              <a:t>Palette, tone, imagery, layout, value proposition, the z-score signature, personas and the AI Score.</a:t>
+            </a:r>
+          </a:p>
+        </p:txBody>
+      </p:sp>
+      <p:sp>
+        <p:nvSpPr>
+          <p:cNvPr id="6" name="TextBox 5"/>
+          <p:cNvSpPr txBox="1"/>
+          <p:nvPr/>
+        </p:nvSpPr>
+        <p:spPr>
+          <a:xfrm>
+            <a:off x="548640" y="6400800"/>
+            <a:ext cx="8229600" cy="274320"/>
+          </a:xfrm>
+          <a:prstGeom prst="rect">
+            <a:avLst/>
+          </a:prstGeom>
+          <a:noFill/>
+        </p:spPr>
+        <p:txBody>
+          <a:bodyPr wrap="square">
+            <a:spAutoFit/>
+          </a:bodyPr>
+          <a:lstStyle/>
+          <a:p>
+            <a:pPr algn="l">
+              <a:lnSpc>
+                <a:spcPct val="105000"/>
+              </a:lnSpc>
+              <a:spcAft>
+                <a:spcPts val="600"/>
+              </a:spcAft>
+            </a:pPr>
+            <a:r>
+              <a:rPr sz="1000" b="0">
+                <a:solidFill>
+                  <a:srgbClr val="585868"/>
+                </a:solidFill>
+                <a:latin typeface="Helvetica Neue"/>
+              </a:rPr>
+              <a:t>Banking Campaigns Comparator · ING DACI / Customer AI · September 2026</a:t>
+            </a:r>
+          </a:p>
+        </p:txBody>
+      </p:sp>
+      <p:sp>
+        <p:nvSpPr>
+          <p:cNvPr id="7" name="TextBox 6"/>
+          <p:cNvSpPr txBox="1"/>
+          <p:nvPr/>
+        </p:nvSpPr>
+        <p:spPr>
+          <a:xfrm>
+            <a:off x="11094415" y="6400800"/>
+            <a:ext cx="548640" cy="274320"/>
+          </a:xfrm>
+          <a:prstGeom prst="rect">
+            <a:avLst/>
+          </a:prstGeom>
+          <a:noFill/>
+        </p:spPr>
+        <p:txBody>
+          <a:bodyPr wrap="square">
+            <a:spAutoFit/>
+          </a:bodyPr>
+          <a:lstStyle/>
+          <a:p>
+            <a:pPr algn="r">
+              <a:lnSpc>
+                <a:spcPct val="105000"/>
+              </a:lnSpc>
+              <a:spcAft>
+                <a:spcPts val="600"/>
+              </a:spcAft>
+            </a:pPr>
+            <a:r>
+              <a:rPr sz="1000" b="0">
+                <a:solidFill>
+                  <a:srgbClr val="585868"/>
+                </a:solidFill>
+                <a:latin typeface="Helvetica Neue"/>
+              </a:rPr>
+              <a:t>24</a:t>
+            </a:r>
+          </a:p>
+        </p:txBody>
+      </p:sp>
+    </p:spTree>
+  </p:cSld>
+  <p:clrMapOvr>
+    <a:masterClrMapping/>
+  </p:clrMapOvr>
+</p:sld>
+</file>
+
+<file path=ppt/slides/slide25.xml><?xml version="1.0" encoding="utf-8"?>
+<p:sld xmlns:a="http://schemas.openxmlformats.org/drawingml/2006/main" xmlns:p="http://schemas.openxmlformats.org/presentationml/2006/main" xmlns:r="http://schemas.openxmlformats.org/officeDocument/2006/relationships">
+  <p:cSld>
+    <p:spTree>
+      <p:nvGrpSpPr>
+        <p:cNvPr id="1" name=""/>
+        <p:cNvGrpSpPr/>
+        <p:nvPr/>
+      </p:nvGrpSpPr>
+      <p:grpSpPr/>
+      <p:sp>
+        <p:nvSpPr>
+          <p:cNvPr id="2" name="TextBox 1"/>
+          <p:cNvSpPr txBox="1"/>
+          <p:nvPr/>
+        </p:nvSpPr>
+        <p:spPr>
+          <a:xfrm>
+            <a:off x="548640" y="320040"/>
+            <a:ext cx="11064240" cy="640080"/>
+          </a:xfrm>
+          <a:prstGeom prst="rect">
+            <a:avLst/>
+          </a:prstGeom>
+          <a:noFill/>
+        </p:spPr>
+        <p:txBody>
+          <a:bodyPr wrap="square">
+            <a:spAutoFit/>
+          </a:bodyPr>
+          <a:lstStyle/>
+          <a:p>
+            <a:pPr algn="l">
+              <a:lnSpc>
+                <a:spcPct val="105000"/>
+              </a:lnSpc>
+              <a:spcAft>
+                <a:spcPts val="600"/>
+              </a:spcAft>
+            </a:pPr>
+            <a:r>
+              <a:rPr sz="2400" b="1">
+                <a:solidFill>
+                  <a:srgbClr val="14141C"/>
+                </a:solidFill>
+                <a:latin typeface="Helvetica Neue"/>
+              </a:rPr>
+              <a:t>Data: the dataset and the frozen dictionary</a:t>
+            </a:r>
+          </a:p>
+        </p:txBody>
+      </p:sp>
       <p:sp>
         <p:nvSpPr>
           <p:cNvPr id="3" name="Rectangle 2"/>
@@ -8205,8 +8355,8 @@
         </p:nvSpPr>
         <p:spPr>
           <a:xfrm>
-            <a:off x="822960" y="2743200"/>
-            <a:ext cx="2011680" cy="91440"/>
+            <a:off x="548640" y="960120"/>
+            <a:ext cx="1463040" cy="54864"/>
           </a:xfrm>
           <a:prstGeom prst="rect">
             <a:avLst/>
@@ -8241,16 +8391,40 @@
           </a:p>
         </p:txBody>
       </p:sp>
-      <p:sp>
-        <p:nvSpPr>
-          <p:cNvPr id="4" name="TextBox 3"/>
+      <p:pic>
+        <p:nvPicPr>
+          <p:cNvPr id="4" name="Picture 3" descr="10_data.png"/>
+          <p:cNvPicPr>
+            <a:picLocks noChangeAspect="1"/>
+          </p:cNvPicPr>
+          <p:nvPr/>
+        </p:nvPicPr>
+        <p:blipFill>
+          <a:blip r:embed="rId2"/>
+          <a:stretch>
+            <a:fillRect/>
+          </a:stretch>
+        </p:blipFill>
+        <p:spPr>
+          <a:xfrm>
+            <a:off x="2113127" y="1325880"/>
+            <a:ext cx="7965440" cy="4480560"/>
+          </a:xfrm>
+          <a:prstGeom prst="rect">
+            <a:avLst/>
+          </a:prstGeom>
+        </p:spPr>
+      </p:pic>
+      <p:sp>
+        <p:nvSpPr>
+          <p:cNvPr id="5" name="TextBox 4"/>
           <p:cNvSpPr txBox="1"/>
           <p:nvPr/>
         </p:nvSpPr>
         <p:spPr>
           <a:xfrm>
-            <a:off x="822960" y="1828800"/>
-            <a:ext cx="10515600" cy="914400"/>
+            <a:off x="685800" y="5916168"/>
+            <a:ext cx="10881360" cy="457200"/>
           </a:xfrm>
           <a:prstGeom prst="rect">
             <a:avLst/>
@@ -8272,27 +8446,27 @@
               </a:spcAft>
             </a:pPr>
             <a:r>
-              <a:rPr sz="2800" b="1">
-                <a:solidFill>
-                  <a:srgbClr val="FFFFFF"/>
-                </a:solidFill>
-                <a:latin typeface="Helvetica Neue"/>
-              </a:rPr>
-              <a:t>Measure one way. Label the trust. Claim only what the data supports.</a:t>
-            </a:r>
-          </a:p>
-        </p:txBody>
-      </p:sp>
-      <p:sp>
-        <p:nvSpPr>
-          <p:cNvPr id="5" name="TextBox 4"/>
+              <a:rPr sz="1200" b="0">
+                <a:solidFill>
+                  <a:srgbClr val="585868"/>
+                </a:solidFill>
+                <a:latin typeface="Helvetica Neue"/>
+              </a:rPr>
+              <a:t>Every capture with its provenance, filterable and exportable, read against the 104-feature dictionary.</a:t>
+            </a:r>
+          </a:p>
+        </p:txBody>
+      </p:sp>
+      <p:sp>
+        <p:nvSpPr>
+          <p:cNvPr id="6" name="TextBox 5"/>
           <p:cNvSpPr txBox="1"/>
           <p:nvPr/>
         </p:nvSpPr>
         <p:spPr>
           <a:xfrm>
-            <a:off x="822960" y="3063240"/>
-            <a:ext cx="10058400" cy="1463040"/>
+            <a:off x="548640" y="6400800"/>
+            <a:ext cx="8229600" cy="274320"/>
           </a:xfrm>
           <a:prstGeom prst="rect">
             <a:avLst/>
@@ -8314,17 +8488,40 @@
               </a:spcAft>
             </a:pPr>
             <a:r>
-              <a:rPr sz="1400" b="0">
-                <a:solidFill>
-                  <a:srgbClr val="B8B8C8"/>
-                </a:solidFill>
-                <a:latin typeface="Helvetica Neue"/>
-              </a:rPr>
-              <a:t>The pipeline, the contract and the guardrails are in the repository:</a:t>
-            </a:r>
-          </a:p>
-          <a:p>
-            <a:pPr algn="l">
+              <a:rPr sz="1000" b="0">
+                <a:solidFill>
+                  <a:srgbClr val="585868"/>
+                </a:solidFill>
+                <a:latin typeface="Helvetica Neue"/>
+              </a:rPr>
+              <a:t>Banking Campaigns Comparator · ING DACI / Customer AI · September 2026</a:t>
+            </a:r>
+          </a:p>
+        </p:txBody>
+      </p:sp>
+      <p:sp>
+        <p:nvSpPr>
+          <p:cNvPr id="7" name="TextBox 6"/>
+          <p:cNvSpPr txBox="1"/>
+          <p:nvPr/>
+        </p:nvSpPr>
+        <p:spPr>
+          <a:xfrm>
+            <a:off x="11094415" y="6400800"/>
+            <a:ext cx="548640" cy="274320"/>
+          </a:xfrm>
+          <a:prstGeom prst="rect">
+            <a:avLst/>
+          </a:prstGeom>
+          <a:noFill/>
+        </p:spPr>
+        <p:txBody>
+          <a:bodyPr wrap="square">
+            <a:spAutoFit/>
+          </a:bodyPr>
+          <a:lstStyle/>
+          <a:p>
+            <a:pPr algn="r">
               <a:lnSpc>
                 <a:spcPct val="105000"/>
               </a:lnSpc>
@@ -8333,13 +8530,1214 @@
               </a:spcAft>
             </a:pPr>
             <a:r>
-              <a:rPr sz="1400" b="0">
-                <a:solidFill>
-                  <a:srgbClr val="B8B8C8"/>
-                </a:solidFill>
-                <a:latin typeface="Helvetica Neue"/>
-              </a:rPr>
-              <a:t>README.md · docs/design.md · docs/pipeline.md · web/README.md · docs/decisions.md</a:t>
+              <a:rPr sz="1000" b="0">
+                <a:solidFill>
+                  <a:srgbClr val="585868"/>
+                </a:solidFill>
+                <a:latin typeface="Helvetica Neue"/>
+              </a:rPr>
+              <a:t>25</a:t>
+            </a:r>
+          </a:p>
+        </p:txBody>
+      </p:sp>
+    </p:spTree>
+  </p:cSld>
+  <p:clrMapOvr>
+    <a:masterClrMapping/>
+  </p:clrMapOvr>
+</p:sld>
+</file>
+
+<file path=ppt/slides/slide26.xml><?xml version="1.0" encoding="utf-8"?>
+<p:sld xmlns:a="http://schemas.openxmlformats.org/drawingml/2006/main" xmlns:p="http://schemas.openxmlformats.org/presentationml/2006/main" xmlns:r="http://schemas.openxmlformats.org/officeDocument/2006/relationships">
+  <p:cSld>
+    <p:spTree>
+      <p:nvGrpSpPr>
+        <p:cNvPr id="1" name=""/>
+        <p:cNvGrpSpPr/>
+        <p:nvPr/>
+      </p:nvGrpSpPr>
+      <p:grpSpPr/>
+      <p:sp>
+        <p:nvSpPr>
+          <p:cNvPr id="2" name="TextBox 1"/>
+          <p:cNvSpPr txBox="1"/>
+          <p:nvPr/>
+        </p:nvSpPr>
+        <p:spPr>
+          <a:xfrm>
+            <a:off x="548640" y="320040"/>
+            <a:ext cx="11064240" cy="640080"/>
+          </a:xfrm>
+          <a:prstGeom prst="rect">
+            <a:avLst/>
+          </a:prstGeom>
+          <a:noFill/>
+        </p:spPr>
+        <p:txBody>
+          <a:bodyPr wrap="square">
+            <a:spAutoFit/>
+          </a:bodyPr>
+          <a:lstStyle/>
+          <a:p>
+            <a:pPr algn="l">
+              <a:lnSpc>
+                <a:spcPct val="105000"/>
+              </a:lnSpc>
+              <a:spcAft>
+                <a:spcPts val="600"/>
+              </a:spcAft>
+            </a:pPr>
+            <a:r>
+              <a:rPr sz="2400" b="1">
+                <a:solidFill>
+                  <a:srgbClr val="14141C"/>
+                </a:solidFill>
+                <a:latin typeface="Helvetica Neue"/>
+              </a:rPr>
+              <a:t>Rubric: the sheets, and where they disagree</a:t>
+            </a:r>
+          </a:p>
+        </p:txBody>
+      </p:sp>
+      <p:sp>
+        <p:nvSpPr>
+          <p:cNvPr id="3" name="Rectangle 2"/>
+          <p:cNvSpPr/>
+          <p:nvPr/>
+        </p:nvSpPr>
+        <p:spPr>
+          <a:xfrm>
+            <a:off x="548640" y="960120"/>
+            <a:ext cx="1463040" cy="54864"/>
+          </a:xfrm>
+          <a:prstGeom prst="rect">
+            <a:avLst/>
+          </a:prstGeom>
+          <a:solidFill>
+            <a:srgbClr val="FF6200"/>
+          </a:solidFill>
+          <a:ln>
+            <a:noFill/>
+          </a:ln>
+          <a:effectLst/>
+        </p:spPr>
+        <p:style>
+          <a:lnRef idx="1">
+            <a:schemeClr val="accent1"/>
+          </a:lnRef>
+          <a:fillRef idx="3">
+            <a:schemeClr val="accent1"/>
+          </a:fillRef>
+          <a:effectRef idx="2">
+            <a:schemeClr val="accent1"/>
+          </a:effectRef>
+          <a:fontRef idx="minor">
+            <a:schemeClr val="lt1"/>
+          </a:fontRef>
+        </p:style>
+        <p:txBody>
+          <a:bodyPr rtlCol="0" anchor="ctr"/>
+          <a:lstStyle/>
+          <a:p>
+            <a:pPr algn="ctr"/>
+          </a:p>
+        </p:txBody>
+      </p:sp>
+      <p:pic>
+        <p:nvPicPr>
+          <p:cNvPr id="4" name="Picture 3" descr="11_rubric.png"/>
+          <p:cNvPicPr>
+            <a:picLocks noChangeAspect="1"/>
+          </p:cNvPicPr>
+          <p:nvPr/>
+        </p:nvPicPr>
+        <p:blipFill>
+          <a:blip r:embed="rId2"/>
+          <a:stretch>
+            <a:fillRect/>
+          </a:stretch>
+        </p:blipFill>
+        <p:spPr>
+          <a:xfrm>
+            <a:off x="2113127" y="1325880"/>
+            <a:ext cx="7965440" cy="4480560"/>
+          </a:xfrm>
+          <a:prstGeom prst="rect">
+            <a:avLst/>
+          </a:prstGeom>
+        </p:spPr>
+      </p:pic>
+      <p:sp>
+        <p:nvSpPr>
+          <p:cNvPr id="5" name="TextBox 4"/>
+          <p:cNvSpPr txBox="1"/>
+          <p:nvPr/>
+        </p:nvSpPr>
+        <p:spPr>
+          <a:xfrm>
+            <a:off x="685800" y="5916168"/>
+            <a:ext cx="10881360" cy="457200"/>
+          </a:xfrm>
+          <a:prstGeom prst="rect">
+            <a:avLst/>
+          </a:prstGeom>
+          <a:noFill/>
+        </p:spPr>
+        <p:txBody>
+          <a:bodyPr wrap="square">
+            <a:spAutoFit/>
+          </a:bodyPr>
+          <a:lstStyle/>
+          <a:p>
+            <a:pPr algn="l">
+              <a:lnSpc>
+                <a:spcPct val="105000"/>
+              </a:lnSpc>
+              <a:spcAft>
+                <a:spcPts val="600"/>
+              </a:spcAft>
+            </a:pPr>
+            <a:r>
+              <a:rPr sz="1200" b="0">
+                <a:solidFill>
+                  <a:srgbClr val="585868"/>
+                </a:solidFill>
+                <a:latin typeface="Helvetica Neue"/>
+              </a:rPr>
+              <a:t>Every sheet, raw agreement, chance-corrected kappa, and the scoring guide — never merged into one score.</a:t>
+            </a:r>
+          </a:p>
+        </p:txBody>
+      </p:sp>
+      <p:sp>
+        <p:nvSpPr>
+          <p:cNvPr id="6" name="TextBox 5"/>
+          <p:cNvSpPr txBox="1"/>
+          <p:nvPr/>
+        </p:nvSpPr>
+        <p:spPr>
+          <a:xfrm>
+            <a:off x="548640" y="6400800"/>
+            <a:ext cx="8229600" cy="274320"/>
+          </a:xfrm>
+          <a:prstGeom prst="rect">
+            <a:avLst/>
+          </a:prstGeom>
+          <a:noFill/>
+        </p:spPr>
+        <p:txBody>
+          <a:bodyPr wrap="square">
+            <a:spAutoFit/>
+          </a:bodyPr>
+          <a:lstStyle/>
+          <a:p>
+            <a:pPr algn="l">
+              <a:lnSpc>
+                <a:spcPct val="105000"/>
+              </a:lnSpc>
+              <a:spcAft>
+                <a:spcPts val="600"/>
+              </a:spcAft>
+            </a:pPr>
+            <a:r>
+              <a:rPr sz="1000" b="0">
+                <a:solidFill>
+                  <a:srgbClr val="585868"/>
+                </a:solidFill>
+                <a:latin typeface="Helvetica Neue"/>
+              </a:rPr>
+              <a:t>Banking Campaigns Comparator · ING DACI / Customer AI · September 2026</a:t>
+            </a:r>
+          </a:p>
+        </p:txBody>
+      </p:sp>
+      <p:sp>
+        <p:nvSpPr>
+          <p:cNvPr id="7" name="TextBox 6"/>
+          <p:cNvSpPr txBox="1"/>
+          <p:nvPr/>
+        </p:nvSpPr>
+        <p:spPr>
+          <a:xfrm>
+            <a:off x="11094415" y="6400800"/>
+            <a:ext cx="548640" cy="274320"/>
+          </a:xfrm>
+          <a:prstGeom prst="rect">
+            <a:avLst/>
+          </a:prstGeom>
+          <a:noFill/>
+        </p:spPr>
+        <p:txBody>
+          <a:bodyPr wrap="square">
+            <a:spAutoFit/>
+          </a:bodyPr>
+          <a:lstStyle/>
+          <a:p>
+            <a:pPr algn="r">
+              <a:lnSpc>
+                <a:spcPct val="105000"/>
+              </a:lnSpc>
+              <a:spcAft>
+                <a:spcPts val="600"/>
+              </a:spcAft>
+            </a:pPr>
+            <a:r>
+              <a:rPr sz="1000" b="0">
+                <a:solidFill>
+                  <a:srgbClr val="585868"/>
+                </a:solidFill>
+                <a:latin typeface="Helvetica Neue"/>
+              </a:rPr>
+              <a:t>26</a:t>
+            </a:r>
+          </a:p>
+        </p:txBody>
+      </p:sp>
+    </p:spTree>
+  </p:cSld>
+  <p:clrMapOvr>
+    <a:masterClrMapping/>
+  </p:clrMapOvr>
+</p:sld>
+</file>
+
+<file path=ppt/slides/slide27.xml><?xml version="1.0" encoding="utf-8"?>
+<p:sld xmlns:a="http://schemas.openxmlformats.org/drawingml/2006/main" xmlns:p="http://schemas.openxmlformats.org/presentationml/2006/main" xmlns:r="http://schemas.openxmlformats.org/officeDocument/2006/relationships">
+  <p:cSld>
+    <p:spTree>
+      <p:nvGrpSpPr>
+        <p:cNvPr id="1" name=""/>
+        <p:cNvGrpSpPr/>
+        <p:nvPr/>
+      </p:nvGrpSpPr>
+      <p:grpSpPr/>
+      <p:sp>
+        <p:nvSpPr>
+          <p:cNvPr id="2" name="TextBox 1"/>
+          <p:cNvSpPr txBox="1"/>
+          <p:nvPr/>
+        </p:nvSpPr>
+        <p:spPr>
+          <a:xfrm>
+            <a:off x="548640" y="320040"/>
+            <a:ext cx="11064240" cy="640080"/>
+          </a:xfrm>
+          <a:prstGeom prst="rect">
+            <a:avLst/>
+          </a:prstGeom>
+          <a:noFill/>
+        </p:spPr>
+        <p:txBody>
+          <a:bodyPr wrap="square">
+            <a:spAutoFit/>
+          </a:bodyPr>
+          <a:lstStyle/>
+          <a:p>
+            <a:pPr algn="l">
+              <a:lnSpc>
+                <a:spcPct val="105000"/>
+              </a:lnSpc>
+              <a:spcAft>
+                <a:spcPts val="600"/>
+              </a:spcAft>
+            </a:pPr>
+            <a:r>
+              <a:rPr sz="2400" b="1">
+                <a:solidFill>
+                  <a:srgbClr val="14141C"/>
+                </a:solidFill>
+                <a:latin typeface="Helvetica Neue"/>
+              </a:rPr>
+              <a:t>Collection: status, provenance and the pipeline</a:t>
+            </a:r>
+          </a:p>
+        </p:txBody>
+      </p:sp>
+      <p:sp>
+        <p:nvSpPr>
+          <p:cNvPr id="3" name="Rectangle 2"/>
+          <p:cNvSpPr/>
+          <p:nvPr/>
+        </p:nvSpPr>
+        <p:spPr>
+          <a:xfrm>
+            <a:off x="548640" y="960120"/>
+            <a:ext cx="1463040" cy="54864"/>
+          </a:xfrm>
+          <a:prstGeom prst="rect">
+            <a:avLst/>
+          </a:prstGeom>
+          <a:solidFill>
+            <a:srgbClr val="FF6200"/>
+          </a:solidFill>
+          <a:ln>
+            <a:noFill/>
+          </a:ln>
+          <a:effectLst/>
+        </p:spPr>
+        <p:style>
+          <a:lnRef idx="1">
+            <a:schemeClr val="accent1"/>
+          </a:lnRef>
+          <a:fillRef idx="3">
+            <a:schemeClr val="accent1"/>
+          </a:fillRef>
+          <a:effectRef idx="2">
+            <a:schemeClr val="accent1"/>
+          </a:effectRef>
+          <a:fontRef idx="minor">
+            <a:schemeClr val="lt1"/>
+          </a:fontRef>
+        </p:style>
+        <p:txBody>
+          <a:bodyPr rtlCol="0" anchor="ctr"/>
+          <a:lstStyle/>
+          <a:p>
+            <a:pPr algn="ctr"/>
+          </a:p>
+        </p:txBody>
+      </p:sp>
+      <p:pic>
+        <p:nvPicPr>
+          <p:cNvPr id="4" name="Picture 3" descr="12_collection.png"/>
+          <p:cNvPicPr>
+            <a:picLocks noChangeAspect="1"/>
+          </p:cNvPicPr>
+          <p:nvPr/>
+        </p:nvPicPr>
+        <p:blipFill>
+          <a:blip r:embed="rId2"/>
+          <a:stretch>
+            <a:fillRect/>
+          </a:stretch>
+        </p:blipFill>
+        <p:spPr>
+          <a:xfrm>
+            <a:off x="2113127" y="1325880"/>
+            <a:ext cx="7965440" cy="4480560"/>
+          </a:xfrm>
+          <a:prstGeom prst="rect">
+            <a:avLst/>
+          </a:prstGeom>
+        </p:spPr>
+      </p:pic>
+      <p:sp>
+        <p:nvSpPr>
+          <p:cNvPr id="5" name="TextBox 4"/>
+          <p:cNvSpPr txBox="1"/>
+          <p:nvPr/>
+        </p:nvSpPr>
+        <p:spPr>
+          <a:xfrm>
+            <a:off x="685800" y="5916168"/>
+            <a:ext cx="10881360" cy="457200"/>
+          </a:xfrm>
+          <a:prstGeom prst="rect">
+            <a:avLst/>
+          </a:prstGeom>
+          <a:noFill/>
+        </p:spPr>
+        <p:txBody>
+          <a:bodyPr wrap="square">
+            <a:spAutoFit/>
+          </a:bodyPr>
+          <a:lstStyle/>
+          <a:p>
+            <a:pPr algn="l">
+              <a:lnSpc>
+                <a:spcPct val="105000"/>
+              </a:lnSpc>
+              <a:spcAft>
+                <a:spcPts val="600"/>
+              </a:spcAft>
+            </a:pPr>
+            <a:r>
+              <a:rPr sz="1200" b="0">
+                <a:solidFill>
+                  <a:srgbClr val="585868"/>
+                </a:solidFill>
+                <a:latin typeface="Helvetica Neue"/>
+              </a:rPr>
+              <a:t>Counts straight from the export, per-bank status, capture provenance, and the commands that produced it.</a:t>
+            </a:r>
+          </a:p>
+        </p:txBody>
+      </p:sp>
+      <p:sp>
+        <p:nvSpPr>
+          <p:cNvPr id="6" name="TextBox 5"/>
+          <p:cNvSpPr txBox="1"/>
+          <p:nvPr/>
+        </p:nvSpPr>
+        <p:spPr>
+          <a:xfrm>
+            <a:off x="548640" y="6400800"/>
+            <a:ext cx="8229600" cy="274320"/>
+          </a:xfrm>
+          <a:prstGeom prst="rect">
+            <a:avLst/>
+          </a:prstGeom>
+          <a:noFill/>
+        </p:spPr>
+        <p:txBody>
+          <a:bodyPr wrap="square">
+            <a:spAutoFit/>
+          </a:bodyPr>
+          <a:lstStyle/>
+          <a:p>
+            <a:pPr algn="l">
+              <a:lnSpc>
+                <a:spcPct val="105000"/>
+              </a:lnSpc>
+              <a:spcAft>
+                <a:spcPts val="600"/>
+              </a:spcAft>
+            </a:pPr>
+            <a:r>
+              <a:rPr sz="1000" b="0">
+                <a:solidFill>
+                  <a:srgbClr val="585868"/>
+                </a:solidFill>
+                <a:latin typeface="Helvetica Neue"/>
+              </a:rPr>
+              <a:t>Banking Campaigns Comparator · ING DACI / Customer AI · September 2026</a:t>
+            </a:r>
+          </a:p>
+        </p:txBody>
+      </p:sp>
+      <p:sp>
+        <p:nvSpPr>
+          <p:cNvPr id="7" name="TextBox 6"/>
+          <p:cNvSpPr txBox="1"/>
+          <p:nvPr/>
+        </p:nvSpPr>
+        <p:spPr>
+          <a:xfrm>
+            <a:off x="11094415" y="6400800"/>
+            <a:ext cx="548640" cy="274320"/>
+          </a:xfrm>
+          <a:prstGeom prst="rect">
+            <a:avLst/>
+          </a:prstGeom>
+          <a:noFill/>
+        </p:spPr>
+        <p:txBody>
+          <a:bodyPr wrap="square">
+            <a:spAutoFit/>
+          </a:bodyPr>
+          <a:lstStyle/>
+          <a:p>
+            <a:pPr algn="r">
+              <a:lnSpc>
+                <a:spcPct val="105000"/>
+              </a:lnSpc>
+              <a:spcAft>
+                <a:spcPts val="600"/>
+              </a:spcAft>
+            </a:pPr>
+            <a:r>
+              <a:rPr sz="1000" b="0">
+                <a:solidFill>
+                  <a:srgbClr val="585868"/>
+                </a:solidFill>
+                <a:latin typeface="Helvetica Neue"/>
+              </a:rPr>
+              <a:t>27</a:t>
+            </a:r>
+          </a:p>
+        </p:txBody>
+      </p:sp>
+    </p:spTree>
+  </p:cSld>
+  <p:clrMapOvr>
+    <a:masterClrMapping/>
+  </p:clrMapOvr>
+</p:sld>
+</file>
+
+<file path=ppt/slides/slide28.xml><?xml version="1.0" encoding="utf-8"?>
+<p:sld xmlns:a="http://schemas.openxmlformats.org/drawingml/2006/main" xmlns:p="http://schemas.openxmlformats.org/presentationml/2006/main" xmlns:r="http://schemas.openxmlformats.org/officeDocument/2006/relationships">
+  <p:cSld>
+    <p:spTree>
+      <p:nvGrpSpPr>
+        <p:cNvPr id="1" name=""/>
+        <p:cNvGrpSpPr/>
+        <p:nvPr/>
+      </p:nvGrpSpPr>
+      <p:grpSpPr/>
+      <p:sp>
+        <p:nvSpPr>
+          <p:cNvPr id="2" name="TextBox 1"/>
+          <p:cNvSpPr txBox="1"/>
+          <p:nvPr/>
+        </p:nvSpPr>
+        <p:spPr>
+          <a:xfrm>
+            <a:off x="548640" y="320040"/>
+            <a:ext cx="11064240" cy="640080"/>
+          </a:xfrm>
+          <a:prstGeom prst="rect">
+            <a:avLst/>
+          </a:prstGeom>
+          <a:noFill/>
+        </p:spPr>
+        <p:txBody>
+          <a:bodyPr wrap="square">
+            <a:spAutoFit/>
+          </a:bodyPr>
+          <a:lstStyle/>
+          <a:p>
+            <a:pPr algn="l">
+              <a:lnSpc>
+                <a:spcPct val="105000"/>
+              </a:lnSpc>
+              <a:spcAft>
+                <a:spcPts val="600"/>
+              </a:spcAft>
+            </a:pPr>
+            <a:r>
+              <a:rPr sz="2400" b="1">
+                <a:solidFill>
+                  <a:srgbClr val="14141C"/>
+                </a:solidFill>
+                <a:latin typeface="Helvetica Neue"/>
+              </a:rPr>
+              <a:t>Research: sourcing a claim</a:t>
+            </a:r>
+          </a:p>
+        </p:txBody>
+      </p:sp>
+      <p:sp>
+        <p:nvSpPr>
+          <p:cNvPr id="3" name="Rectangle 2"/>
+          <p:cNvSpPr/>
+          <p:nvPr/>
+        </p:nvSpPr>
+        <p:spPr>
+          <a:xfrm>
+            <a:off x="548640" y="960120"/>
+            <a:ext cx="1463040" cy="54864"/>
+          </a:xfrm>
+          <a:prstGeom prst="rect">
+            <a:avLst/>
+          </a:prstGeom>
+          <a:solidFill>
+            <a:srgbClr val="FF6200"/>
+          </a:solidFill>
+          <a:ln>
+            <a:noFill/>
+          </a:ln>
+          <a:effectLst/>
+        </p:spPr>
+        <p:style>
+          <a:lnRef idx="1">
+            <a:schemeClr val="accent1"/>
+          </a:lnRef>
+          <a:fillRef idx="3">
+            <a:schemeClr val="accent1"/>
+          </a:fillRef>
+          <a:effectRef idx="2">
+            <a:schemeClr val="accent1"/>
+          </a:effectRef>
+          <a:fontRef idx="minor">
+            <a:schemeClr val="lt1"/>
+          </a:fontRef>
+        </p:style>
+        <p:txBody>
+          <a:bodyPr rtlCol="0" anchor="ctr"/>
+          <a:lstStyle/>
+          <a:p>
+            <a:pPr algn="ctr"/>
+          </a:p>
+        </p:txBody>
+      </p:sp>
+      <p:pic>
+        <p:nvPicPr>
+          <p:cNvPr id="4" name="Picture 3" descr="13_research.png"/>
+          <p:cNvPicPr>
+            <a:picLocks noChangeAspect="1"/>
+          </p:cNvPicPr>
+          <p:nvPr/>
+        </p:nvPicPr>
+        <p:blipFill>
+          <a:blip r:embed="rId2"/>
+          <a:stretch>
+            <a:fillRect/>
+          </a:stretch>
+        </p:blipFill>
+        <p:spPr>
+          <a:xfrm>
+            <a:off x="2113127" y="1325880"/>
+            <a:ext cx="7965440" cy="4480560"/>
+          </a:xfrm>
+          <a:prstGeom prst="rect">
+            <a:avLst/>
+          </a:prstGeom>
+        </p:spPr>
+      </p:pic>
+      <p:sp>
+        <p:nvSpPr>
+          <p:cNvPr id="5" name="TextBox 4"/>
+          <p:cNvSpPr txBox="1"/>
+          <p:nvPr/>
+        </p:nvSpPr>
+        <p:spPr>
+          <a:xfrm>
+            <a:off x="685800" y="5916168"/>
+            <a:ext cx="10881360" cy="457200"/>
+          </a:xfrm>
+          <a:prstGeom prst="rect">
+            <a:avLst/>
+          </a:prstGeom>
+          <a:noFill/>
+        </p:spPr>
+        <p:txBody>
+          <a:bodyPr wrap="square">
+            <a:spAutoFit/>
+          </a:bodyPr>
+          <a:lstStyle/>
+          <a:p>
+            <a:pPr algn="l">
+              <a:lnSpc>
+                <a:spcPct val="105000"/>
+              </a:lnSpc>
+              <a:spcAft>
+                <a:spcPts val="600"/>
+              </a:spcAft>
+            </a:pPr>
+            <a:r>
+              <a:rPr sz="1200" b="0">
+                <a:solidFill>
+                  <a:srgbClr val="585868"/>
+                </a:solidFill>
+                <a:latin typeface="Helvetica Neue"/>
+              </a:rPr>
+              <a:t>Semantic Scholar, on demand. Empty is reported as empty — a rate limit must not read as 'no evidence'.</a:t>
+            </a:r>
+          </a:p>
+        </p:txBody>
+      </p:sp>
+      <p:sp>
+        <p:nvSpPr>
+          <p:cNvPr id="6" name="TextBox 5"/>
+          <p:cNvSpPr txBox="1"/>
+          <p:nvPr/>
+        </p:nvSpPr>
+        <p:spPr>
+          <a:xfrm>
+            <a:off x="548640" y="6400800"/>
+            <a:ext cx="8229600" cy="274320"/>
+          </a:xfrm>
+          <a:prstGeom prst="rect">
+            <a:avLst/>
+          </a:prstGeom>
+          <a:noFill/>
+        </p:spPr>
+        <p:txBody>
+          <a:bodyPr wrap="square">
+            <a:spAutoFit/>
+          </a:bodyPr>
+          <a:lstStyle/>
+          <a:p>
+            <a:pPr algn="l">
+              <a:lnSpc>
+                <a:spcPct val="105000"/>
+              </a:lnSpc>
+              <a:spcAft>
+                <a:spcPts val="600"/>
+              </a:spcAft>
+            </a:pPr>
+            <a:r>
+              <a:rPr sz="1000" b="0">
+                <a:solidFill>
+                  <a:srgbClr val="585868"/>
+                </a:solidFill>
+                <a:latin typeface="Helvetica Neue"/>
+              </a:rPr>
+              <a:t>Banking Campaigns Comparator · ING DACI / Customer AI · September 2026</a:t>
+            </a:r>
+          </a:p>
+        </p:txBody>
+      </p:sp>
+      <p:sp>
+        <p:nvSpPr>
+          <p:cNvPr id="7" name="TextBox 6"/>
+          <p:cNvSpPr txBox="1"/>
+          <p:nvPr/>
+        </p:nvSpPr>
+        <p:spPr>
+          <a:xfrm>
+            <a:off x="11094415" y="6400800"/>
+            <a:ext cx="548640" cy="274320"/>
+          </a:xfrm>
+          <a:prstGeom prst="rect">
+            <a:avLst/>
+          </a:prstGeom>
+          <a:noFill/>
+        </p:spPr>
+        <p:txBody>
+          <a:bodyPr wrap="square">
+            <a:spAutoFit/>
+          </a:bodyPr>
+          <a:lstStyle/>
+          <a:p>
+            <a:pPr algn="r">
+              <a:lnSpc>
+                <a:spcPct val="105000"/>
+              </a:lnSpc>
+              <a:spcAft>
+                <a:spcPts val="600"/>
+              </a:spcAft>
+            </a:pPr>
+            <a:r>
+              <a:rPr sz="1000" b="0">
+                <a:solidFill>
+                  <a:srgbClr val="585868"/>
+                </a:solidFill>
+                <a:latin typeface="Helvetica Neue"/>
+              </a:rPr>
+              <a:t>28</a:t>
+            </a:r>
+          </a:p>
+        </p:txBody>
+      </p:sp>
+    </p:spTree>
+  </p:cSld>
+  <p:clrMapOvr>
+    <a:masterClrMapping/>
+  </p:clrMapOvr>
+</p:sld>
+</file>
+
+<file path=ppt/slides/slide29.xml><?xml version="1.0" encoding="utf-8"?>
+<p:sld xmlns:a="http://schemas.openxmlformats.org/drawingml/2006/main" xmlns:p="http://schemas.openxmlformats.org/presentationml/2006/main" xmlns:r="http://schemas.openxmlformats.org/officeDocument/2006/relationships">
+  <p:cSld>
+    <p:spTree>
+      <p:nvGrpSpPr>
+        <p:cNvPr id="1" name=""/>
+        <p:cNvGrpSpPr/>
+        <p:nvPr/>
+      </p:nvGrpSpPr>
+      <p:grpSpPr/>
+      <p:sp>
+        <p:nvSpPr>
+          <p:cNvPr id="2" name="TextBox 1"/>
+          <p:cNvSpPr txBox="1"/>
+          <p:nvPr/>
+        </p:nvSpPr>
+        <p:spPr>
+          <a:xfrm>
+            <a:off x="548640" y="384048"/>
+            <a:ext cx="11064240" cy="731520"/>
+          </a:xfrm>
+          <a:prstGeom prst="rect">
+            <a:avLst/>
+          </a:prstGeom>
+          <a:noFill/>
+        </p:spPr>
+        <p:txBody>
+          <a:bodyPr wrap="square">
+            <a:spAutoFit/>
+          </a:bodyPr>
+          <a:lstStyle/>
+          <a:p>
+            <a:pPr algn="l">
+              <a:lnSpc>
+                <a:spcPct val="105000"/>
+              </a:lnSpc>
+              <a:spcAft>
+                <a:spcPts val="600"/>
+              </a:spcAft>
+            </a:pPr>
+            <a:r>
+              <a:rPr sz="2800" b="1">
+                <a:solidFill>
+                  <a:srgbClr val="14141C"/>
+                </a:solidFill>
+                <a:latin typeface="Helvetica Neue"/>
+              </a:rPr>
+              <a:t>What this cannot support</a:t>
+            </a:r>
+          </a:p>
+        </p:txBody>
+      </p:sp>
+      <p:sp>
+        <p:nvSpPr>
+          <p:cNvPr id="3" name="Rectangle 2"/>
+          <p:cNvSpPr/>
+          <p:nvPr/>
+        </p:nvSpPr>
+        <p:spPr>
+          <a:xfrm>
+            <a:off x="548640" y="1115568"/>
+            <a:ext cx="1463040" cy="64008"/>
+          </a:xfrm>
+          <a:prstGeom prst="rect">
+            <a:avLst/>
+          </a:prstGeom>
+          <a:solidFill>
+            <a:srgbClr val="FF6200"/>
+          </a:solidFill>
+          <a:ln>
+            <a:noFill/>
+          </a:ln>
+          <a:effectLst/>
+        </p:spPr>
+        <p:style>
+          <a:lnRef idx="1">
+            <a:schemeClr val="accent1"/>
+          </a:lnRef>
+          <a:fillRef idx="3">
+            <a:schemeClr val="accent1"/>
+          </a:fillRef>
+          <a:effectRef idx="2">
+            <a:schemeClr val="accent1"/>
+          </a:effectRef>
+          <a:fontRef idx="minor">
+            <a:schemeClr val="lt1"/>
+          </a:fontRef>
+        </p:style>
+        <p:txBody>
+          <a:bodyPr rtlCol="0" anchor="ctr"/>
+          <a:lstStyle/>
+          <a:p>
+            <a:pPr algn="ctr"/>
+          </a:p>
+        </p:txBody>
+      </p:sp>
+      <p:sp>
+        <p:nvSpPr>
+          <p:cNvPr id="4" name="TextBox 3"/>
+          <p:cNvSpPr txBox="1"/>
+          <p:nvPr/>
+        </p:nvSpPr>
+        <p:spPr>
+          <a:xfrm>
+            <a:off x="685800" y="1463040"/>
+            <a:ext cx="10881360" cy="4754880"/>
+          </a:xfrm>
+          <a:prstGeom prst="rect">
+            <a:avLst/>
+          </a:prstGeom>
+          <a:noFill/>
+        </p:spPr>
+        <p:txBody>
+          <a:bodyPr wrap="square">
+            <a:spAutoFit/>
+          </a:bodyPr>
+          <a:lstStyle/>
+          <a:p>
+            <a:pPr algn="l">
+              <a:lnSpc>
+                <a:spcPct val="105000"/>
+              </a:lnSpc>
+              <a:spcAft>
+                <a:spcPts val="200"/>
+              </a:spcAft>
+            </a:pPr>
+            <a:r>
+              <a:rPr sz="1500" b="1">
+                <a:solidFill>
+                  <a:srgbClr val="14141C"/>
+                </a:solidFill>
+                <a:latin typeface="Helvetica Neue"/>
+              </a:rPr>
+              <a:t>•  No performance data exists here</a:t>
+            </a:r>
+          </a:p>
+          <a:p>
+            <a:pPr algn="l">
+              <a:lnSpc>
+                <a:spcPct val="105000"/>
+              </a:lnSpc>
+              <a:spcAft>
+                <a:spcPts val="1000"/>
+              </a:spcAft>
+            </a:pPr>
+            <a:r>
+              <a:rPr sz="1300" b="0">
+                <a:solidFill>
+                  <a:srgbClr val="585868"/>
+                </a:solidFill>
+                <a:latin typeface="Helvetica Neue"/>
+              </a:rPr>
+              <a:t>     Nothing links a design choice to a click, a conversion or a sale. Every recommendation is a hypothesis ING could test.</a:t>
+            </a:r>
+          </a:p>
+          <a:p>
+            <a:pPr algn="l">
+              <a:lnSpc>
+                <a:spcPct val="105000"/>
+              </a:lnSpc>
+              <a:spcAft>
+                <a:spcPts val="200"/>
+              </a:spcAft>
+            </a:pPr>
+            <a:r>
+              <a:rPr sz="1500" b="1">
+                <a:solidFill>
+                  <a:srgbClr val="14141C"/>
+                </a:solidFill>
+                <a:latin typeface="Helvetica Neue"/>
+              </a:rPr>
+              <a:t>•  Small groups, by design</a:t>
+            </a:r>
+          </a:p>
+          <a:p>
+            <a:pPr algn="l">
+              <a:lnSpc>
+                <a:spcPct val="105000"/>
+              </a:lnSpc>
+              <a:spcAft>
+                <a:spcPts val="1000"/>
+              </a:spcAft>
+            </a:pPr>
+            <a:r>
+              <a:rPr sz="1300" b="0">
+                <a:solidFill>
+                  <a:srgbClr val="585868"/>
+                </a:solidFill>
+                <a:latin typeface="Helvetica Neue"/>
+              </a:rPr>
+              <a:t>     Four challengers against ten traditional banks, and most banks contribute a single page — so a group mean is an anecdote and an effect size describes separation, not significance.</a:t>
+            </a:r>
+          </a:p>
+          <a:p>
+            <a:pPr algn="l">
+              <a:lnSpc>
+                <a:spcPct val="105000"/>
+              </a:lnSpc>
+              <a:spcAft>
+                <a:spcPts val="200"/>
+              </a:spcAft>
+            </a:pPr>
+            <a:r>
+              <a:rPr sz="1500" b="1">
+                <a:solidFill>
+                  <a:srgbClr val="14141C"/>
+                </a:solidFill>
+                <a:latin typeface="Helvetica Neue"/>
+              </a:rPr>
+              <a:t>•  The judgement features are thinner than they look</a:t>
+            </a:r>
+          </a:p>
+          <a:p>
+            <a:pPr algn="l">
+              <a:lnSpc>
+                <a:spcPct val="105000"/>
+              </a:lnSpc>
+              <a:spcAft>
+                <a:spcPts val="1000"/>
+              </a:spcAft>
+            </a:pPr>
+            <a:r>
+              <a:rPr sz="1300" b="0">
+                <a:solidFill>
+                  <a:srgbClr val="585868"/>
+                </a:solidFill>
+                <a:latin typeface="Helvetica Neue"/>
+              </a:rPr>
+              <a:t>     Two humans overlap on only 11 pages, Stephane's 9 were machine-proposed and adopted, and six of the thirteen features sit below the agreement bar — so a finding resting on persuasion levers or accent placement is a hypothesis.</a:t>
+            </a:r>
+          </a:p>
+          <a:p>
+            <a:pPr algn="l">
+              <a:lnSpc>
+                <a:spcPct val="105000"/>
+              </a:lnSpc>
+              <a:spcAft>
+                <a:spcPts val="200"/>
+              </a:spcAft>
+            </a:pPr>
+            <a:r>
+              <a:rPr sz="1500" b="1">
+                <a:solidFill>
+                  <a:srgbClr val="14141C"/>
+                </a:solidFill>
+                <a:latin typeface="Helvetica Neue"/>
+              </a:rPr>
+              <a:t>•  Search interest is context, and covers part of the market</a:t>
+            </a:r>
+          </a:p>
+          <a:p>
+            <a:pPr algn="l">
+              <a:lnSpc>
+                <a:spcPct val="105000"/>
+              </a:lnSpc>
+              <a:spcAft>
+                <a:spcPts val="1000"/>
+              </a:spcAft>
+            </a:pPr>
+            <a:r>
+              <a:rPr sz="1300" b="0">
+                <a:solidFill>
+                  <a:srgbClr val="585868"/>
+                </a:solidFill>
+                <a:latin typeface="Helvetica Neue"/>
+              </a:rPr>
+              <a:t>     It measures what people searched for, not what a campaign achieved, and the pages captured are today's pages.</a:t>
+            </a:r>
+          </a:p>
+          <a:p>
+            <a:pPr algn="l">
+              <a:lnSpc>
+                <a:spcPct val="105000"/>
+              </a:lnSpc>
+              <a:spcAft>
+                <a:spcPts val="200"/>
+              </a:spcAft>
+            </a:pPr>
+            <a:r>
+              <a:rPr sz="1500" b="1">
+                <a:solidFill>
+                  <a:srgbClr val="14141C"/>
+                </a:solidFill>
+                <a:latin typeface="Helvetica Neue"/>
+              </a:rPr>
+              <a:t>•  Only the open web is covered</a:t>
+            </a:r>
+          </a:p>
+          <a:p>
+            <a:pPr algn="l">
+              <a:lnSpc>
+                <a:spcPct val="105000"/>
+              </a:lnSpc>
+              <a:spcAft>
+                <a:spcPts val="1000"/>
+              </a:spcAft>
+            </a:pPr>
+            <a:r>
+              <a:rPr sz="1300" b="0">
+                <a:solidFill>
+                  <a:srgbClr val="585868"/>
+                </a:solidFill>
+                <a:latin typeface="Helvetica Neue"/>
+              </a:rPr>
+              <a:t>     Social, in-app and email banners are out of scope — and may be where a bank's real communication happens.</a:t>
+            </a:r>
+          </a:p>
+          <a:p>
+            <a:pPr algn="l">
+              <a:lnSpc>
+                <a:spcPct val="105000"/>
+              </a:lnSpc>
+              <a:spcAft>
+                <a:spcPts val="200"/>
+              </a:spcAft>
+            </a:pPr>
+            <a:r>
+              <a:rPr sz="600" b="0">
+                <a:solidFill>
+                  <a:srgbClr val="14141C"/>
+                </a:solidFill>
+                <a:latin typeface="Helvetica Neue"/>
+              </a:rPr>
+              <a:t/>
+            </a:r>
+          </a:p>
+          <a:p>
+            <a:pPr algn="l">
+              <a:lnSpc>
+                <a:spcPct val="105000"/>
+              </a:lnSpc>
+              <a:spcAft>
+                <a:spcPts val="0"/>
+              </a:spcAft>
+            </a:pPr>
+            <a:r>
+              <a:rPr sz="1250" b="0">
+                <a:solidFill>
+                  <a:srgbClr val="585868"/>
+                </a:solidFill>
+                <a:latin typeface="Helvetica Neue"/>
+              </a:rPr>
+              <a:t>outputs/limitations.md is regenerated from the dataset on every run, so these cannot quietly go stale.</a:t>
+            </a:r>
+          </a:p>
+        </p:txBody>
+      </p:sp>
+      <p:sp>
+        <p:nvSpPr>
+          <p:cNvPr id="5" name="TextBox 4"/>
+          <p:cNvSpPr txBox="1"/>
+          <p:nvPr/>
+        </p:nvSpPr>
+        <p:spPr>
+          <a:xfrm>
+            <a:off x="548640" y="6400800"/>
+            <a:ext cx="8229600" cy="274320"/>
+          </a:xfrm>
+          <a:prstGeom prst="rect">
+            <a:avLst/>
+          </a:prstGeom>
+          <a:noFill/>
+        </p:spPr>
+        <p:txBody>
+          <a:bodyPr wrap="square">
+            <a:spAutoFit/>
+          </a:bodyPr>
+          <a:lstStyle/>
+          <a:p>
+            <a:pPr algn="l">
+              <a:lnSpc>
+                <a:spcPct val="105000"/>
+              </a:lnSpc>
+              <a:spcAft>
+                <a:spcPts val="600"/>
+              </a:spcAft>
+            </a:pPr>
+            <a:r>
+              <a:rPr sz="1000" b="0">
+                <a:solidFill>
+                  <a:srgbClr val="585868"/>
+                </a:solidFill>
+                <a:latin typeface="Helvetica Neue"/>
+              </a:rPr>
+              <a:t>Banking Campaigns Comparator · ING DACI / Customer AI · September 2026</a:t>
+            </a:r>
+          </a:p>
+        </p:txBody>
+      </p:sp>
+      <p:sp>
+        <p:nvSpPr>
+          <p:cNvPr id="6" name="TextBox 5"/>
+          <p:cNvSpPr txBox="1"/>
+          <p:nvPr/>
+        </p:nvSpPr>
+        <p:spPr>
+          <a:xfrm>
+            <a:off x="11094415" y="6400800"/>
+            <a:ext cx="548640" cy="274320"/>
+          </a:xfrm>
+          <a:prstGeom prst="rect">
+            <a:avLst/>
+          </a:prstGeom>
+          <a:noFill/>
+        </p:spPr>
+        <p:txBody>
+          <a:bodyPr wrap="square">
+            <a:spAutoFit/>
+          </a:bodyPr>
+          <a:lstStyle/>
+          <a:p>
+            <a:pPr algn="r">
+              <a:lnSpc>
+                <a:spcPct val="105000"/>
+              </a:lnSpc>
+              <a:spcAft>
+                <a:spcPts val="600"/>
+              </a:spcAft>
+            </a:pPr>
+            <a:r>
+              <a:rPr sz="1000" b="0">
+                <a:solidFill>
+                  <a:srgbClr val="585868"/>
+                </a:solidFill>
+                <a:latin typeface="Helvetica Neue"/>
+              </a:rPr>
+              <a:t>29</a:t>
             </a:r>
           </a:p>
         </p:txBody>
@@ -8485,7 +9883,7 @@
                 </a:solidFill>
                 <a:latin typeface="Helvetica Neue"/>
               </a:rPr>
-              <a:t>•  A measurement pipeline: 11 banks, 13 current-account pages, 104 declared features, one frozen contract.</a:t>
+              <a:t>•  A measurement pipeline: 14 banks, 16 current-account pages, 104 declared features, one frozen contract.</a:t>
             </a:r>
           </a:p>
           <a:p>
@@ -8542,7 +9940,7 @@
                 </a:solidFill>
                 <a:latin typeface="Helvetica Neue"/>
               </a:rPr>
-              <a:t>•  Two business surfaces: a React web UI (Analysis, Trends, Reputation, Recommendations) and a Streamlit dashboard.</a:t>
+              <a:t>•  One web UI with ten tabs: four business views (Analysis, Trends, Reputation, Recommendations), the generated-site builder, and six read-only operator views carried over from the Streamlit dashboard.</a:t>
             </a:r>
           </a:p>
           <a:p>
@@ -8703,6 +10101,616 @@
                 <a:latin typeface="Helvetica Neue"/>
               </a:rPr>
               <a:t>3</a:t>
+            </a:r>
+          </a:p>
+        </p:txBody>
+      </p:sp>
+    </p:spTree>
+  </p:cSld>
+  <p:clrMapOvr>
+    <a:masterClrMapping/>
+  </p:clrMapOvr>
+</p:sld>
+</file>
+
+<file path=ppt/slides/slide30.xml><?xml version="1.0" encoding="utf-8"?>
+<p:sld xmlns:a="http://schemas.openxmlformats.org/drawingml/2006/main" xmlns:p="http://schemas.openxmlformats.org/presentationml/2006/main" xmlns:r="http://schemas.openxmlformats.org/officeDocument/2006/relationships">
+  <p:cSld>
+    <p:spTree>
+      <p:nvGrpSpPr>
+        <p:cNvPr id="1" name=""/>
+        <p:cNvGrpSpPr/>
+        <p:nvPr/>
+      </p:nvGrpSpPr>
+      <p:grpSpPr/>
+      <p:sp>
+        <p:nvSpPr>
+          <p:cNvPr id="2" name="TextBox 1"/>
+          <p:cNvSpPr txBox="1"/>
+          <p:nvPr/>
+        </p:nvSpPr>
+        <p:spPr>
+          <a:xfrm>
+            <a:off x="548640" y="384048"/>
+            <a:ext cx="11064240" cy="731520"/>
+          </a:xfrm>
+          <a:prstGeom prst="rect">
+            <a:avLst/>
+          </a:prstGeom>
+          <a:noFill/>
+        </p:spPr>
+        <p:txBody>
+          <a:bodyPr wrap="square">
+            <a:spAutoFit/>
+          </a:bodyPr>
+          <a:lstStyle/>
+          <a:p>
+            <a:pPr algn="l">
+              <a:lnSpc>
+                <a:spcPct val="105000"/>
+              </a:lnSpc>
+              <a:spcAft>
+                <a:spcPts val="600"/>
+              </a:spcAft>
+            </a:pPr>
+            <a:r>
+              <a:rPr sz="2800" b="1">
+                <a:solidFill>
+                  <a:srgbClr val="14141C"/>
+                </a:solidFill>
+                <a:latin typeface="Helvetica Neue"/>
+              </a:rPr>
+              <a:t>Roadmap</a:t>
+            </a:r>
+          </a:p>
+        </p:txBody>
+      </p:sp>
+      <p:sp>
+        <p:nvSpPr>
+          <p:cNvPr id="3" name="Rectangle 2"/>
+          <p:cNvSpPr/>
+          <p:nvPr/>
+        </p:nvSpPr>
+        <p:spPr>
+          <a:xfrm>
+            <a:off x="548640" y="1115568"/>
+            <a:ext cx="1463040" cy="64008"/>
+          </a:xfrm>
+          <a:prstGeom prst="rect">
+            <a:avLst/>
+          </a:prstGeom>
+          <a:solidFill>
+            <a:srgbClr val="FF6200"/>
+          </a:solidFill>
+          <a:ln>
+            <a:noFill/>
+          </a:ln>
+          <a:effectLst/>
+        </p:spPr>
+        <p:style>
+          <a:lnRef idx="1">
+            <a:schemeClr val="accent1"/>
+          </a:lnRef>
+          <a:fillRef idx="3">
+            <a:schemeClr val="accent1"/>
+          </a:fillRef>
+          <a:effectRef idx="2">
+            <a:schemeClr val="accent1"/>
+          </a:effectRef>
+          <a:fontRef idx="minor">
+            <a:schemeClr val="lt1"/>
+          </a:fontRef>
+        </p:style>
+        <p:txBody>
+          <a:bodyPr rtlCol="0" anchor="ctr"/>
+          <a:lstStyle/>
+          <a:p>
+            <a:pPr algn="ctr"/>
+          </a:p>
+        </p:txBody>
+      </p:sp>
+      <p:sp>
+        <p:nvSpPr>
+          <p:cNvPr id="4" name="TextBox 3"/>
+          <p:cNvSpPr txBox="1"/>
+          <p:nvPr/>
+        </p:nvSpPr>
+        <p:spPr>
+          <a:xfrm>
+            <a:off x="685800" y="1463040"/>
+            <a:ext cx="10881360" cy="4754880"/>
+          </a:xfrm>
+          <a:prstGeom prst="rect">
+            <a:avLst/>
+          </a:prstGeom>
+          <a:noFill/>
+        </p:spPr>
+        <p:txBody>
+          <a:bodyPr wrap="square">
+            <a:spAutoFit/>
+          </a:bodyPr>
+          <a:lstStyle/>
+          <a:p>
+            <a:pPr algn="l">
+              <a:lnSpc>
+                <a:spcPct val="105000"/>
+              </a:lnSpc>
+              <a:spcAft>
+                <a:spcPts val="200"/>
+              </a:spcAft>
+            </a:pPr>
+            <a:r>
+              <a:rPr sz="1500" b="1">
+                <a:solidFill>
+                  <a:srgbClr val="14141C"/>
+                </a:solidFill>
+                <a:latin typeface="Helvetica Neue"/>
+              </a:rPr>
+              <a:t>•  1. Turn the rubric into a number you can quote</a:t>
+            </a:r>
+          </a:p>
+          <a:p>
+            <a:pPr algn="l">
+              <a:lnSpc>
+                <a:spcPct val="105000"/>
+              </a:lnSpc>
+              <a:spcAft>
+                <a:spcPts val="1000"/>
+              </a:spcAft>
+            </a:pPr>
+            <a:r>
+              <a:rPr sz="1300" b="0">
+                <a:solidFill>
+                  <a:srgbClr val="585868"/>
+                </a:solidFill>
+                <a:latin typeface="Helvetica Neue"/>
+              </a:rPr>
+              <a:t>     Two humans now overlap on 11 pages; extend that to every bank in scope, and tighten the wording for the six features below the 60% bar before any judged feature carries a finding.</a:t>
+            </a:r>
+          </a:p>
+          <a:p>
+            <a:pPr algn="l">
+              <a:lnSpc>
+                <a:spcPct val="105000"/>
+              </a:lnSpc>
+              <a:spcAft>
+                <a:spcPts val="200"/>
+              </a:spcAft>
+            </a:pPr>
+            <a:r>
+              <a:rPr sz="1500" b="1">
+                <a:solidFill>
+                  <a:srgbClr val="14141C"/>
+                </a:solidFill>
+                <a:latin typeface="Helvetica Neue"/>
+              </a:rPr>
+              <a:t>•  2. Score the six new banks</a:t>
+            </a:r>
+          </a:p>
+          <a:p>
+            <a:pPr algn="l">
+              <a:lnSpc>
+                <a:spcPct val="105000"/>
+              </a:lnSpc>
+              <a:spcAft>
+                <a:spcPts val="1000"/>
+              </a:spcAft>
+            </a:pPr>
+            <a:r>
+              <a:rPr sz="1300" b="0">
+                <a:solidFill>
+                  <a:srgbClr val="585868"/>
+                </a:solidFill>
+                <a:latin typeface="Helvetica Neue"/>
+              </a:rPr>
+              <a:t>     CBC, Keytrade, BNP's pages and the restored Belfius and Revolut need rubric sheets, so every bank in the comparison carries a judged layer rather than blanks.</a:t>
+            </a:r>
+          </a:p>
+          <a:p>
+            <a:pPr algn="l">
+              <a:lnSpc>
+                <a:spcPct val="105000"/>
+              </a:lnSpc>
+              <a:spcAft>
+                <a:spcPts val="200"/>
+              </a:spcAft>
+            </a:pPr>
+            <a:r>
+              <a:rPr sz="1500" b="1">
+                <a:solidFill>
+                  <a:srgbClr val="14141C"/>
+                </a:solidFill>
+                <a:latin typeface="Helvetica Neue"/>
+              </a:rPr>
+              <a:t>•  3. Re-run and re-export</a:t>
+            </a:r>
+          </a:p>
+          <a:p>
+            <a:pPr algn="l">
+              <a:lnSpc>
+                <a:spcPct val="105000"/>
+              </a:lnSpc>
+              <a:spcAft>
+                <a:spcPts val="1000"/>
+              </a:spcAft>
+            </a:pPr>
+            <a:r>
+              <a:rPr sz="1300" b="0">
+                <a:solidFill>
+                  <a:srgbClr val="585868"/>
+                </a:solidFill>
+                <a:latin typeface="Helvetica Neue"/>
+              </a:rPr>
+              <a:t>     rubric_sheet.py merge → run_analysis.py → export_web_report.py, then re-verify the narrative's figures against the new snapshot.</a:t>
+            </a:r>
+          </a:p>
+          <a:p>
+            <a:pPr algn="l">
+              <a:lnSpc>
+                <a:spcPct val="105000"/>
+              </a:lnSpc>
+              <a:spcAft>
+                <a:spcPts val="200"/>
+              </a:spcAft>
+            </a:pPr>
+            <a:r>
+              <a:rPr sz="1500" b="1">
+                <a:solidFill>
+                  <a:srgbClr val="14141C"/>
+                </a:solidFill>
+                <a:latin typeface="Helvetica Neue"/>
+              </a:rPr>
+              <a:t>•  4. Decide on outputs/ in git</a:t>
+            </a:r>
+          </a:p>
+          <a:p>
+            <a:pPr algn="l">
+              <a:lnSpc>
+                <a:spcPct val="105000"/>
+              </a:lnSpc>
+              <a:spcAft>
+                <a:spcPts val="1000"/>
+              </a:spcAft>
+            </a:pPr>
+            <a:r>
+              <a:rPr sz="1300" b="0">
+                <a:solidFill>
+                  <a:srgbClr val="585868"/>
+                </a:solidFill>
+                <a:latin typeface="Helvetica Neue"/>
+              </a:rPr>
+              <a:t>     It is regenerated on every run yet tracked, so each analysis leaves a large binary diff.</a:t>
+            </a:r>
+          </a:p>
+          <a:p>
+            <a:pPr algn="l">
+              <a:lnSpc>
+                <a:spcPct val="105000"/>
+              </a:lnSpc>
+              <a:spcAft>
+                <a:spcPts val="200"/>
+              </a:spcAft>
+            </a:pPr>
+            <a:r>
+              <a:rPr sz="1500" b="1">
+                <a:solidFill>
+                  <a:srgbClr val="14141C"/>
+                </a:solidFill>
+                <a:latin typeface="Helvetica Neue"/>
+              </a:rPr>
+              <a:t>•  5. Then, if the team wants it</a:t>
+            </a:r>
+          </a:p>
+          <a:p>
+            <a:pPr algn="l">
+              <a:lnSpc>
+                <a:spcPct val="105000"/>
+              </a:lnSpc>
+              <a:spcAft>
+                <a:spcPts val="1000"/>
+              </a:spcAft>
+            </a:pPr>
+            <a:r>
+              <a:rPr sz="1300" b="0">
+                <a:solidFill>
+                  <a:srgbClr val="585868"/>
+                </a:solidFill>
+                <a:latin typeface="Helvetica Neue"/>
+              </a:rPr>
+              <a:t>     More product families (savings, mortgage) compared the same way, and a wider bank set.</a:t>
+            </a:r>
+          </a:p>
+        </p:txBody>
+      </p:sp>
+      <p:sp>
+        <p:nvSpPr>
+          <p:cNvPr id="5" name="TextBox 4"/>
+          <p:cNvSpPr txBox="1"/>
+          <p:nvPr/>
+        </p:nvSpPr>
+        <p:spPr>
+          <a:xfrm>
+            <a:off x="548640" y="6400800"/>
+            <a:ext cx="8229600" cy="274320"/>
+          </a:xfrm>
+          <a:prstGeom prst="rect">
+            <a:avLst/>
+          </a:prstGeom>
+          <a:noFill/>
+        </p:spPr>
+        <p:txBody>
+          <a:bodyPr wrap="square">
+            <a:spAutoFit/>
+          </a:bodyPr>
+          <a:lstStyle/>
+          <a:p>
+            <a:pPr algn="l">
+              <a:lnSpc>
+                <a:spcPct val="105000"/>
+              </a:lnSpc>
+              <a:spcAft>
+                <a:spcPts val="600"/>
+              </a:spcAft>
+            </a:pPr>
+            <a:r>
+              <a:rPr sz="1000" b="0">
+                <a:solidFill>
+                  <a:srgbClr val="585868"/>
+                </a:solidFill>
+                <a:latin typeface="Helvetica Neue"/>
+              </a:rPr>
+              <a:t>Banking Campaigns Comparator · ING DACI / Customer AI · September 2026</a:t>
+            </a:r>
+          </a:p>
+        </p:txBody>
+      </p:sp>
+      <p:sp>
+        <p:nvSpPr>
+          <p:cNvPr id="6" name="TextBox 5"/>
+          <p:cNvSpPr txBox="1"/>
+          <p:nvPr/>
+        </p:nvSpPr>
+        <p:spPr>
+          <a:xfrm>
+            <a:off x="11094415" y="6400800"/>
+            <a:ext cx="548640" cy="274320"/>
+          </a:xfrm>
+          <a:prstGeom prst="rect">
+            <a:avLst/>
+          </a:prstGeom>
+          <a:noFill/>
+        </p:spPr>
+        <p:txBody>
+          <a:bodyPr wrap="square">
+            <a:spAutoFit/>
+          </a:bodyPr>
+          <a:lstStyle/>
+          <a:p>
+            <a:pPr algn="r">
+              <a:lnSpc>
+                <a:spcPct val="105000"/>
+              </a:lnSpc>
+              <a:spcAft>
+                <a:spcPts val="600"/>
+              </a:spcAft>
+            </a:pPr>
+            <a:r>
+              <a:rPr sz="1000" b="0">
+                <a:solidFill>
+                  <a:srgbClr val="585868"/>
+                </a:solidFill>
+                <a:latin typeface="Helvetica Neue"/>
+              </a:rPr>
+              <a:t>30</a:t>
+            </a:r>
+          </a:p>
+        </p:txBody>
+      </p:sp>
+    </p:spTree>
+  </p:cSld>
+  <p:clrMapOvr>
+    <a:masterClrMapping/>
+  </p:clrMapOvr>
+</p:sld>
+</file>
+
+<file path=ppt/slides/slide31.xml><?xml version="1.0" encoding="utf-8"?>
+<p:sld xmlns:a="http://schemas.openxmlformats.org/drawingml/2006/main" xmlns:p="http://schemas.openxmlformats.org/presentationml/2006/main" xmlns:r="http://schemas.openxmlformats.org/officeDocument/2006/relationships">
+  <p:cSld>
+    <p:spTree>
+      <p:nvGrpSpPr>
+        <p:cNvPr id="1" name=""/>
+        <p:cNvGrpSpPr/>
+        <p:nvPr/>
+      </p:nvGrpSpPr>
+      <p:grpSpPr/>
+      <p:sp>
+        <p:nvSpPr>
+          <p:cNvPr id="2" name="Rectangle 1"/>
+          <p:cNvSpPr/>
+          <p:nvPr/>
+        </p:nvSpPr>
+        <p:spPr>
+          <a:xfrm>
+            <a:off x="0" y="0"/>
+            <a:ext cx="12191695" cy="6858000"/>
+          </a:xfrm>
+          <a:prstGeom prst="rect">
+            <a:avLst/>
+          </a:prstGeom>
+          <a:solidFill>
+            <a:srgbClr val="14141C"/>
+          </a:solidFill>
+          <a:ln>
+            <a:noFill/>
+          </a:ln>
+          <a:effectLst/>
+        </p:spPr>
+        <p:style>
+          <a:lnRef idx="1">
+            <a:schemeClr val="accent1"/>
+          </a:lnRef>
+          <a:fillRef idx="3">
+            <a:schemeClr val="accent1"/>
+          </a:fillRef>
+          <a:effectRef idx="2">
+            <a:schemeClr val="accent1"/>
+          </a:effectRef>
+          <a:fontRef idx="minor">
+            <a:schemeClr val="lt1"/>
+          </a:fontRef>
+        </p:style>
+        <p:txBody>
+          <a:bodyPr rtlCol="0" anchor="ctr"/>
+          <a:lstStyle/>
+          <a:p>
+            <a:pPr algn="ctr"/>
+          </a:p>
+        </p:txBody>
+      </p:sp>
+      <p:sp>
+        <p:nvSpPr>
+          <p:cNvPr id="3" name="Rectangle 2"/>
+          <p:cNvSpPr/>
+          <p:nvPr/>
+        </p:nvSpPr>
+        <p:spPr>
+          <a:xfrm>
+            <a:off x="822960" y="2743200"/>
+            <a:ext cx="2011680" cy="91440"/>
+          </a:xfrm>
+          <a:prstGeom prst="rect">
+            <a:avLst/>
+          </a:prstGeom>
+          <a:solidFill>
+            <a:srgbClr val="FF6200"/>
+          </a:solidFill>
+          <a:ln>
+            <a:noFill/>
+          </a:ln>
+          <a:effectLst/>
+        </p:spPr>
+        <p:style>
+          <a:lnRef idx="1">
+            <a:schemeClr val="accent1"/>
+          </a:lnRef>
+          <a:fillRef idx="3">
+            <a:schemeClr val="accent1"/>
+          </a:fillRef>
+          <a:effectRef idx="2">
+            <a:schemeClr val="accent1"/>
+          </a:effectRef>
+          <a:fontRef idx="minor">
+            <a:schemeClr val="lt1"/>
+          </a:fontRef>
+        </p:style>
+        <p:txBody>
+          <a:bodyPr rtlCol="0" anchor="ctr"/>
+          <a:lstStyle/>
+          <a:p>
+            <a:pPr algn="ctr"/>
+          </a:p>
+        </p:txBody>
+      </p:sp>
+      <p:sp>
+        <p:nvSpPr>
+          <p:cNvPr id="4" name="TextBox 3"/>
+          <p:cNvSpPr txBox="1"/>
+          <p:nvPr/>
+        </p:nvSpPr>
+        <p:spPr>
+          <a:xfrm>
+            <a:off x="822960" y="1828800"/>
+            <a:ext cx="10515600" cy="914400"/>
+          </a:xfrm>
+          <a:prstGeom prst="rect">
+            <a:avLst/>
+          </a:prstGeom>
+          <a:noFill/>
+        </p:spPr>
+        <p:txBody>
+          <a:bodyPr wrap="square">
+            <a:spAutoFit/>
+          </a:bodyPr>
+          <a:lstStyle/>
+          <a:p>
+            <a:pPr algn="l">
+              <a:lnSpc>
+                <a:spcPct val="105000"/>
+              </a:lnSpc>
+              <a:spcAft>
+                <a:spcPts val="600"/>
+              </a:spcAft>
+            </a:pPr>
+            <a:r>
+              <a:rPr sz="2800" b="1">
+                <a:solidFill>
+                  <a:srgbClr val="FFFFFF"/>
+                </a:solidFill>
+                <a:latin typeface="Helvetica Neue"/>
+              </a:rPr>
+              <a:t>Measure one way. Label the trust. Claim only what the data supports.</a:t>
+            </a:r>
+          </a:p>
+        </p:txBody>
+      </p:sp>
+      <p:sp>
+        <p:nvSpPr>
+          <p:cNvPr id="5" name="TextBox 4"/>
+          <p:cNvSpPr txBox="1"/>
+          <p:nvPr/>
+        </p:nvSpPr>
+        <p:spPr>
+          <a:xfrm>
+            <a:off x="822960" y="3063240"/>
+            <a:ext cx="10058400" cy="1463040"/>
+          </a:xfrm>
+          <a:prstGeom prst="rect">
+            <a:avLst/>
+          </a:prstGeom>
+          <a:noFill/>
+        </p:spPr>
+        <p:txBody>
+          <a:bodyPr wrap="square">
+            <a:spAutoFit/>
+          </a:bodyPr>
+          <a:lstStyle/>
+          <a:p>
+            <a:pPr algn="l">
+              <a:lnSpc>
+                <a:spcPct val="105000"/>
+              </a:lnSpc>
+              <a:spcAft>
+                <a:spcPts val="600"/>
+              </a:spcAft>
+            </a:pPr>
+            <a:r>
+              <a:rPr sz="1400" b="0">
+                <a:solidFill>
+                  <a:srgbClr val="B8B8C8"/>
+                </a:solidFill>
+                <a:latin typeface="Helvetica Neue"/>
+              </a:rPr>
+              <a:t>The pipeline, the contract and the guardrails are in the repository:</a:t>
+            </a:r>
+          </a:p>
+          <a:p>
+            <a:pPr algn="l">
+              <a:lnSpc>
+                <a:spcPct val="105000"/>
+              </a:lnSpc>
+              <a:spcAft>
+                <a:spcPts val="600"/>
+              </a:spcAft>
+            </a:pPr>
+            <a:r>
+              <a:rPr sz="1400" b="0">
+                <a:solidFill>
+                  <a:srgbClr val="B8B8C8"/>
+                </a:solidFill>
+                <a:latin typeface="Helvetica Neue"/>
+              </a:rPr>
+              <a:t>README.md · docs/design.md · docs/pipeline.md · web/README.md · docs/decisions.md</a:t>
             </a:r>
           </a:p>
         </p:txBody>
@@ -10374,7 +12382,7 @@
                 </a:solidFill>
                 <a:latin typeface="Helvetica Neue"/>
               </a:rPr>
-              <a:t>•  16 pages, 14 banks, 25 comparable features, nothing excluded</a:t>
+              <a:t>•  16 pages, 14 banks, 30 comparable features, nothing excluded</a:t>
             </a:r>
           </a:p>
           <a:p>

</xml_diff>

<commit_message>
docs: align the rubric figures with the full-scope sheets
The three human sheets now cover every captured page as blank rows, so two
stated figures were wrong: Dan and Siegried share 10 scored pages, not 11, and
agreement spans 9 to 15 pages, not 9 to 11. Corrected in the README, the
decision entry, D06 and the deck, and operations.json is regenerated from the
sheets that are now on main (Dan 51 / Siegried 63 / Stephane 63 rows).

The deck was rebuilt and the video re-rendered (15.7 min, 36.0 MB), including a
fresh Rubric tab screenshot that shows the full-scope sheets.
</commit_message>
<xml_diff>
--- a/docs/Banking_Campaigns_Comparator.pptx
+++ b/docs/Banking_Campaigns_Comparator.pptx
@@ -3568,7 +3568,7 @@
                 </a:solidFill>
                 <a:latin typeface="Helvetica Neue"/>
               </a:rPr>
-              <a:t>•  Two independent humans now overlap on 11 pages</a:t>
+              <a:t>•  Two independent humans now overlap on 10 pages</a:t>
             </a:r>
           </a:p>
           <a:p>
@@ -3587,7 +3587,7 @@
                 </a:solidFill>
                 <a:latin typeface="Helvetica Neue"/>
               </a:rPr>
-              <a:t>     Siegried has scored 25 pages and Dan 11, and the two sheets share all 11 of Dan's — so the agreement figure finally measures two people, not one person against a model.</a:t>
+              <a:t>     Siegried has scored 25 pages and Dan 11, and 10 of Dan's 11 scored pages also carry a Siegried score — so the agreement figure finally measures two people, not one person against a model.</a:t>
             </a:r>
           </a:p>
           <a:p>
@@ -3644,7 +3644,7 @@
                 </a:solidFill>
                 <a:latin typeface="Helvetica Neue"/>
               </a:rPr>
-              <a:t>•  Agreement is measurable for all 13 features, over 9 to 11 pages</a:t>
+              <a:t>•  Agreement is measurable for all 13 features, over 9 to 15 pages</a:t>
             </a:r>
           </a:p>
           <a:p>
@@ -9539,7 +9539,7 @@
                 </a:solidFill>
                 <a:latin typeface="Helvetica Neue"/>
               </a:rPr>
-              <a:t>     Two humans overlap on only 11 pages, Stephane's 9 were machine-proposed and adopted, and six of the thirteen features sit below the agreement bar — so a finding resting on persuasion levers or accent placement is a hypothesis.</a:t>
+              <a:t>     Two humans overlap on only 10 pages, Stephane's 9 were machine-proposed and adopted, and six of the thirteen features sit below the agreement bar — so a finding resting on persuasion levers or accent placement is a hypothesis.</a:t>
             </a:r>
           </a:p>
           <a:p>
@@ -10265,7 +10265,7 @@
                 </a:solidFill>
                 <a:latin typeface="Helvetica Neue"/>
               </a:rPr>
-              <a:t>     Two humans now overlap on 11 pages; extend that to every bank in scope, and tighten the wording for the six features below the 60% bar before any judged feature carries a finding.</a:t>
+              <a:t>     Two humans now overlap on 10 pages; extend that to every bank in scope, and tighten the wording for the six features below the 60% bar before any judged feature carries a finding.</a:t>
             </a:r>
           </a:p>
           <a:p>

</xml_diff>

<commit_message>
docs: frame the generated site as an illustration, and say what reputation is not
The client answered that the goal is comparative and that "actionable"
means how ING communicates, not changes to its website. The generated
site is therefore presented as an illustration of what a recommendation
means in practice, on the deck's overview and on the slide that shows it.

The same answer read the reputation feature as showing "how well the
campaigns are doing". That is the one claim the module refuses to make,
so the Reputation slide and the tab itself now say it in the client's own
terms: themes are what a bank is written about, never evidence that a
page or campaign performed.

The tab also stopped asserting "no recent headlines found" for a bank it
simply could not fetch - with newsapi.org currently returning 401, that
string was reporting an outage as a finding. It now reads "no headlines
recorded", with the caveat stated above the list.
</commit_message>
<xml_diff>
--- a/docs/Banking_Campaigns_Comparator.pptx
+++ b/docs/Banking_Campaigns_Comparator.pptx
@@ -5476,7 +5476,7 @@
                 </a:solidFill>
                 <a:latin typeface="Helvetica Neue"/>
               </a:rPr>
-              <a:t>•  Themes are context about the bank, never evidence about the page.</a:t>
+              <a:t>•  Themes are context about the bank, never evidence that a page or campaign performed. Asked whether reputation shows how well campaigns are doing, the honest answer is no: press coverage says what a bank is written about, not whether its page worked.</a:t>
             </a:r>
           </a:p>
         </p:txBody>
@@ -6290,7 +6290,7 @@
                 </a:solidFill>
                 <a:latin typeface="Helvetica Neue"/>
               </a:rPr>
-              <a:t>Each section that implements a recommendation is boxed; the (i) button opens the reasoning above it, and that section's glow switches to a slow yellow flicker.</a:t>
+              <a:t>An illustration, not a proposal for ING's site: each section that implements a recommendation is boxed, the (i) button opens the reasoning above it, and that section's glow switches to a slow yellow flicker.</a:t>
             </a:r>
           </a:p>
         </p:txBody>
@@ -9978,7 +9978,7 @@
                 </a:solidFill>
                 <a:latin typeface="Helvetica Neue"/>
               </a:rPr>
-              <a:t>•  A generated ING website: ten pages built from the selected recommendations, in ING's house style.</a:t>
+              <a:t>•  A generated ING website: ten pages built from the selected recommendations — an illustration of what a recommendation means in practice, not a proposal for ING's own site.</a:t>
             </a:r>
           </a:p>
           <a:p>

</xml_diff>

<commit_message>
deck: cite the CTA figure rather than rank it, detail moves to the speaker notes
ING is 11th of 14 on the counted figure (1.0 against a peer mean of 5.0), so
under the rule Siegried set - publish it only if ING is above, otherwise name it
and say the rest aloud - the slide now names the feature and states that no
ranking is published. The nine-clickable-things-one-that-converts observation
moves into her notes for that slide, where it belongs as spoken material.
</commit_message>
<xml_diff>
--- a/docs/Banking_Campaigns_Comparator.pptx
+++ b/docs/Banking_Campaigns_Comparator.pptx
@@ -1024,6 +1024,12 @@
             <a:r>
               <a:rPr lang="en-US" dirty="0"/>
               <a:t>Then: Dan takes slides 9-12, trends, about 2 min. Stephane takes 13-17, recommendations and site, about 2 min 30.</a:t>
+            </a:r>
+          </a:p>
+          <a:p>
+            <a:r>
+              <a:rPr lang="en-US" dirty="0"/>
+              <a:t>CALLS TO ACTION, spoken, not on the slide: ING is 11th of 14 on the counted figure, 1.0 against a peer mean of 5.0 - but we do not publish that ranking, because no rule reproduces a human count on every bank. What the page itself shows is the point: ING's pack page carries nine clickable things and exactly one that opens an account, Se lancer, on a page eleven thousand pixels long. Plenty to click, almost nothing that converts.</a:t>
             </a:r>
           </a:p>
         </p:txBody>
@@ -23306,7 +23312,7 @@
                 </a:solidFill>
                 <a:latin typeface="Helvetica Neue"/>
               </a:rPr>
-              <a:t>     Animation: 0.33 vs peers 0.62 (-0.58 SD) — the one measured place ING sits below the set. Calls to action: we publish no ranking, because no counting rule we tried reproduces a human count across all fourteen banks. What the pages do show is worth saying out loud. ING’s pack page carries nine clickable things and exactly one that opens an account — Se lancer — on a page eleven thousand pixels long. Plenty to click, almost nothing that converts.</a:t>
+              <a:t>     Animation: 0.33 vs peers 0.62 (-0.58 SD) — the one measured place ING sits below the set. Calls to action are measured but not ranked here: no counting rule we tried reproduces a human count across all fourteen banks, so the figure is named rather than published.</a:t>
             </a:r>
           </a:p>
           <a:p>

</xml_diff>

<commit_message>
deck: remove slide 11's institutional-trust row, it rested on one data point
institutional_trust_signal_present is False on 17 of the 18 compared pages -
Revolut is the only True in the family. The row read +1.02 vs -0.28, but the
trio's +1.02 came entirely from that one page and ING's -0.28 meant only
"False, like almost everyone". The flag is wrong on its face too: ING's pages
carry FSMA registration, RPM Bruxelles and the deposit guarantee, more
institutional markers than KBC's on two of three pages, and are still False.

The animation row moves up to fill the gap. No replacement exists: every
feature where the trio sits above ING is either binary - alt text and animation
have 2 and 3 distinct values across fourteen banks - or markup-dependent.
section_count counts <section> tags, so KBC and CBC score 1 while carrying 12
and 13 headings, Crelan scores 154, and ING has no value at all.

Tests: 423 passed, 1 skipped.
</commit_message>
<xml_diff>
--- a/docs/Banking_Campaigns_Comparator.pptx
+++ b/docs/Banking_Campaigns_Comparator.pptx
@@ -4,6 +4,9 @@
   <p:sldMasterIdLst>
     <p:sldMasterId id="2147483648" r:id="rId1"/>
   </p:sldMasterIdLst>
+  <p:notesMasterIdLst>
+    <p:notesMasterId r:id="rId43"/>
+  </p:notesMasterIdLst>
   <p:sldIdLst>
     <p:sldId id="256" r:id="rId2"/>
     <p:sldId id="257" r:id="rId3"/>
@@ -47,9 +50,6 @@
     <p:sldId id="295" r:id="rId41"/>
     <p:sldId id="296" r:id="rId42"/>
   </p:sldIdLst>
-  <p:notesMasterIdLst>
-    <p:notesMasterId r:id="rId9000"/>
-  </p:notesMasterIdLst>
   <p:sldSz cx="12192000" cy="6858000"/>
   <p:notesSz cx="6858000" cy="9144000"/>
   <p:defaultTextStyle>
@@ -215,7 +215,7 @@
             </a:lvl1pPr>
           </a:lstStyle>
           <a:p>
-            <a:endParaRPr lang="en-US"/>
+            <a:endParaRPr lang="fr-BE"/>
           </a:p>
         </p:txBody>
       </p:sp>
@@ -246,11 +246,11 @@
             </a:lvl1pPr>
           </a:lstStyle>
           <a:p>
-            <a:fld id="{5282F153-3F37-0F45-9E97-73ACFA13230C}" type="datetimeFigureOut">
-              <a:rPr lang="en-US"/>
-              <a:t>7/23/19</a:t>
+            <a:fld id="{5EAA65B6-A2CF-4CB4-ADA6-4FB12DC6F514}" type="datetimeFigureOut">
+              <a:rPr lang="fr-BE" smtClean="0"/>
+              <a:t>24-09-26</a:t>
             </a:fld>
-            <a:endParaRPr lang="en-US"/>
+            <a:endParaRPr lang="fr-BE"/>
           </a:p>
         </p:txBody>
       </p:sp>
@@ -283,7 +283,7 @@
           <a:bodyPr vert="horz" lIns="91440" tIns="45720" rIns="91440" bIns="45720" rtlCol="0" anchor="ctr"/>
           <a:lstStyle/>
           <a:p>
-            <a:endParaRPr lang="en-US"/>
+            <a:endParaRPr lang="fr-BE"/>
           </a:p>
         </p:txBody>
       </p:sp>
@@ -343,6 +343,7 @@
               <a:rPr lang="en-US"/>
               <a:t>Fifth level</a:t>
             </a:r>
+            <a:endParaRPr lang="fr-BE"/>
           </a:p>
         </p:txBody>
       </p:sp>
@@ -373,7 +374,7 @@
             </a:lvl1pPr>
           </a:lstStyle>
           <a:p>
-            <a:endParaRPr lang="en-US"/>
+            <a:endParaRPr lang="fr-BE"/>
           </a:p>
         </p:txBody>
       </p:sp>
@@ -404,18 +405,18 @@
             </a:lvl1pPr>
           </a:lstStyle>
           <a:p>
-            <a:fld id="{CE5E9CC1-C706-0F49-92D6-E571CC5EEA8F}" type="slidenum">
-              <a:rPr lang="en-US"/>
+            <a:fld id="{3BD8D499-DB7D-4F44-9C48-D7F5314CC23E}" type="slidenum">
+              <a:rPr lang="fr-BE" smtClean="0"/>
               <a:t>‹#›</a:t>
             </a:fld>
-            <a:endParaRPr lang="en-US"/>
+            <a:endParaRPr lang="fr-BE"/>
           </a:p>
         </p:txBody>
       </p:sp>
     </p:spTree>
     <p:extLst>
       <p:ext uri="{BB962C8B-B14F-4D97-AF65-F5344CB8AC3E}">
-        <p14:creationId xmlns:p14="http://schemas.microsoft.com/office/powerpoint/2010/main" val="1024086991"/>
+        <p14:creationId xmlns:p14="http://schemas.microsoft.com/office/powerpoint/2010/main" val="1555760893"/>
       </p:ext>
     </p:extLst>
   </p:cSld>
@@ -8627,7 +8628,7 @@
       </p:sp>
       <p:sp>
         <p:nvSpPr>
-          <p:cNvPr id="13" name="TextBox"/>
+          <p:cNvPr id="19" name="TextBox"/>
           <p:cNvSpPr txBox="1"/>
           <p:nvPr/>
         </p:nvSpPr>
@@ -8662,14 +8663,14 @@
                 </a:solidFill>
                 <a:latin typeface="Helvetica Neue"/>
               </a:rPr>
-              <a:t>Institutional trust signals</a:t>
-            </a:r>
-          </a:p>
-        </p:txBody>
-      </p:sp>
-      <p:sp>
-        <p:nvSpPr>
-          <p:cNvPr id="14" name="Rect"/>
+              <a:t>Animated elements</a:t>
+            </a:r>
+          </a:p>
+        </p:txBody>
+      </p:sp>
+      <p:sp>
+        <p:nvSpPr>
+          <p:cNvPr id="20" name="Rect"/>
           <p:cNvSpPr/>
           <p:nvPr/>
         </p:nvSpPr>
@@ -8698,7 +8699,7 @@
       </p:sp>
       <p:sp>
         <p:nvSpPr>
-          <p:cNvPr id="15" name="Rect"/>
+          <p:cNvPr id="21" name="Rect"/>
           <p:cNvSpPr/>
           <p:nvPr/>
         </p:nvSpPr>
@@ -8727,13 +8728,13 @@
       </p:sp>
       <p:sp>
         <p:nvSpPr>
-          <p:cNvPr id="16" name="Oval"/>
+          <p:cNvPr id="22" name="Oval"/>
           <p:cNvSpPr/>
           <p:nvPr/>
         </p:nvSpPr>
         <p:spPr>
           <a:xfrm>
-            <a:off x="4509504" y="2415501"/>
+            <a:off x="4140200" y="2415501"/>
             <a:ext cx="177800" cy="177800"/>
           </a:xfrm>
           <a:prstGeom prst="ellipse">
@@ -8756,13 +8757,13 @@
       </p:sp>
       <p:sp>
         <p:nvSpPr>
-          <p:cNvPr id="17" name="Oval"/>
+          <p:cNvPr id="23" name="Oval"/>
           <p:cNvSpPr/>
           <p:nvPr/>
         </p:nvSpPr>
         <p:spPr>
           <a:xfrm>
-            <a:off x="6303254" y="2415501"/>
+            <a:off x="6064250" y="2415501"/>
             <a:ext cx="177800" cy="177800"/>
           </a:xfrm>
           <a:prstGeom prst="ellipse">
@@ -8785,222 +8786,13 @@
       </p:sp>
       <p:sp>
         <p:nvSpPr>
-          <p:cNvPr id="18" name="TextBox"/>
-          <p:cNvSpPr txBox="1"/>
-          <p:nvPr/>
-        </p:nvSpPr>
-        <p:spPr>
-          <a:xfrm>
-            <a:off x="8686800" y="2397741"/>
-            <a:ext cx="1500000" cy="238720"/>
-          </a:xfrm>
-          <a:prstGeom prst="rect">
-            <a:avLst/>
-          </a:prstGeom>
-          <a:noFill/>
-        </p:spPr>
-        <p:txBody>
-          <a:bodyPr wrap="none">
-            <a:spAutoFit/>
-          </a:bodyPr>
-          <a:lstStyle/>
-          <a:p>
-            <a:pPr algn="l">
-              <a:lnSpc>
-                <a:spcPct val="105000"/>
-              </a:lnSpc>
-              <a:spcAft>
-                <a:spcPts val="0"/>
-              </a:spcAft>
-            </a:pPr>
-            <a:r>
-              <a:rPr sz="1200" b="0">
-                <a:solidFill>
-                  <a:srgbClr val="14141C"/>
-                </a:solidFill>
-                <a:latin typeface="Helvetica Neue"/>
-              </a:rPr>
-              <a:t>+1.02 vs </a:t>
-            </a:r>
-            <a:r>
-              <a:rPr sz="1200" b="0">
-                <a:solidFill>
-                  <a:srgbClr val="FF6200"/>
-                </a:solidFill>
-                <a:latin typeface="Helvetica Neue"/>
-              </a:rPr>
-              <a:t>−0.28</a:t>
-            </a:r>
-          </a:p>
-        </p:txBody>
-      </p:sp>
-      <p:sp>
-        <p:nvSpPr>
-          <p:cNvPr id="19" name="TextBox"/>
-          <p:cNvSpPr txBox="1"/>
-          <p:nvPr/>
-        </p:nvSpPr>
-        <p:spPr>
-          <a:xfrm>
-            <a:off x="685800" y="2913380"/>
-            <a:ext cx="2747010" cy="274241"/>
-          </a:xfrm>
-          <a:prstGeom prst="rect">
-            <a:avLst/>
-          </a:prstGeom>
-          <a:noFill/>
-        </p:spPr>
-        <p:txBody>
-          <a:bodyPr wrap="square">
-            <a:spAutoFit/>
-          </a:bodyPr>
-          <a:lstStyle/>
-          <a:p>
-            <a:pPr algn="l">
-              <a:lnSpc>
-                <a:spcPct val="105000"/>
-              </a:lnSpc>
-              <a:spcAft>
-                <a:spcPts val="0"/>
-              </a:spcAft>
-            </a:pPr>
-            <a:r>
-              <a:rPr sz="1400" b="1">
-                <a:solidFill>
-                  <a:srgbClr val="14141C"/>
-                </a:solidFill>
-                <a:latin typeface="Helvetica Neue"/>
-              </a:rPr>
-              <a:t>Animated elements</a:t>
-            </a:r>
-          </a:p>
-        </p:txBody>
-      </p:sp>
-      <p:sp>
-        <p:nvSpPr>
-          <p:cNvPr id="20" name="Rect"/>
-          <p:cNvSpPr/>
-          <p:nvPr/>
-        </p:nvSpPr>
-        <p:spPr>
-          <a:xfrm>
-            <a:off x="3606800" y="3031451"/>
-            <a:ext cx="4826000" cy="12700"/>
-          </a:xfrm>
-          <a:prstGeom prst="rect">
-            <a:avLst/>
-          </a:prstGeom>
-          <a:solidFill>
-            <a:srgbClr val="D8D8E0"/>
-          </a:solidFill>
-          <a:ln>
-            <a:noFill/>
-          </a:ln>
-        </p:spPr>
-        <p:txBody>
-          <a:bodyPr/>
-          <a:lstStyle/>
-          <a:p>
-            <a:endParaRPr/>
-          </a:p>
-        </p:txBody>
-      </p:sp>
-      <p:sp>
-        <p:nvSpPr>
-          <p:cNvPr id="21" name="Rect"/>
-          <p:cNvSpPr/>
-          <p:nvPr/>
-        </p:nvSpPr>
-        <p:spPr>
-          <a:xfrm>
-            <a:off x="4978400" y="2910801"/>
-            <a:ext cx="12700" cy="254000"/>
-          </a:xfrm>
-          <a:prstGeom prst="rect">
-            <a:avLst/>
-          </a:prstGeom>
-          <a:solidFill>
-            <a:srgbClr val="A8A8B8"/>
-          </a:solidFill>
-          <a:ln>
-            <a:noFill/>
-          </a:ln>
-        </p:spPr>
-        <p:txBody>
-          <a:bodyPr/>
-          <a:lstStyle/>
-          <a:p>
-            <a:endParaRPr/>
-          </a:p>
-        </p:txBody>
-      </p:sp>
-      <p:sp>
-        <p:nvSpPr>
-          <p:cNvPr id="22" name="Oval"/>
-          <p:cNvSpPr/>
-          <p:nvPr/>
-        </p:nvSpPr>
-        <p:spPr>
-          <a:xfrm>
-            <a:off x="4140200" y="2948901"/>
-            <a:ext cx="177800" cy="177800"/>
-          </a:xfrm>
-          <a:prstGeom prst="ellipse">
-            <a:avLst/>
-          </a:prstGeom>
-          <a:solidFill>
-            <a:srgbClr val="FF6200"/>
-          </a:solidFill>
-          <a:ln>
-            <a:noFill/>
-          </a:ln>
-        </p:spPr>
-        <p:txBody>
-          <a:bodyPr/>
-          <a:lstStyle/>
-          <a:p>
-            <a:endParaRPr/>
-          </a:p>
-        </p:txBody>
-      </p:sp>
-      <p:sp>
-        <p:nvSpPr>
-          <p:cNvPr id="23" name="Oval"/>
-          <p:cNvSpPr/>
-          <p:nvPr/>
-        </p:nvSpPr>
-        <p:spPr>
-          <a:xfrm>
-            <a:off x="6064250" y="2948901"/>
-            <a:ext cx="177800" cy="177800"/>
-          </a:xfrm>
-          <a:prstGeom prst="ellipse">
-            <a:avLst/>
-          </a:prstGeom>
-          <a:solidFill>
-            <a:srgbClr val="14141C"/>
-          </a:solidFill>
-          <a:ln>
-            <a:noFill/>
-          </a:ln>
-        </p:spPr>
-        <p:txBody>
-          <a:bodyPr/>
-          <a:lstStyle/>
-          <a:p>
-            <a:endParaRPr/>
-          </a:p>
-        </p:txBody>
-      </p:sp>
-      <p:sp>
-        <p:nvSpPr>
           <p:cNvPr id="24" name="TextBox"/>
           <p:cNvSpPr txBox="1"/>
           <p:nvPr/>
         </p:nvSpPr>
         <p:spPr>
           <a:xfrm>
-            <a:off x="8686800" y="2931141"/>
+            <a:off x="8686800" y="2397741"/>
             <a:ext cx="1500000" cy="238720"/>
           </a:xfrm>
           <a:prstGeom prst="rect">
@@ -9585,7 +9377,7 @@
         <p:spPr>
           <a:xfrm>
             <a:off x="5529858" y="2021801"/>
-            <a:ext cx="1883664" cy="238720"/>
+            <a:ext cx="3248382" cy="272832"/>
           </a:xfrm>
           <a:prstGeom prst="rect">
             <a:avLst/>
@@ -20878,7 +20670,7 @@
           <p:nvPr/>
         </p:nvPicPr>
         <p:blipFill>
-          <a:blip r:embed="rId2"/>
+          <a:blip r:embed="rId3"/>
           <a:stretch>
             <a:fillRect/>
           </a:stretch>
@@ -23284,16 +23076,7 @@
                 </a:solidFill>
                 <a:latin typeface="Helvetica Neue"/>
               </a:rPr>
-              <a:t>•  </a:t>
-            </a:r>
-            <a:r>
-              <a:rPr sz="1500" b="1" dirty="0">
-                <a:solidFill>
-                  <a:srgbClr val="14141C"/>
-                </a:solidFill>
-                <a:latin typeface="Helvetica Neue"/>
-              </a:rPr>
-              <a:t>Where ING is below</a:t>
+              <a:t>•  Where ING is below</a:t>
             </a:r>
           </a:p>
           <a:p>
@@ -25854,4 +25637,319 @@
   </a:objectDefaults>
   <a:extraClrSchemeLst/>
 </a:theme>
+</file>
+
+<file path=ppt/theme/theme2.xml><?xml version="1.0" encoding="utf-8"?>
+<a:theme xmlns:a="http://schemas.openxmlformats.org/drawingml/2006/main" name="Office Theme">
+  <a:themeElements>
+    <a:clrScheme name="Office">
+      <a:dk1>
+        <a:sysClr val="windowText" lastClr="000000"/>
+      </a:dk1>
+      <a:lt1>
+        <a:sysClr val="window" lastClr="FFFFFF"/>
+      </a:lt1>
+      <a:dk2>
+        <a:srgbClr val="0E2841"/>
+      </a:dk2>
+      <a:lt2>
+        <a:srgbClr val="E8E8E8"/>
+      </a:lt2>
+      <a:accent1>
+        <a:srgbClr val="156082"/>
+      </a:accent1>
+      <a:accent2>
+        <a:srgbClr val="E97132"/>
+      </a:accent2>
+      <a:accent3>
+        <a:srgbClr val="196B24"/>
+      </a:accent3>
+      <a:accent4>
+        <a:srgbClr val="0F9ED5"/>
+      </a:accent4>
+      <a:accent5>
+        <a:srgbClr val="A02B93"/>
+      </a:accent5>
+      <a:accent6>
+        <a:srgbClr val="4EA72E"/>
+      </a:accent6>
+      <a:hlink>
+        <a:srgbClr val="467886"/>
+      </a:hlink>
+      <a:folHlink>
+        <a:srgbClr val="96607D"/>
+      </a:folHlink>
+    </a:clrScheme>
+    <a:fontScheme name="Office">
+      <a:majorFont>
+        <a:latin typeface="Aptos Display" panose="02110004020202020204"/>
+        <a:ea typeface=""/>
+        <a:cs typeface=""/>
+        <a:font script="Jpan" typeface="游ゴシック Light"/>
+        <a:font script="Hang" typeface="맑은 고딕"/>
+        <a:font script="Hans" typeface="等线 Light"/>
+        <a:font script="Hant" typeface="新細明體"/>
+        <a:font script="Arab" typeface="Times New Roman"/>
+        <a:font script="Hebr" typeface="Times New Roman"/>
+        <a:font script="Thai" typeface="Angsana New"/>
+        <a:font script="Ethi" typeface="Nyala"/>
+        <a:font script="Beng" typeface="Vrinda"/>
+        <a:font script="Gujr" typeface="Shruti"/>
+        <a:font script="Khmr" typeface="MoolBoran"/>
+        <a:font script="Knda" typeface="Tunga"/>
+        <a:font script="Guru" typeface="Raavi"/>
+        <a:font script="Cans" typeface="Euphemia"/>
+        <a:font script="Cher" typeface="Plantagenet Cherokee"/>
+        <a:font script="Yiii" typeface="Microsoft Yi Baiti"/>
+        <a:font script="Tibt" typeface="Microsoft Himalaya"/>
+        <a:font script="Thaa" typeface="MV Boli"/>
+        <a:font script="Deva" typeface="Mangal"/>
+        <a:font script="Telu" typeface="Gautami"/>
+        <a:font script="Taml" typeface="Latha"/>
+        <a:font script="Syrc" typeface="Estrangelo Edessa"/>
+        <a:font script="Orya" typeface="Kalinga"/>
+        <a:font script="Mlym" typeface="Kartika"/>
+        <a:font script="Laoo" typeface="DokChampa"/>
+        <a:font script="Sinh" typeface="Iskoola Pota"/>
+        <a:font script="Mong" typeface="Mongolian Baiti"/>
+        <a:font script="Viet" typeface="Times New Roman"/>
+        <a:font script="Uigh" typeface="Microsoft Uighur"/>
+        <a:font script="Geor" typeface="Sylfaen"/>
+        <a:font script="Armn" typeface="Arial"/>
+        <a:font script="Bugi" typeface="Leelawadee UI"/>
+        <a:font script="Bopo" typeface="Microsoft JhengHei"/>
+        <a:font script="Java" typeface="Javanese Text"/>
+        <a:font script="Lisu" typeface="Segoe UI"/>
+        <a:font script="Mymr" typeface="Myanmar Text"/>
+        <a:font script="Nkoo" typeface="Ebrima"/>
+        <a:font script="Olck" typeface="Nirmala UI"/>
+        <a:font script="Osma" typeface="Ebrima"/>
+        <a:font script="Phag" typeface="Phagspa"/>
+        <a:font script="Syrn" typeface="Estrangelo Edessa"/>
+        <a:font script="Syrj" typeface="Estrangelo Edessa"/>
+        <a:font script="Syre" typeface="Estrangelo Edessa"/>
+        <a:font script="Sora" typeface="Nirmala UI"/>
+        <a:font script="Tale" typeface="Microsoft Tai Le"/>
+        <a:font script="Talu" typeface="Microsoft New Tai Lue"/>
+        <a:font script="Tfng" typeface="Ebrima"/>
+      </a:majorFont>
+      <a:minorFont>
+        <a:latin typeface="Aptos" panose="02110004020202020204"/>
+        <a:ea typeface=""/>
+        <a:cs typeface=""/>
+        <a:font script="Jpan" typeface="游ゴシック"/>
+        <a:font script="Hang" typeface="맑은 고딕"/>
+        <a:font script="Hans" typeface="等线"/>
+        <a:font script="Hant" typeface="新細明體"/>
+        <a:font script="Arab" typeface="Arial"/>
+        <a:font script="Hebr" typeface="Arial"/>
+        <a:font script="Thai" typeface="Cordia New"/>
+        <a:font script="Ethi" typeface="Nyala"/>
+        <a:font script="Beng" typeface="Vrinda"/>
+        <a:font script="Gujr" typeface="Shruti"/>
+        <a:font script="Khmr" typeface="DaunPenh"/>
+        <a:font script="Knda" typeface="Tunga"/>
+        <a:font script="Guru" typeface="Raavi"/>
+        <a:font script="Cans" typeface="Euphemia"/>
+        <a:font script="Cher" typeface="Plantagenet Cherokee"/>
+        <a:font script="Yiii" typeface="Microsoft Yi Baiti"/>
+        <a:font script="Tibt" typeface="Microsoft Himalaya"/>
+        <a:font script="Thaa" typeface="MV Boli"/>
+        <a:font script="Deva" typeface="Mangal"/>
+        <a:font script="Telu" typeface="Gautami"/>
+        <a:font script="Taml" typeface="Latha"/>
+        <a:font script="Syrc" typeface="Estrangelo Edessa"/>
+        <a:font script="Orya" typeface="Kalinga"/>
+        <a:font script="Mlym" typeface="Kartika"/>
+        <a:font script="Laoo" typeface="DokChampa"/>
+        <a:font script="Sinh" typeface="Iskoola Pota"/>
+        <a:font script="Mong" typeface="Mongolian Baiti"/>
+        <a:font script="Viet" typeface="Arial"/>
+        <a:font script="Uigh" typeface="Microsoft Uighur"/>
+        <a:font script="Geor" typeface="Sylfaen"/>
+        <a:font script="Armn" typeface="Arial"/>
+        <a:font script="Bugi" typeface="Leelawadee UI"/>
+        <a:font script="Bopo" typeface="Microsoft JhengHei"/>
+        <a:font script="Java" typeface="Javanese Text"/>
+        <a:font script="Lisu" typeface="Segoe UI"/>
+        <a:font script="Mymr" typeface="Myanmar Text"/>
+        <a:font script="Nkoo" typeface="Ebrima"/>
+        <a:font script="Olck" typeface="Nirmala UI"/>
+        <a:font script="Osma" typeface="Ebrima"/>
+        <a:font script="Phag" typeface="Phagspa"/>
+        <a:font script="Syrn" typeface="Estrangelo Edessa"/>
+        <a:font script="Syrj" typeface="Estrangelo Edessa"/>
+        <a:font script="Syre" typeface="Estrangelo Edessa"/>
+        <a:font script="Sora" typeface="Nirmala UI"/>
+        <a:font script="Tale" typeface="Microsoft Tai Le"/>
+        <a:font script="Talu" typeface="Microsoft New Tai Lue"/>
+        <a:font script="Tfng" typeface="Ebrima"/>
+      </a:minorFont>
+    </a:fontScheme>
+    <a:fmtScheme name="Office">
+      <a:fillStyleLst>
+        <a:solidFill>
+          <a:schemeClr val="phClr"/>
+        </a:solidFill>
+        <a:gradFill rotWithShape="1">
+          <a:gsLst>
+            <a:gs pos="0">
+              <a:schemeClr val="phClr">
+                <a:lumMod val="110000"/>
+                <a:satMod val="105000"/>
+                <a:tint val="67000"/>
+              </a:schemeClr>
+            </a:gs>
+            <a:gs pos="50000">
+              <a:schemeClr val="phClr">
+                <a:lumMod val="105000"/>
+                <a:satMod val="103000"/>
+                <a:tint val="73000"/>
+              </a:schemeClr>
+            </a:gs>
+            <a:gs pos="100000">
+              <a:schemeClr val="phClr">
+                <a:lumMod val="105000"/>
+                <a:satMod val="109000"/>
+                <a:tint val="81000"/>
+              </a:schemeClr>
+            </a:gs>
+          </a:gsLst>
+          <a:lin ang="5400000" scaled="0"/>
+        </a:gradFill>
+        <a:gradFill rotWithShape="1">
+          <a:gsLst>
+            <a:gs pos="0">
+              <a:schemeClr val="phClr">
+                <a:satMod val="103000"/>
+                <a:lumMod val="102000"/>
+                <a:tint val="94000"/>
+              </a:schemeClr>
+            </a:gs>
+            <a:gs pos="50000">
+              <a:schemeClr val="phClr">
+                <a:satMod val="110000"/>
+                <a:lumMod val="100000"/>
+                <a:shade val="100000"/>
+              </a:schemeClr>
+            </a:gs>
+            <a:gs pos="100000">
+              <a:schemeClr val="phClr">
+                <a:lumMod val="99000"/>
+                <a:satMod val="120000"/>
+                <a:shade val="78000"/>
+              </a:schemeClr>
+            </a:gs>
+          </a:gsLst>
+          <a:lin ang="5400000" scaled="0"/>
+        </a:gradFill>
+      </a:fillStyleLst>
+      <a:lnStyleLst>
+        <a:ln w="12700" cap="flat" cmpd="sng" algn="ctr">
+          <a:solidFill>
+            <a:schemeClr val="phClr"/>
+          </a:solidFill>
+          <a:prstDash val="solid"/>
+          <a:miter lim="800000"/>
+        </a:ln>
+        <a:ln w="19050" cap="flat" cmpd="sng" algn="ctr">
+          <a:solidFill>
+            <a:schemeClr val="phClr"/>
+          </a:solidFill>
+          <a:prstDash val="solid"/>
+          <a:miter lim="800000"/>
+        </a:ln>
+        <a:ln w="25400" cap="flat" cmpd="sng" algn="ctr">
+          <a:solidFill>
+            <a:schemeClr val="phClr"/>
+          </a:solidFill>
+          <a:prstDash val="solid"/>
+          <a:miter lim="800000"/>
+        </a:ln>
+      </a:lnStyleLst>
+      <a:effectStyleLst>
+        <a:effectStyle>
+          <a:effectLst/>
+        </a:effectStyle>
+        <a:effectStyle>
+          <a:effectLst/>
+        </a:effectStyle>
+        <a:effectStyle>
+          <a:effectLst>
+            <a:outerShdw blurRad="57150" dist="19050" dir="5400000" algn="ctr" rotWithShape="0">
+              <a:srgbClr val="000000">
+                <a:alpha val="63000"/>
+              </a:srgbClr>
+            </a:outerShdw>
+          </a:effectLst>
+        </a:effectStyle>
+      </a:effectStyleLst>
+      <a:bgFillStyleLst>
+        <a:solidFill>
+          <a:schemeClr val="phClr"/>
+        </a:solidFill>
+        <a:solidFill>
+          <a:schemeClr val="phClr">
+            <a:tint val="95000"/>
+            <a:satMod val="170000"/>
+          </a:schemeClr>
+        </a:solidFill>
+        <a:gradFill rotWithShape="1">
+          <a:gsLst>
+            <a:gs pos="0">
+              <a:schemeClr val="phClr">
+                <a:tint val="93000"/>
+                <a:satMod val="150000"/>
+                <a:shade val="98000"/>
+                <a:lumMod val="102000"/>
+              </a:schemeClr>
+            </a:gs>
+            <a:gs pos="50000">
+              <a:schemeClr val="phClr">
+                <a:tint val="98000"/>
+                <a:satMod val="130000"/>
+                <a:shade val="90000"/>
+                <a:lumMod val="103000"/>
+              </a:schemeClr>
+            </a:gs>
+            <a:gs pos="100000">
+              <a:schemeClr val="phClr">
+                <a:shade val="63000"/>
+                <a:satMod val="120000"/>
+              </a:schemeClr>
+            </a:gs>
+          </a:gsLst>
+          <a:lin ang="5400000" scaled="0"/>
+        </a:gradFill>
+      </a:bgFillStyleLst>
+    </a:fmtScheme>
+  </a:themeElements>
+  <a:objectDefaults>
+    <a:lnDef>
+      <a:spPr/>
+      <a:bodyPr/>
+      <a:lstStyle/>
+      <a:style>
+        <a:lnRef idx="2">
+          <a:schemeClr val="accent1"/>
+        </a:lnRef>
+        <a:fillRef idx="0">
+          <a:schemeClr val="accent1"/>
+        </a:fillRef>
+        <a:effectRef idx="1">
+          <a:schemeClr val="accent1"/>
+        </a:effectRef>
+        <a:fontRef idx="minor">
+          <a:schemeClr val="tx1"/>
+        </a:fontRef>
+      </a:style>
+    </a:lnDef>
+  </a:objectDefaults>
+  <a:extraClrSchemeLst/>
+  <a:extLst>
+    <a:ext uri="{05A4C25C-085E-4340-85A3-A5531E510DB2}">
+      <thm15:themeFamily xmlns:thm15="http://schemas.microsoft.com/office/thememl/2012/main" name="Office Theme" id="{2E142A2C-CD16-42D6-873A-C26D2A0506FA}" vid="{1BDDFF52-6CD6-40A5-AB3C-68EB2F1E4D0A}"/>
+    </a:ext>
+  </a:extLst>
+</a:theme>
 </file>
</xml_diff>

<commit_message>
fix: name the bundled-offer axis for what it measures, and label the cross-sell products
The AI Score axis keyed `cross_sell` is `is_bundled_offer`, a yes/no. Calling it
"Cross-sell" on screen put a 0-or-10 flag beside `crossSellScore`, a 0-1 breadth
ratio, under one word on one panel: ING reads 10/10 on the radar and 26% in the
cross-sell tab, and both are right. The axis is now labelled "Bundled offer"; the
key and the formula are unchanged.

`insurance`, `credit_card` and `partner_perk` had no entry in FAMILY_NAMES, so
the cross-sell matrix drew its axes raw - "credit_card" sat next to
"Current-account packs", and the top-pairs list read the same way. They are not
product families, but they travel through that map because the matrix takes its
axes from `cross_sold_products`.

423 passed, 1 skipped.
</commit_message>
<xml_diff>
--- a/docs/Banking_Campaigns_Comparator.pptx
+++ b/docs/Banking_Campaigns_Comparator.pptx
@@ -10,11 +10,11 @@
   <p:sldIdLst>
     <p:sldId id="256" r:id="rId2"/>
     <p:sldId id="257" r:id="rId3"/>
-    <p:sldId id="258" r:id="rId4"/>
-    <p:sldId id="259" r:id="rId5"/>
-    <p:sldId id="260" r:id="rId6"/>
-    <p:sldId id="261" r:id="rId7"/>
-    <p:sldId id="262" r:id="rId8"/>
+    <p:sldId id="262" r:id="rId4"/>
+    <p:sldId id="258" r:id="rId5"/>
+    <p:sldId id="259" r:id="rId6"/>
+    <p:sldId id="260" r:id="rId7"/>
+    <p:sldId id="261" r:id="rId8"/>
     <p:sldId id="263" r:id="rId9"/>
     <p:sldId id="264" r:id="rId10"/>
     <p:sldId id="265" r:id="rId11"/>
@@ -563,13 +563,7 @@
           <a:p>
             <a:r>
               <a:rPr lang="en-US" dirty="0"/>
-              <a:t>Ouverture — 1 min.</a:t>
-            </a:r>
-          </a:p>
-          <a:p>
-            <a:r>
-              <a:rPr lang="en-US" dirty="0"/>
-              <a:t>"As part of the ING DACI two-week POC, we set out to answer one question: how do Belgian banks communicate similar products on the open web, and what can ING learn from it? To move away from subjective design opinions, we built a fully reproducible, end-to-end measurement pipeline across 14 banks and 104 features. First disclaimer as guardrail before we start: we have zero click, conversion or performance data. Nothing here claims a design choice caused a commercial outcome - every recommendation is an argued hypothesis worth testing. Let's walk through what the data shows."</a:t>
+              <a:t>"As part of the ING DACI two-week P of C, we set out to answer one question: how do Belgian banks communicate similar products on the open web, and what can ING learn from it?  To move away from subjective design opinions, we built a fully reproducible, end-to-end measurement pipeline across 14 banks and 104 features. First disclaimer before we start: we have no internal data, nothing here claims a design choice caused a commercial outcome — every recommendation is an argued hypothesis worth testing. </a:t>
             </a:r>
           </a:p>
         </p:txBody>
@@ -1037,48 +1031,59 @@
           <a:lstStyle/>
           <a:p>
             <a:r>
-              <a:t>What this cannot support — 60 s. Écran : onglet Analysis, le bloc 104 → 33.</a:t>
-            </a:r>
-          </a:p>
-          <a:p/>
-          <a:p>
-            <a:r>
+              <a:rPr lang="en-US" dirty="0"/>
               <a:t>"104 features in, 33 out. Every reduction is on screen.</a:t>
             </a:r>
           </a:p>
-          <a:p/>
-          <a:p>
-            <a:r>
+          <a:p>
+            <a:r>
+              <a:rPr lang="en-US" dirty="0"/>
               <a:t>And five withdrawn outright, because they measured our tooling, not your pages.</a:t>
             </a:r>
           </a:p>
-          <a:p/>
-          <a:p>
-            <a:r>
+          <a:p>
+            <a:r>
+              <a:rPr lang="en-US" dirty="0"/>
               <a:t>Calls to action: no counting rule held across fourteen banks. Navigation, repeated links, clickable cards — each bank marks them up differently.</a:t>
             </a:r>
           </a:p>
-          <a:p/>
-          <a:p>
-            <a:r>
-              <a:t>Animation: our rule asked whether the stylesheet declared an animation, not whether the page moves. Across eighteen pages, exactly one has real motion — Revolut, a video. Your kickoff deck said ING was the only traditional bank animating. That is now marked not testable, not disproved. We will not rule on it with a broken instrument.</a:t>
-            </a:r>
-          </a:p>
-          <a:p/>
-          <a:p>
-            <a:r>
-              <a:t>The fifth we found while rehearsing this: a feature that tested whether a page uses an HTML table element. Traditional banks do. N26 and Revolut build the same plan comparison in CSS. It was reporting a markup convention as a strategic difference.</a:t>
-            </a:r>
-          </a:p>
-          <a:p/>
-          <a:p>
-            <a:r>
+          <a:p>
+            <a:r>
+              <a:rPr lang="en-US" dirty="0"/>
+              <a:t>Animation: our rule asked whether the stylesheet declared an animation, not whether the page moves. Across eighteen pages, exactly one has real motion — </a:t>
+            </a:r>
+            <a:r>
+              <a:rPr lang="en-US" dirty="0" err="1"/>
+              <a:t>Revolut</a:t>
+            </a:r>
+            <a:r>
+              <a:rPr lang="en-US" dirty="0"/>
+              <a:t>, a video. Your kickoff deck said ING was the only traditional bank animating. That is now marked not testable, not disproved. We will not rule on it with a broken instrument.</a:t>
+            </a:r>
+          </a:p>
+          <a:p>
+            <a:r>
+              <a:rPr lang="en-US" dirty="0"/>
+              <a:t>The fifth we found while rehearsing this: a feature that tested whether a page uses an HTML table element. Traditional banks do. N26 and </a:t>
+            </a:r>
+            <a:r>
+              <a:rPr lang="en-US" dirty="0" err="1"/>
+              <a:t>Revolut</a:t>
+            </a:r>
+            <a:r>
+              <a:rPr lang="en-US" dirty="0"/>
+              <a:t> build the same plan comparison in CSS. It was reporting a markup convention as a strategic difference.</a:t>
+            </a:r>
+          </a:p>
+          <a:p>
+            <a:r>
+              <a:rPr lang="en-US" dirty="0"/>
               <a:t>And one whole axis of our AI Score returns nothing.</a:t>
             </a:r>
           </a:p>
-          <a:p/>
-          <a:p>
-            <a:r>
+          <a:p>
+            <a:r>
+              <a:rPr lang="en-US" dirty="0"/>
               <a:t>We would rather hand you 33 numbers we can defend."</a:t>
             </a:r>
           </a:p>
@@ -1137,26 +1142,36 @@
           <a:lstStyle/>
           <a:p>
             <a:r>
-              <a:t>Clôture — 30 s. Écran : onglet Recommendations.</a:t>
-            </a:r>
-          </a:p>
-          <a:p/>
-          <a:p>
-            <a:r>
+              <a:rPr lang="en-US" dirty="0"/>
               <a:t>"What you keep is an instrument: 104 documented features, a frozen contract, a pipeline that re-runs from stored snapshots, 423 tests. The next comparison costs days, not weeks — including next September's state-bond wave.</a:t>
             </a:r>
           </a:p>
-          <a:p/>
-          <a:p>
-            <a:r>
-              <a:t>Ten prioritised changes came out of this run, each traced to a feature and a page. None is a performance claim — no click data exists, so each is a hypothesis you can test.</a:t>
-            </a:r>
-          </a:p>
-          <a:p/>
-          <a:p>
-            <a:r>
+          <a:p>
+            <a:endParaRPr lang="en-US" dirty="0"/>
+          </a:p>
+          <a:p>
+            <a:r>
+              <a:rPr lang="en-US" dirty="0"/>
+              <a:t>Ten </a:t>
+            </a:r>
+            <a:r>
+              <a:rPr lang="en-US" dirty="0" err="1"/>
+              <a:t>prioritised</a:t>
+            </a:r>
+            <a:r>
+              <a:rPr lang="en-US" dirty="0"/>
+              <a:t> changes came out of this run, each traced to a feature and a page. None is a performance claim — no click data exists, so each is a hypothesis you can test.</a:t>
+            </a:r>
+          </a:p>
+          <a:p>
+            <a:endParaRPr lang="en-US" dirty="0"/>
+          </a:p>
+          <a:p>
+            <a:r>
+              <a:rPr lang="en-US" dirty="0"/>
               <a:t>It is a proof of concept. Your questions are the useful part."</a:t>
             </a:r>
+            <a:endParaRPr dirty="0"/>
           </a:p>
         </p:txBody>
       </p:sp>
@@ -1214,18 +1229,60 @@
           <a:p>
             <a:r>
               <a:rPr lang="en-US" dirty="0"/>
-              <a:t>What we built - 45 s.</a:t>
-            </a:r>
+              <a:t>"Three things frame this.</a:t>
+            </a:r>
+          </a:p>
+          <a:p>
+            <a:endParaRPr lang="en-US" dirty="0"/>
           </a:p>
           <a:p>
             <a:r>
               <a:rPr lang="en-US" dirty="0"/>
-              <a:t>"One pipeline, one frozen contract, no second definition of any number: 51 pages, 14 banks, 6 product families. Automatic extraction where a machine can measure it, a human rubric where it's genuinely a judgement call, one web UI tying the two together. 420 automated tests guard it."</a:t>
+              <a:t>ING is a hybrid. You carry the direct, feature-first, mobile-first tone of a neobank, and the institutional weight of a Tier-1 bank. That is a position, not an accident.</a:t>
+            </a:r>
+          </a:p>
+          <a:p>
+            <a:endParaRPr lang="en-US" dirty="0"/>
+          </a:p>
+          <a:p>
+            <a:r>
+              <a:rPr lang="en-US" dirty="0"/>
+              <a:t>The playing field is level on regulation. Neobanks' speed is architecture and no branches — not lighter European or compliance rules.</a:t>
+            </a:r>
+          </a:p>
+          <a:p>
+            <a:endParaRPr lang="en-US" dirty="0"/>
+          </a:p>
+          <a:p>
+            <a:r>
+              <a:rPr lang="en-US" dirty="0"/>
+              <a:t>Where you differ is the engine. Traditional banks use the current account as a loss leader and </a:t>
+            </a:r>
+            <a:r>
+              <a:rPr lang="en-US" dirty="0" err="1"/>
+              <a:t>monetise</a:t>
+            </a:r>
+            <a:r>
+              <a:rPr lang="en-US" dirty="0"/>
+              <a:t> later: mortgages, insurance, wealth. Neobanks </a:t>
+            </a:r>
+            <a:r>
+              <a:rPr lang="en-US" dirty="0" err="1"/>
+              <a:t>monetise</a:t>
+            </a:r>
+            <a:r>
+              <a:rPr lang="en-US" dirty="0"/>
+              <a:t> upfront — freemium tiers, subscriptions, abonnements, FX. They chase volume among young adults and digital nomads. You chase lifetime value: expats, first-time investors, first-time buyers."</a:t>
             </a:r>
           </a:p>
         </p:txBody>
       </p:sp>
     </p:spTree>
+    <p:extLst>
+      <p:ext uri="{BB962C8B-B14F-4D97-AF65-F5344CB8AC3E}">
+        <p14:creationId xmlns:p14="http://schemas.microsoft.com/office/powerpoint/2010/main" val="559537629"/>
+      </p:ext>
+    </p:extLst>
   </p:cSld>
   <p:clrMapOvr>
     <a:masterClrMapping/>
@@ -1277,16 +1334,7 @@
           <a:bodyPr/>
           <a:lstStyle/>
           <a:p>
-            <a:r>
-              <a:rPr lang="en-US" dirty="0"/>
-              <a:t>The pipeline - 30 s.</a:t>
-            </a:r>
-          </a:p>
-          <a:p>
-            <a:r>
-              <a:rPr lang="en-US" dirty="0"/>
-              <a:t>"Five stages: collect under a compliance gate, extract, derive, score, analyse. Every stage writes to the same frozen feature contract, so no number has a second definition anywhere in the chain."</a:t>
-            </a:r>
+            <a:endParaRPr lang="en-US" dirty="0"/>
           </a:p>
         </p:txBody>
       </p:sp>
@@ -1343,25 +1391,8 @@
           <a:lstStyle/>
           <a:p>
             <a:r>
-              <a:t>Dataset — 30 s. Écran : cette slide, puis bascule sur l'onglet Data.</a:t>
-            </a:r>
-          </a:p>
-          <a:p/>
-          <a:p>
-            <a:r>
-              <a:t>"So the question is whether that hybrid position shows up in how you actually communicate.</a:t>
-            </a:r>
-          </a:p>
-          <a:p/>
-          <a:p>
-            <a:r>
-              <a:t>51 pages, 14 banks, 6 product families, 104 documented features. We only ever compare within one product family — pages do different jobs. The headline runs on 18 current-account pages, 14 banks.</a:t>
-            </a:r>
-          </a:p>
-          <a:p/>
-          <a:p>
-            <a:r>
-              <a:t>Deciding what was relevant was part of the work."</a:t>
+              <a:rPr lang="en-US" dirty="0"/>
+              <a:t>"Five stages: collect under a compliance gate, extract, derive, score, analyse. Every stage writes to the same frozen feature contract, so no number has a second definition anywhere in the chain."</a:t>
             </a:r>
           </a:p>
         </p:txBody>
@@ -1418,28 +1449,26 @@
           <a:bodyPr/>
           <a:lstStyle/>
           <a:p>
+            <a:endParaRPr lang="en-US" dirty="0"/>
+          </a:p>
+          <a:p>
             <a:r>
               <a:rPr lang="en-US" dirty="0"/>
-              <a:t>Rubric scoring - 1 min 15.</a:t>
+              <a:t>"So the question is whether that hybrid position shows up in how you actually communicate.</a:t>
             </a:r>
           </a:p>
           <a:p>
             <a:r>
               <a:rPr lang="en-US" dirty="0"/>
-              <a:t>"13 features are judgements, not measurements - clarity of the offer, layout, persuasion technique. Only one human judge for this pass, and I say so plainly rather than dressing a single opinion up as a consensus.</a:t>
+              <a:t>51 pages, 14 banks, 6 product families, 104 documented features. We only ever compare within one product family — pages do different jobs. The headline runs on 18 current-account pages, 14 banks.</a:t>
             </a:r>
           </a:p>
           <a:p>
             <a:r>
               <a:rPr lang="en-US" dirty="0"/>
-              <a:t>We also have a model sheet, written to its own file and never into a human one. But it is not a second opinion, because our pinned model reads text; it has no vision. And 12 of our 13 judged features are defined in the dictionary as judged from the screenshot. Only one - formality - can honestly be scored from text, and there the model lands within one point of the human seventy-three percent of the time. On the 12 visual ones, its answers are confident answers to a question the text cannot always settle: on value proposition clarity it ranked the pages close to the opposite of the human.</a:t>
-            </a:r>
-          </a:p>
-          <a:p>
-            <a:r>
-              <a:rPr lang="en-US" dirty="0"/>
-              <a:t>So we keep it as a reference and we do not average it in. That's the difference between using a model and trusting it."</a:t>
-            </a:r>
+              <a:t>Deciding what was relevant was part of the work."</a:t>
+            </a:r>
+            <a:endParaRPr dirty="0"/>
           </a:p>
         </p:txBody>
       </p:sp>
@@ -1495,33 +1524,7 @@
           <a:bodyPr/>
           <a:lstStyle/>
           <a:p>
-            <a:r>
-              <a:t>Strategic context — 50 s. Écran : cette slide. Tu les regardes, pas l'écran.</a:t>
-            </a:r>
-          </a:p>
-          <a:p/>
-          <a:p>
-            <a:r>
-              <a:t>"Three things frame this.</a:t>
-            </a:r>
-          </a:p>
-          <a:p/>
-          <a:p>
-            <a:r>
-              <a:t>ING is a hybrid. You carry the direct, feature-first, mobile-first tone of a neobank, and the institutional weight of a Tier-1 bank. That is a position, not an accident.</a:t>
-            </a:r>
-          </a:p>
-          <a:p/>
-          <a:p>
-            <a:r>
-              <a:t>The playing field is level on regulation. Neobanks' speed is architecture and no branches — not lighter European or compliance rules.</a:t>
-            </a:r>
-          </a:p>
-          <a:p/>
-          <a:p>
-            <a:r>
-              <a:t>Where you differ is the engine. Traditional banks use the current account as a loss leader and monetise later: mortgages, insurance, wealth. Neobanks monetise upfront — freemium tiers, subscriptions, "abonnements", FX. They chase volume among young adults and digital nomads. You chase lifetime value: expats, first-time investors, first-time buyers."</a:t>
-            </a:r>
+            <a:endParaRPr lang="en-US" dirty="0"/>
           </a:p>
         </p:txBody>
       </p:sp>
@@ -1578,37 +1581,61 @@
           <a:lstStyle/>
           <a:p>
             <a:r>
-              <a:t>What the analysis found — 70 s. Écran : onglet Home, le radar puis l'axe.</a:t>
-            </a:r>
-          </a:p>
-          <a:p/>
-          <a:p>
-            <a:r>
-              <a:t>"On the traditional–challenger axis ING scores 0.41. Belfius sits at 0.28 below you, Keytrade at 0.55 above — and Keytrade is a challenger. You are the last incumbent on the axis before the challengers begin: the most challenger-like traditional bank in Belgium. The hybrid is not a claim, it is a position on a line.</a:t>
-            </a:r>
-          </a:p>
-          <a:p/>
-          <a:p>
-            <a:r>
+              <a:rPr lang="en-US" dirty="0"/>
+              <a:t>On the traditional–challenger axis ING scores 0.41. Belfius sits at 0.28 below you, </a:t>
+            </a:r>
+            <a:r>
+              <a:rPr lang="en-US" dirty="0" err="1"/>
+              <a:t>Keytrade</a:t>
+            </a:r>
+            <a:r>
+              <a:rPr lang="en-US" dirty="0"/>
+              <a:t> at 0.55 above — and </a:t>
+            </a:r>
+            <a:r>
+              <a:rPr lang="en-US" dirty="0" err="1"/>
+              <a:t>Keytrade</a:t>
+            </a:r>
+            <a:r>
+              <a:rPr lang="en-US" dirty="0"/>
+              <a:t> is a challenger. You are the last incumbent on the axis before the challengers begin: the most challenger-like traditional bank in Belgium. The hybrid is not a claim, it is a position on a line.</a:t>
+            </a:r>
+          </a:p>
+          <a:p>
+            <a:r>
+              <a:rPr lang="en-US" dirty="0"/>
               <a:t>Your targeting shows too. The personas named on your pack pages are mass market, student and expat. Across your whole page set, six of eight, including investor and retiree. The high-value segments are there in the copy.</a:t>
             </a:r>
           </a:p>
-          <a:p/>
-          <a:p>
-            <a:r>
-              <a:t>But three signals separate you from everyone, and all three are pressure. Deadline language, the largest gap in the set. Persuasion levers. And the offer reads as clearly worth having.</a:t>
-            </a:r>
-          </a:p>
-          <a:p/>
-          <a:p>
-            <a:r>
-              <a:t>On the pages we measured, you are the loudest bank in Belgium. Next to a top-five NPS irritator, that's the finding."</a:t>
-            </a:r>
-          </a:p>
-          <a:p/>
-          <a:p>
-            <a:r>
-              <a:t>SI LE RADAR EST À L'ÉCRAN, la ligne à dire : "Trust reads zero for thirteen banks of fourteen. That is measured, not missing — not one page in this family cites a branch network as a benefit, and the only two carrying an institutional or regulatory trust signal are Revolut's and bunq's. Both challengers. The asset a Tier-1 bank has and a neobank cannot copy is the one nobody is using on the page."</a:t>
+          <a:p>
+            <a:r>
+              <a:rPr lang="en-US" dirty="0"/>
+              <a:t>But three signals separate you from everyone, and all three are pressure. Deadline language, the largest gap in the set. Persuasion levers. And the offer reads as clearly worth having. On the pages we measured, you are the loudest bank in Belgium. Next to a top-five NPS irritator, that's the finding."</a:t>
+            </a:r>
+          </a:p>
+          <a:p>
+            <a:endParaRPr lang="en-US" dirty="0"/>
+          </a:p>
+          <a:p>
+            <a:r>
+              <a:rPr lang="en-US" dirty="0"/>
+              <a:t>"Trust reads zero for thirteen banks of fourteen. That is measured, not missing — not one page in this family cites a branch network as a benefit, and the only two carrying an institutional or regulatory trust signal are </a:t>
+            </a:r>
+            <a:r>
+              <a:rPr lang="en-US" dirty="0" err="1"/>
+              <a:t>Revolut's</a:t>
+            </a:r>
+            <a:r>
+              <a:rPr lang="en-US" dirty="0"/>
+              <a:t> and </a:t>
+            </a:r>
+            <a:r>
+              <a:rPr lang="en-US" dirty="0" err="1"/>
+              <a:t>bunq's</a:t>
+            </a:r>
+            <a:r>
+              <a:rPr lang="en-US" dirty="0"/>
+              <a:t>. Both challengers. The asset a Tier-1 bank has and a neobank cannot copy is the one nobody is using on the page."</a:t>
             </a:r>
           </a:p>
         </p:txBody>
@@ -11396,7 +11423,10 @@
         </p:spPr>
         <p:txBody>
           <a:bodyPr/>
-          <a:p/>
+          <a:lstStyle/>
+          <a:p>
+            <a:endParaRPr/>
+          </a:p>
         </p:txBody>
       </p:sp>
       <p:sp>
@@ -11503,7 +11533,10 @@
         </p:spPr>
         <p:txBody>
           <a:bodyPr/>
-          <a:p/>
+          <a:lstStyle/>
+          <a:p>
+            <a:endParaRPr/>
+          </a:p>
         </p:txBody>
       </p:sp>
       <p:pic>
@@ -11912,7 +11945,10 @@
         </p:spPr>
         <p:txBody>
           <a:bodyPr/>
-          <a:p/>
+          <a:lstStyle/>
+          <a:p>
+            <a:endParaRPr/>
+          </a:p>
         </p:txBody>
       </p:sp>
       <p:sp>
@@ -12055,7 +12091,10 @@
         </p:spPr>
         <p:txBody>
           <a:bodyPr/>
-          <a:p/>
+          <a:lstStyle/>
+          <a:p>
+            <a:endParaRPr/>
+          </a:p>
         </p:txBody>
       </p:sp>
       <p:sp>
@@ -12162,7 +12201,10 @@
         </p:spPr>
         <p:txBody>
           <a:bodyPr/>
-          <a:p/>
+          <a:lstStyle/>
+          <a:p>
+            <a:endParaRPr/>
+          </a:p>
         </p:txBody>
       </p:sp>
       <p:pic>
@@ -12641,7 +12683,10 @@
         </p:spPr>
         <p:txBody>
           <a:bodyPr/>
-          <a:p/>
+          <a:lstStyle/>
+          <a:p>
+            <a:endParaRPr/>
+          </a:p>
         </p:txBody>
       </p:sp>
       <p:sp>
@@ -12750,7 +12795,10 @@
         </p:spPr>
         <p:txBody>
           <a:bodyPr/>
-          <a:p/>
+          <a:lstStyle/>
+          <a:p>
+            <a:endParaRPr/>
+          </a:p>
         </p:txBody>
       </p:sp>
       <p:sp>
@@ -12901,7 +12949,10 @@
         </p:spPr>
         <p:txBody>
           <a:bodyPr/>
-          <a:p/>
+          <a:lstStyle/>
+          <a:p>
+            <a:endParaRPr/>
+          </a:p>
         </p:txBody>
       </p:sp>
       <p:sp>
@@ -13052,7 +13103,10 @@
         </p:spPr>
         <p:txBody>
           <a:bodyPr/>
-          <a:p/>
+          <a:lstStyle/>
+          <a:p>
+            <a:endParaRPr/>
+          </a:p>
         </p:txBody>
       </p:sp>
       <p:sp>
@@ -13240,7 +13294,10 @@
         </p:spPr>
         <p:txBody>
           <a:bodyPr/>
-          <a:p/>
+          <a:lstStyle/>
+          <a:p>
+            <a:endParaRPr/>
+          </a:p>
         </p:txBody>
       </p:sp>
       <p:sp>
@@ -13347,7 +13404,10 @@
         </p:spPr>
         <p:txBody>
           <a:bodyPr/>
-          <a:p/>
+          <a:lstStyle/>
+          <a:p>
+            <a:endParaRPr/>
+          </a:p>
         </p:txBody>
       </p:sp>
       <p:sp>
@@ -13454,7 +13514,10 @@
         </p:spPr>
         <p:txBody>
           <a:bodyPr/>
-          <a:p/>
+          <a:lstStyle/>
+          <a:p>
+            <a:endParaRPr/>
+          </a:p>
         </p:txBody>
       </p:sp>
       <p:sp>
@@ -13675,7 +13738,10 @@
         </p:spPr>
         <p:txBody>
           <a:bodyPr/>
-          <a:p/>
+          <a:lstStyle/>
+          <a:p>
+            <a:endParaRPr/>
+          </a:p>
         </p:txBody>
       </p:sp>
       <p:sp>
@@ -13782,7 +13848,10 @@
         </p:spPr>
         <p:txBody>
           <a:bodyPr/>
-          <a:p/>
+          <a:lstStyle/>
+          <a:p>
+            <a:endParaRPr/>
+          </a:p>
         </p:txBody>
       </p:sp>
       <p:pic>
@@ -13835,7 +13904,10 @@
         </p:spPr>
         <p:txBody>
           <a:bodyPr/>
-          <a:p/>
+          <a:lstStyle/>
+          <a:p>
+            <a:endParaRPr/>
+          </a:p>
         </p:txBody>
       </p:sp>
       <p:pic>
@@ -14356,7 +14428,10 @@
         </p:spPr>
         <p:txBody>
           <a:bodyPr/>
-          <a:p/>
+          <a:lstStyle/>
+          <a:p>
+            <a:endParaRPr/>
+          </a:p>
         </p:txBody>
       </p:sp>
       <p:sp>
@@ -18487,7 +18562,7 @@
                 </a:solidFill>
                 <a:latin typeface="Helvetica Neue"/>
               </a:rPr>
-              <a:t>What we built, end to end</a:t>
+              <a:t>Strategic context and positioning</a:t>
             </a:r>
           </a:p>
         </p:txBody>
@@ -18546,7 +18621,7 @@
         <p:spPr>
           <a:xfrm>
             <a:off x="685800" y="1463040"/>
-            <a:ext cx="10881360" cy="4754880"/>
+            <a:ext cx="10881360" cy="3821367"/>
           </a:xfrm>
           <a:prstGeom prst="rect">
             <a:avLst/>
@@ -18564,254 +18639,250 @@
                 <a:spcPct val="105000"/>
               </a:lnSpc>
               <a:spcAft>
-                <a:spcPts val="900"/>
-              </a:spcAft>
-            </a:pPr>
-            <a:r>
-              <a:rPr sz="1500" b="0" dirty="0">
+                <a:spcPts val="200"/>
+              </a:spcAft>
+            </a:pPr>
+            <a:r>
+              <a:rPr sz="1500" b="1" dirty="0">
                 <a:solidFill>
                   <a:srgbClr val="14141C"/>
                 </a:solidFill>
                 <a:latin typeface="Helvetica Neue"/>
               </a:rPr>
-              <a:t>•  A measurement pipeline: 14 banks, 51 pages across 6 product families (18 of them current-account), 104 declared features, one frozen contract.</a:t>
-            </a:r>
-          </a:p>
-          <a:p>
-            <a:pPr algn="l">
-              <a:lnSpc>
-                <a:spcPct val="105000"/>
-              </a:lnSpc>
-              <a:spcAft>
-                <a:spcPts val="900"/>
-              </a:spcAft>
-            </a:pPr>
-            <a:r>
-              <a:rPr sz="1500" b="0" dirty="0">
+              <a:t>•  The hybrid model</a:t>
+            </a:r>
+          </a:p>
+          <a:p>
+            <a:pPr algn="l">
+              <a:lnSpc>
+                <a:spcPct val="105000"/>
+              </a:lnSpc>
+              <a:spcAft>
+                <a:spcPts val="1000"/>
+              </a:spcAft>
+            </a:pPr>
+            <a:r>
+              <a:rPr sz="1300" b="0" dirty="0">
+                <a:solidFill>
+                  <a:srgbClr val="585868"/>
+                </a:solidFill>
+                <a:latin typeface="Helvetica Neue"/>
+              </a:rPr>
+              <a:t>     ING blends the direct, feature-focused, mobile-first tone of a neobank with the institutional weight of a Tier-1 retail bank — regulatory authority and an established brand. </a:t>
+            </a:r>
+          </a:p>
+          <a:p>
+            <a:pPr algn="l">
+              <a:lnSpc>
+                <a:spcPct val="105000"/>
+              </a:lnSpc>
+              <a:spcAft>
+                <a:spcPts val="200"/>
+              </a:spcAft>
+            </a:pPr>
+            <a:r>
+              <a:rPr sz="1500" b="1" dirty="0">
                 <a:solidFill>
                   <a:srgbClr val="14141C"/>
                 </a:solidFill>
                 <a:latin typeface="Helvetica Neue"/>
               </a:rPr>
-              <a:t>•  A scoring workflow: automatic extraction, model-assisted extraction, and a human rubric for the 13 judgement features.</a:t>
-            </a:r>
-          </a:p>
-          <a:p>
-            <a:pPr algn="l">
-              <a:lnSpc>
-                <a:spcPct val="105000"/>
-              </a:lnSpc>
-              <a:spcAft>
-                <a:spcPts val="900"/>
-              </a:spcAft>
-            </a:pPr>
-            <a:r>
-              <a:rPr sz="1500" b="0" dirty="0">
+              <a:t>•  A level playing field on regulation</a:t>
+            </a:r>
+          </a:p>
+          <a:p>
+            <a:pPr algn="l">
+              <a:lnSpc>
+                <a:spcPct val="105000"/>
+              </a:lnSpc>
+              <a:spcAft>
+                <a:spcPts val="1000"/>
+              </a:spcAft>
+            </a:pPr>
+            <a:r>
+              <a:rPr sz="1300" b="0" dirty="0">
+                <a:solidFill>
+                  <a:srgbClr val="585868"/>
+                </a:solidFill>
+                <a:latin typeface="Helvetica Neue"/>
+              </a:rPr>
+              <a:t>     Neobanks like Revolut hold the same European banking licenses and face the same Belgian compliance checks — including the mandatory CCP credit-registry query for consumer lending. Their speed comes from modern architecture, no branch network, and faster decision loops — not lighter rules.</a:t>
+            </a:r>
+          </a:p>
+          <a:p>
+            <a:pPr algn="l">
+              <a:lnSpc>
+                <a:spcPct val="105000"/>
+              </a:lnSpc>
+              <a:spcAft>
+                <a:spcPts val="200"/>
+              </a:spcAft>
+            </a:pPr>
+            <a:r>
+              <a:rPr sz="1500" b="1" dirty="0">
                 <a:solidFill>
                   <a:srgbClr val="14141C"/>
                 </a:solidFill>
                 <a:latin typeface="Helvetica Neue"/>
               </a:rPr>
-              <a:t>•  An analysis library: positioning, similarity, category comparison, AI score, cross-sell, plus generated limitations.</a:t>
-            </a:r>
-          </a:p>
-          <a:p>
-            <a:pPr algn="l">
-              <a:lnSpc>
-                <a:spcPct val="105000"/>
-              </a:lnSpc>
-              <a:spcAft>
-                <a:spcPts val="900"/>
-              </a:spcAft>
-            </a:pPr>
-            <a:r>
-              <a:rPr sz="1500" b="0" dirty="0">
+              <a:t>•  Different monetization engines</a:t>
+            </a:r>
+          </a:p>
+          <a:p>
+            <a:pPr algn="l">
+              <a:lnSpc>
+                <a:spcPct val="105000"/>
+              </a:lnSpc>
+              <a:spcAft>
+                <a:spcPts val="1000"/>
+              </a:spcAft>
+            </a:pPr>
+            <a:r>
+              <a:rPr sz="1300" b="0" dirty="0">
+                <a:solidFill>
+                  <a:srgbClr val="585868"/>
+                </a:solidFill>
+                <a:latin typeface="Helvetica Neue"/>
+              </a:rPr>
+              <a:t>     Traditional banks have long used the basic current account as a loss leader — a produit d'appel — to acquire clients and monetize later through mortgages, insurance and wealth management. Neobanks flip that: transparent freemium tiers, paid subscriptions, and transactional FX / fee income, upfront.</a:t>
+            </a:r>
+          </a:p>
+          <a:p>
+            <a:pPr algn="l">
+              <a:lnSpc>
+                <a:spcPct val="105000"/>
+              </a:lnSpc>
+              <a:spcAft>
+                <a:spcPts val="200"/>
+              </a:spcAft>
+            </a:pPr>
+            <a:r>
+              <a:rPr sz="1500" b="1" dirty="0">
                 <a:solidFill>
                   <a:srgbClr val="14141C"/>
                 </a:solidFill>
                 <a:latin typeface="Helvetica Neue"/>
               </a:rPr>
-              <a:t>•  One web UI with ten tabs: four business views (Analysis, Trends, Reputation, Recommendations), the generated-site builder, and six read-only operator views carried over from the </a:t>
-            </a:r>
-            <a:r>
-              <a:rPr sz="1500" b="0" dirty="0" err="1">
-                <a:solidFill>
-                  <a:srgbClr val="14141C"/>
-                </a:solidFill>
-                <a:latin typeface="Helvetica Neue"/>
-              </a:rPr>
-              <a:t>Streamlit</a:t>
-            </a:r>
-            <a:r>
-              <a:rPr sz="1500" b="0" dirty="0">
-                <a:solidFill>
-                  <a:srgbClr val="14141C"/>
-                </a:solidFill>
-                <a:latin typeface="Helvetica Neue"/>
-              </a:rPr>
-              <a:t> dashboard.</a:t>
-            </a:r>
-          </a:p>
-          <a:p>
-            <a:pPr algn="l">
-              <a:lnSpc>
-                <a:spcPct val="105000"/>
-              </a:lnSpc>
-              <a:spcAft>
-                <a:spcPts val="900"/>
-              </a:spcAft>
-            </a:pPr>
-            <a:r>
-              <a:rPr sz="1500" b="0" dirty="0">
-                <a:solidFill>
-                  <a:srgbClr val="14141C"/>
-                </a:solidFill>
-                <a:latin typeface="Helvetica Neue"/>
-              </a:rPr>
-              <a:t>•  Two optional signals, both fenced off from the performance claim: search interest, and news themes.</a:t>
-            </a:r>
-          </a:p>
-          <a:p>
-            <a:pPr algn="l">
-              <a:lnSpc>
-                <a:spcPct val="105000"/>
-              </a:lnSpc>
-              <a:spcAft>
-                <a:spcPts val="900"/>
-              </a:spcAft>
-            </a:pPr>
-            <a:r>
-              <a:rPr sz="1500" b="0" dirty="0">
-                <a:solidFill>
-                  <a:srgbClr val="14141C"/>
-                </a:solidFill>
-                <a:latin typeface="Helvetica Neue"/>
-              </a:rPr>
-              <a:t>•  A generated ING website: ten pages built from the selected recommendations — an illustration of what a recommendation means in practice, not a proposal for ING's own site.</a:t>
-            </a:r>
-          </a:p>
-          <a:p>
-            <a:pPr algn="l">
-              <a:lnSpc>
-                <a:spcPct val="105000"/>
-              </a:lnSpc>
-              <a:spcAft>
-                <a:spcPts val="200"/>
-              </a:spcAft>
-            </a:pPr>
-            <a:endParaRPr sz="1500" b="0" dirty="0">
+              <a:t>•  Who each side is chasing</a:t>
+            </a:r>
+          </a:p>
+          <a:p>
+            <a:pPr algn="l">
+              <a:lnSpc>
+                <a:spcPct val="105000"/>
+              </a:lnSpc>
+              <a:spcAft>
+                <a:spcPts val="0"/>
+              </a:spcAft>
+            </a:pPr>
+            <a:r>
+              <a:rPr sz="1300" b="0" dirty="0">
+                <a:solidFill>
+                  <a:srgbClr val="585868"/>
+                </a:solidFill>
+                <a:latin typeface="Helvetica Neue"/>
+              </a:rPr>
+              <a:t>     Neobanks win volume among young adults, digital nomads and casual spenders. ING's acquisition budget targets high lifetime-value segments instead: first-time investors, expats and high-net-worth individuals, and first-time buyers in mortgage and real estate. Professional and business banking is out of scope for this comparison — retail only.</a:t>
+            </a:r>
+          </a:p>
+        </p:txBody>
+      </p:sp>
+      <p:sp>
+        <p:nvSpPr>
+          <p:cNvPr id="5" name="TextBox 4"/>
+          <p:cNvSpPr txBox="1"/>
+          <p:nvPr/>
+        </p:nvSpPr>
+        <p:spPr>
+          <a:xfrm>
+            <a:off x="548640" y="6400800"/>
+            <a:ext cx="8229600" cy="274320"/>
+          </a:xfrm>
+          <a:prstGeom prst="rect">
+            <a:avLst/>
+          </a:prstGeom>
+          <a:noFill/>
+        </p:spPr>
+        <p:txBody>
+          <a:bodyPr wrap="square">
+            <a:spAutoFit/>
+          </a:bodyPr>
+          <a:lstStyle/>
+          <a:p>
+            <a:pPr algn="l">
+              <a:lnSpc>
+                <a:spcPct val="105000"/>
+              </a:lnSpc>
+              <a:spcAft>
+                <a:spcPts val="600"/>
+              </a:spcAft>
+            </a:pPr>
+            <a:r>
+              <a:rPr sz="1000" b="0">
+                <a:solidFill>
+                  <a:srgbClr val="585868"/>
+                </a:solidFill>
+                <a:latin typeface="Helvetica Neue"/>
+              </a:rPr>
+              <a:t>Banking Campaigns Comparator · ING DACI / Customer AI · September 2026</a:t>
+            </a:r>
+          </a:p>
+        </p:txBody>
+      </p:sp>
+      <p:sp>
+        <p:nvSpPr>
+          <p:cNvPr id="6" name="TextBox 5"/>
+          <p:cNvSpPr txBox="1"/>
+          <p:nvPr/>
+        </p:nvSpPr>
+        <p:spPr>
+          <a:xfrm>
+            <a:off x="11094415" y="6400800"/>
+            <a:ext cx="548640" cy="242695"/>
+          </a:xfrm>
+          <a:prstGeom prst="rect">
+            <a:avLst/>
+          </a:prstGeom>
+          <a:noFill/>
+        </p:spPr>
+        <p:txBody>
+          <a:bodyPr wrap="square">
+            <a:spAutoFit/>
+          </a:bodyPr>
+          <a:lstStyle/>
+          <a:p>
+            <a:pPr algn="r">
+              <a:lnSpc>
+                <a:spcPct val="105000"/>
+              </a:lnSpc>
+              <a:spcAft>
+                <a:spcPts val="600"/>
+              </a:spcAft>
+            </a:pPr>
+            <a:r>
+              <a:rPr lang="fr-FR" sz="1000" b="0" dirty="0">
+                <a:solidFill>
+                  <a:srgbClr val="585868"/>
+                </a:solidFill>
+                <a:latin typeface="Helvetica Neue"/>
+              </a:rPr>
+              <a:t>3</a:t>
+            </a:r>
+            <a:endParaRPr sz="1000" b="0" dirty="0">
               <a:solidFill>
-                <a:srgbClr val="14141C"/>
+                <a:srgbClr val="585868"/>
               </a:solidFill>
               <a:latin typeface="Helvetica Neue"/>
             </a:endParaRPr>
           </a:p>
-          <a:p>
-            <a:pPr algn="l">
-              <a:lnSpc>
-                <a:spcPct val="105000"/>
-              </a:lnSpc>
-              <a:spcAft>
-                <a:spcPts val="0"/>
-              </a:spcAft>
-            </a:pPr>
-            <a:r>
-              <a:rPr sz="1250" b="0" dirty="0">
-                <a:solidFill>
-                  <a:srgbClr val="585868"/>
-                </a:solidFill>
-                <a:latin typeface="Helvetica Neue"/>
-              </a:rPr>
-              <a:t>Each of those pieces is the next few slides; the pipeline diagram overleaf is the map.</a:t>
-            </a:r>
-          </a:p>
-        </p:txBody>
-      </p:sp>
-      <p:sp>
-        <p:nvSpPr>
-          <p:cNvPr id="5" name="TextBox 4"/>
-          <p:cNvSpPr txBox="1"/>
-          <p:nvPr/>
-        </p:nvSpPr>
-        <p:spPr>
-          <a:xfrm>
-            <a:off x="548640" y="6400800"/>
-            <a:ext cx="8229600" cy="274320"/>
-          </a:xfrm>
-          <a:prstGeom prst="rect">
-            <a:avLst/>
-          </a:prstGeom>
-          <a:noFill/>
-        </p:spPr>
-        <p:txBody>
-          <a:bodyPr wrap="square">
-            <a:spAutoFit/>
-          </a:bodyPr>
-          <a:lstStyle/>
-          <a:p>
-            <a:pPr algn="l">
-              <a:lnSpc>
-                <a:spcPct val="105000"/>
-              </a:lnSpc>
-              <a:spcAft>
-                <a:spcPts val="600"/>
-              </a:spcAft>
-            </a:pPr>
-            <a:r>
-              <a:rPr sz="1000" b="0">
-                <a:solidFill>
-                  <a:srgbClr val="585868"/>
-                </a:solidFill>
-                <a:latin typeface="Helvetica Neue"/>
-              </a:rPr>
-              <a:t>Banking Campaigns Comparator · ING DACI / Customer AI · September 2026</a:t>
-            </a:r>
-          </a:p>
-        </p:txBody>
-      </p:sp>
-      <p:sp>
-        <p:nvSpPr>
-          <p:cNvPr id="6" name="TextBox 5"/>
-          <p:cNvSpPr txBox="1"/>
-          <p:nvPr/>
-        </p:nvSpPr>
-        <p:spPr>
-          <a:xfrm>
-            <a:off x="11094415" y="6400800"/>
-            <a:ext cx="548640" cy="274320"/>
-          </a:xfrm>
-          <a:prstGeom prst="rect">
-            <a:avLst/>
-          </a:prstGeom>
-          <a:noFill/>
-        </p:spPr>
-        <p:txBody>
-          <a:bodyPr wrap="square">
-            <a:spAutoFit/>
-          </a:bodyPr>
-          <a:lstStyle/>
-          <a:p>
-            <a:pPr algn="r">
-              <a:lnSpc>
-                <a:spcPct val="105000"/>
-              </a:lnSpc>
-              <a:spcAft>
-                <a:spcPts val="600"/>
-              </a:spcAft>
-            </a:pPr>
-            <a:r>
-              <a:rPr sz="1000" b="0">
-                <a:solidFill>
-                  <a:srgbClr val="585868"/>
-                </a:solidFill>
-                <a:latin typeface="Helvetica Neue"/>
-              </a:rPr>
-              <a:t>3</a:t>
-            </a:r>
-          </a:p>
         </p:txBody>
       </p:sp>
     </p:spTree>
+    <p:extLst>
+      <p:ext uri="{BB962C8B-B14F-4D97-AF65-F5344CB8AC3E}">
+        <p14:creationId xmlns:p14="http://schemas.microsoft.com/office/powerpoint/2010/main" val="3710705376"/>
+      </p:ext>
+    </p:extLst>
   </p:cSld>
   <p:clrMapOvr>
     <a:masterClrMapping/>
@@ -21750,8 +21821,8 @@
         </p:nvSpPr>
         <p:spPr>
           <a:xfrm>
-            <a:off x="548640" y="320040"/>
-            <a:ext cx="11064240" cy="640080"/>
+            <a:off x="548640" y="384048"/>
+            <a:ext cx="11064240" cy="731520"/>
           </a:xfrm>
           <a:prstGeom prst="rect">
             <a:avLst/>
@@ -21773,13 +21844,13 @@
               </a:spcAft>
             </a:pPr>
             <a:r>
-              <a:rPr sz="2400" b="1">
+              <a:rPr sz="2800" b="1">
                 <a:solidFill>
                   <a:srgbClr val="14141C"/>
                 </a:solidFill>
                 <a:latin typeface="Helvetica Neue"/>
               </a:rPr>
-              <a:t>The pipeline, end to end</a:t>
+              <a:t>What we built, end to end</a:t>
             </a:r>
           </a:p>
         </p:txBody>
@@ -21792,8 +21863,8 @@
         </p:nvSpPr>
         <p:spPr>
           <a:xfrm>
-            <a:off x="548640" y="960120"/>
-            <a:ext cx="1463040" cy="54864"/>
+            <a:off x="548640" y="1115568"/>
+            <a:ext cx="1463040" cy="64008"/>
           </a:xfrm>
           <a:prstGeom prst="rect">
             <a:avLst/>
@@ -21829,40 +21900,16 @@
           </a:p>
         </p:txBody>
       </p:sp>
-      <p:pic>
-        <p:nvPicPr>
-          <p:cNvPr id="4" name="Picture 3" descr="diagram_pipeline.png"/>
-          <p:cNvPicPr>
-            <a:picLocks noChangeAspect="1"/>
-          </p:cNvPicPr>
-          <p:nvPr/>
-        </p:nvPicPr>
-        <p:blipFill>
-          <a:blip r:embed="rId3"/>
-          <a:stretch>
-            <a:fillRect/>
-          </a:stretch>
-        </p:blipFill>
-        <p:spPr>
-          <a:xfrm>
-            <a:off x="1828647" y="1325880"/>
-            <a:ext cx="8534400" cy="4800600"/>
-          </a:xfrm>
-          <a:prstGeom prst="rect">
-            <a:avLst/>
-          </a:prstGeom>
-        </p:spPr>
-      </p:pic>
-      <p:sp>
-        <p:nvSpPr>
-          <p:cNvPr id="5" name="TextBox 4"/>
+      <p:sp>
+        <p:nvSpPr>
+          <p:cNvPr id="4" name="TextBox 3"/>
           <p:cNvSpPr txBox="1"/>
           <p:nvPr/>
         </p:nvSpPr>
         <p:spPr>
           <a:xfrm>
-            <a:off x="685800" y="6236208"/>
-            <a:ext cx="10881360" cy="457200"/>
+            <a:off x="685800" y="1463040"/>
+            <a:ext cx="10881360" cy="4754880"/>
           </a:xfrm>
           <a:prstGeom prst="rect">
             <a:avLst/>
@@ -21880,24 +21927,172 @@
                 <a:spcPct val="105000"/>
               </a:lnSpc>
               <a:spcAft>
-                <a:spcPts val="600"/>
-              </a:spcAft>
-            </a:pPr>
-            <a:r>
-              <a:rPr sz="1200" b="0">
+                <a:spcPts val="900"/>
+              </a:spcAft>
+            </a:pPr>
+            <a:r>
+              <a:rPr sz="1500" b="0" dirty="0">
+                <a:solidFill>
+                  <a:srgbClr val="14141C"/>
+                </a:solidFill>
+                <a:latin typeface="Helvetica Neue"/>
+              </a:rPr>
+              <a:t>•  A measurement pipeline: 14 banks, 51 pages across 6 product families (18 of them current-account), 104 declared features, one frozen contract.</a:t>
+            </a:r>
+          </a:p>
+          <a:p>
+            <a:pPr algn="l">
+              <a:lnSpc>
+                <a:spcPct val="105000"/>
+              </a:lnSpc>
+              <a:spcAft>
+                <a:spcPts val="900"/>
+              </a:spcAft>
+            </a:pPr>
+            <a:r>
+              <a:rPr sz="1500" b="0" dirty="0">
+                <a:solidFill>
+                  <a:srgbClr val="14141C"/>
+                </a:solidFill>
+                <a:latin typeface="Helvetica Neue"/>
+              </a:rPr>
+              <a:t>•  A scoring workflow: automatic extraction, model-assisted extraction, and a human rubric for the 13 judgement features.</a:t>
+            </a:r>
+          </a:p>
+          <a:p>
+            <a:pPr algn="l">
+              <a:lnSpc>
+                <a:spcPct val="105000"/>
+              </a:lnSpc>
+              <a:spcAft>
+                <a:spcPts val="900"/>
+              </a:spcAft>
+            </a:pPr>
+            <a:r>
+              <a:rPr sz="1500" b="0" dirty="0">
+                <a:solidFill>
+                  <a:srgbClr val="14141C"/>
+                </a:solidFill>
+                <a:latin typeface="Helvetica Neue"/>
+              </a:rPr>
+              <a:t>•  An analysis library: positioning, similarity, category comparison, AI score, cross-sell, plus generated limitations.</a:t>
+            </a:r>
+          </a:p>
+          <a:p>
+            <a:pPr algn="l">
+              <a:lnSpc>
+                <a:spcPct val="105000"/>
+              </a:lnSpc>
+              <a:spcAft>
+                <a:spcPts val="900"/>
+              </a:spcAft>
+            </a:pPr>
+            <a:r>
+              <a:rPr sz="1500" b="0" dirty="0">
+                <a:solidFill>
+                  <a:srgbClr val="14141C"/>
+                </a:solidFill>
+                <a:latin typeface="Helvetica Neue"/>
+              </a:rPr>
+              <a:t>•  One web UI with ten tabs: four business views (Analysis, Trends, Reputation, Recommendations), the generated-site builder, and six read-only operator views carried over from the </a:t>
+            </a:r>
+            <a:r>
+              <a:rPr sz="1500" b="0" dirty="0" err="1">
+                <a:solidFill>
+                  <a:srgbClr val="14141C"/>
+                </a:solidFill>
+                <a:latin typeface="Helvetica Neue"/>
+              </a:rPr>
+              <a:t>Streamlit</a:t>
+            </a:r>
+            <a:r>
+              <a:rPr sz="1500" b="0" dirty="0">
+                <a:solidFill>
+                  <a:srgbClr val="14141C"/>
+                </a:solidFill>
+                <a:latin typeface="Helvetica Neue"/>
+              </a:rPr>
+              <a:t> dashboard.</a:t>
+            </a:r>
+          </a:p>
+          <a:p>
+            <a:pPr algn="l">
+              <a:lnSpc>
+                <a:spcPct val="105000"/>
+              </a:lnSpc>
+              <a:spcAft>
+                <a:spcPts val="900"/>
+              </a:spcAft>
+            </a:pPr>
+            <a:r>
+              <a:rPr sz="1500" b="0" dirty="0">
+                <a:solidFill>
+                  <a:srgbClr val="14141C"/>
+                </a:solidFill>
+                <a:latin typeface="Helvetica Neue"/>
+              </a:rPr>
+              <a:t>•  Two optional signals, both fenced off from the performance claim: search interest, and news themes.</a:t>
+            </a:r>
+          </a:p>
+          <a:p>
+            <a:pPr algn="l">
+              <a:lnSpc>
+                <a:spcPct val="105000"/>
+              </a:lnSpc>
+              <a:spcAft>
+                <a:spcPts val="900"/>
+              </a:spcAft>
+            </a:pPr>
+            <a:r>
+              <a:rPr sz="1500" b="0" dirty="0">
+                <a:solidFill>
+                  <a:srgbClr val="14141C"/>
+                </a:solidFill>
+                <a:latin typeface="Helvetica Neue"/>
+              </a:rPr>
+              <a:t>•  A generated ING website: ten pages built from the selected recommendations — an illustration of what a recommendation means in practice, not a proposal for ING's own site.</a:t>
+            </a:r>
+          </a:p>
+          <a:p>
+            <a:pPr algn="l">
+              <a:lnSpc>
+                <a:spcPct val="105000"/>
+              </a:lnSpc>
+              <a:spcAft>
+                <a:spcPts val="200"/>
+              </a:spcAft>
+            </a:pPr>
+            <a:endParaRPr sz="1500" b="0" dirty="0">
+              <a:solidFill>
+                <a:srgbClr val="14141C"/>
+              </a:solidFill>
+              <a:latin typeface="Helvetica Neue"/>
+            </a:endParaRPr>
+          </a:p>
+          <a:p>
+            <a:pPr algn="l">
+              <a:lnSpc>
+                <a:spcPct val="105000"/>
+              </a:lnSpc>
+              <a:spcAft>
+                <a:spcPts val="0"/>
+              </a:spcAft>
+            </a:pPr>
+            <a:r>
+              <a:rPr sz="1250" b="0" dirty="0">
                 <a:solidFill>
                   <a:srgbClr val="585868"/>
                 </a:solidFill>
                 <a:latin typeface="Helvetica Neue"/>
               </a:rPr>
-              <a:t>One direction, five stages. Every arrow is a script that can be re-run; the guardrail band holds at every stage.</a:t>
-            </a:r>
-          </a:p>
-        </p:txBody>
-      </p:sp>
-      <p:sp>
-        <p:nvSpPr>
-          <p:cNvPr id="6" name="TextBox 5"/>
+              <a:t>Each of those pieces is the next few slides; the pipeline diagram overleaf is the map.</a:t>
+            </a:r>
+          </a:p>
+        </p:txBody>
+      </p:sp>
+      <p:sp>
+        <p:nvSpPr>
+          <p:cNvPr id="5" name="TextBox 4"/>
           <p:cNvSpPr txBox="1"/>
           <p:nvPr/>
         </p:nvSpPr>
@@ -21939,14 +22134,14 @@
       </p:sp>
       <p:sp>
         <p:nvSpPr>
-          <p:cNvPr id="7" name="TextBox 6"/>
+          <p:cNvPr id="6" name="TextBox 5"/>
           <p:cNvSpPr txBox="1"/>
           <p:nvPr/>
         </p:nvSpPr>
         <p:spPr>
           <a:xfrm>
             <a:off x="11094415" y="6400800"/>
-            <a:ext cx="548640" cy="274320"/>
+            <a:ext cx="548640" cy="242695"/>
           </a:xfrm>
           <a:prstGeom prst="rect">
             <a:avLst/>
@@ -21968,7 +22163,7 @@
               </a:spcAft>
             </a:pPr>
             <a:r>
-              <a:rPr sz="1000" b="0">
+              <a:rPr lang="fr-FR" sz="1000" b="0" dirty="0">
                 <a:solidFill>
                   <a:srgbClr val="585868"/>
                 </a:solidFill>
@@ -21976,6 +22171,12 @@
               </a:rPr>
               <a:t>4</a:t>
             </a:r>
+            <a:endParaRPr sz="1000" b="0" dirty="0">
+              <a:solidFill>
+                <a:srgbClr val="585868"/>
+              </a:solidFill>
+              <a:latin typeface="Helvetica Neue"/>
+            </a:endParaRPr>
           </a:p>
         </p:txBody>
       </p:sp>
@@ -22945,8 +23146,8 @@
         </p:nvSpPr>
         <p:spPr>
           <a:xfrm>
-            <a:off x="548640" y="384048"/>
-            <a:ext cx="11064240" cy="731520"/>
+            <a:off x="548640" y="320040"/>
+            <a:ext cx="11064240" cy="640080"/>
           </a:xfrm>
           <a:prstGeom prst="rect">
             <a:avLst/>
@@ -22968,13 +23169,13 @@
               </a:spcAft>
             </a:pPr>
             <a:r>
-              <a:rPr sz="2800" b="1">
+              <a:rPr sz="2400" b="1">
                 <a:solidFill>
                   <a:srgbClr val="14141C"/>
                 </a:solidFill>
                 <a:latin typeface="Helvetica Neue"/>
               </a:rPr>
-              <a:t>The dataset behind this analysis</a:t>
+              <a:t>The pipeline, end to end</a:t>
             </a:r>
           </a:p>
         </p:txBody>
@@ -22987,8 +23188,8 @@
         </p:nvSpPr>
         <p:spPr>
           <a:xfrm>
-            <a:off x="548640" y="1115568"/>
-            <a:ext cx="1463040" cy="64008"/>
+            <a:off x="548640" y="960120"/>
+            <a:ext cx="1463040" cy="54864"/>
           </a:xfrm>
           <a:prstGeom prst="rect">
             <a:avLst/>
@@ -23024,16 +23225,40 @@
           </a:p>
         </p:txBody>
       </p:sp>
-      <p:sp>
-        <p:nvSpPr>
-          <p:cNvPr id="4" name="TextBox 3"/>
+      <p:pic>
+        <p:nvPicPr>
+          <p:cNvPr id="4" name="Picture 3" descr="diagram_pipeline.png"/>
+          <p:cNvPicPr>
+            <a:picLocks noChangeAspect="1"/>
+          </p:cNvPicPr>
+          <p:nvPr/>
+        </p:nvPicPr>
+        <p:blipFill>
+          <a:blip r:embed="rId3"/>
+          <a:stretch>
+            <a:fillRect/>
+          </a:stretch>
+        </p:blipFill>
+        <p:spPr>
+          <a:xfrm>
+            <a:off x="1828647" y="1325880"/>
+            <a:ext cx="8534400" cy="4800600"/>
+          </a:xfrm>
+          <a:prstGeom prst="rect">
+            <a:avLst/>
+          </a:prstGeom>
+        </p:spPr>
+      </p:pic>
+      <p:sp>
+        <p:nvSpPr>
+          <p:cNvPr id="5" name="TextBox 4"/>
           <p:cNvSpPr txBox="1"/>
           <p:nvPr/>
         </p:nvSpPr>
         <p:spPr>
           <a:xfrm>
-            <a:off x="685800" y="1463040"/>
-            <a:ext cx="10881360" cy="3464025"/>
+            <a:off x="685800" y="6236208"/>
+            <a:ext cx="10881360" cy="457200"/>
           </a:xfrm>
           <a:prstGeom prst="rect">
             <a:avLst/>
@@ -23051,417 +23276,108 @@
                 <a:spcPct val="105000"/>
               </a:lnSpc>
               <a:spcAft>
-                <a:spcPts val="200"/>
-              </a:spcAft>
-            </a:pPr>
-            <a:r>
-              <a:rPr sz="1500" b="1" dirty="0">
-                <a:solidFill>
-                  <a:srgbClr val="14141C"/>
-                </a:solidFill>
-                <a:latin typeface="Helvetica Neue"/>
-              </a:rPr>
-              <a:t>•  51 pages scored across 6 product families. This comparison: the 18 current-account pages, 14 banks, 33 comparable features</a:t>
-            </a:r>
-          </a:p>
-          <a:p>
-            <a:pPr algn="l">
-              <a:lnSpc>
-                <a:spcPct val="105000"/>
-              </a:lnSpc>
-              <a:spcAft>
-                <a:spcPts val="1000"/>
-              </a:spcAft>
-            </a:pPr>
-            <a:r>
-              <a:rPr sz="1300" b="0" dirty="0">
+                <a:spcPts val="600"/>
+              </a:spcAft>
+            </a:pPr>
+            <a:r>
+              <a:rPr sz="1200" b="0">
                 <a:solidFill>
                   <a:srgbClr val="585868"/>
                 </a:solidFill>
                 <a:latin typeface="Helvetica Neue"/>
               </a:rPr>
-              <a:t>     </a:t>
-            </a:r>
-            <a:r>
-              <a:rPr sz="1300" b="0" dirty="0" err="1">
+              <a:t>One direction, five stages. Every arrow is a script that can be re-run; the guardrail band holds at every stage.</a:t>
+            </a:r>
+          </a:p>
+        </p:txBody>
+      </p:sp>
+      <p:sp>
+        <p:nvSpPr>
+          <p:cNvPr id="6" name="TextBox 5"/>
+          <p:cNvSpPr txBox="1"/>
+          <p:nvPr/>
+        </p:nvSpPr>
+        <p:spPr>
+          <a:xfrm>
+            <a:off x="548640" y="6400800"/>
+            <a:ext cx="8229600" cy="274320"/>
+          </a:xfrm>
+          <a:prstGeom prst="rect">
+            <a:avLst/>
+          </a:prstGeom>
+          <a:noFill/>
+        </p:spPr>
+        <p:txBody>
+          <a:bodyPr wrap="square">
+            <a:spAutoFit/>
+          </a:bodyPr>
+          <a:lstStyle/>
+          <a:p>
+            <a:pPr algn="l">
+              <a:lnSpc>
+                <a:spcPct val="105000"/>
+              </a:lnSpc>
+              <a:spcAft>
+                <a:spcPts val="600"/>
+              </a:spcAft>
+            </a:pPr>
+            <a:r>
+              <a:rPr sz="1000" b="0">
                 <a:solidFill>
                   <a:srgbClr val="585868"/>
                 </a:solidFill>
                 <a:latin typeface="Helvetica Neue"/>
               </a:rPr>
-              <a:t>Argenta</a:t>
-            </a:r>
-            <a:r>
-              <a:rPr sz="1300" b="0" dirty="0">
+              <a:t>Banking Campaigns Comparator · ING DACI / Customer AI · September 2026</a:t>
+            </a:r>
+          </a:p>
+        </p:txBody>
+      </p:sp>
+      <p:sp>
+        <p:nvSpPr>
+          <p:cNvPr id="7" name="TextBox 6"/>
+          <p:cNvSpPr txBox="1"/>
+          <p:nvPr/>
+        </p:nvSpPr>
+        <p:spPr>
+          <a:xfrm>
+            <a:off x="11094415" y="6400800"/>
+            <a:ext cx="548640" cy="242695"/>
+          </a:xfrm>
+          <a:prstGeom prst="rect">
+            <a:avLst/>
+          </a:prstGeom>
+          <a:noFill/>
+        </p:spPr>
+        <p:txBody>
+          <a:bodyPr wrap="square">
+            <a:spAutoFit/>
+          </a:bodyPr>
+          <a:lstStyle/>
+          <a:p>
+            <a:pPr algn="r">
+              <a:lnSpc>
+                <a:spcPct val="105000"/>
+              </a:lnSpc>
+              <a:spcAft>
+                <a:spcPts val="600"/>
+              </a:spcAft>
+            </a:pPr>
+            <a:r>
+              <a:rPr lang="fr-FR" sz="1000" b="0" dirty="0">
                 <a:solidFill>
                   <a:srgbClr val="585868"/>
                 </a:solidFill>
                 <a:latin typeface="Helvetica Neue"/>
               </a:rPr>
-              <a:t> · Belfius · </a:t>
-            </a:r>
-            <a:r>
-              <a:rPr sz="1300" b="0" dirty="0" err="1">
-                <a:solidFill>
-                  <a:srgbClr val="585868"/>
-                </a:solidFill>
-                <a:latin typeface="Helvetica Neue"/>
-              </a:rPr>
-              <a:t>Beobank</a:t>
-            </a:r>
-            <a:r>
-              <a:rPr sz="1300" b="0" dirty="0">
-                <a:solidFill>
-                  <a:srgbClr val="585868"/>
-                </a:solidFill>
-                <a:latin typeface="Helvetica Neue"/>
-              </a:rPr>
-              <a:t> · BNP Paribas Fortis · </a:t>
-            </a:r>
-            <a:r>
-              <a:rPr sz="1300" b="0" dirty="0" err="1">
-                <a:solidFill>
-                  <a:srgbClr val="585868"/>
-                </a:solidFill>
-                <a:latin typeface="Helvetica Neue"/>
-              </a:rPr>
-              <a:t>bunq</a:t>
-            </a:r>
-            <a:r>
-              <a:rPr sz="1300" b="0" dirty="0">
-                <a:solidFill>
-                  <a:srgbClr val="585868"/>
-                </a:solidFill>
-                <a:latin typeface="Helvetica Neue"/>
-              </a:rPr>
-              <a:t> · CBC · </a:t>
-            </a:r>
-            <a:r>
-              <a:rPr sz="1300" b="0" dirty="0" err="1">
-                <a:solidFill>
-                  <a:srgbClr val="585868"/>
-                </a:solidFill>
-                <a:latin typeface="Helvetica Neue"/>
-              </a:rPr>
-              <a:t>Crelan</a:t>
-            </a:r>
-            <a:r>
-              <a:rPr sz="1300" b="0" dirty="0">
-                <a:solidFill>
-                  <a:srgbClr val="585868"/>
-                </a:solidFill>
-                <a:latin typeface="Helvetica Neue"/>
-              </a:rPr>
-              <a:t> · </a:t>
-            </a:r>
-            <a:r>
-              <a:rPr sz="1300" b="0" dirty="0" err="1">
-                <a:solidFill>
-                  <a:srgbClr val="585868"/>
-                </a:solidFill>
-                <a:latin typeface="Helvetica Neue"/>
-              </a:rPr>
-              <a:t>Hellobank</a:t>
-            </a:r>
-            <a:r>
-              <a:rPr sz="1300" b="0" dirty="0">
-                <a:solidFill>
-                  <a:srgbClr val="585868"/>
-                </a:solidFill>
-                <a:latin typeface="Helvetica Neue"/>
-              </a:rPr>
-              <a:t> · ING · KBC · </a:t>
-            </a:r>
-            <a:r>
-              <a:rPr sz="1300" b="0" dirty="0" err="1">
-                <a:solidFill>
-                  <a:srgbClr val="585868"/>
-                </a:solidFill>
-                <a:latin typeface="Helvetica Neue"/>
-              </a:rPr>
-              <a:t>Keytrade</a:t>
-            </a:r>
-            <a:r>
-              <a:rPr sz="1300" b="0" dirty="0">
-                <a:solidFill>
-                  <a:srgbClr val="585868"/>
-                </a:solidFill>
-                <a:latin typeface="Helvetica Neue"/>
-              </a:rPr>
-              <a:t> · N26 · </a:t>
-            </a:r>
-            <a:r>
-              <a:rPr sz="1300" b="0" dirty="0" err="1">
-                <a:solidFill>
-                  <a:srgbClr val="585868"/>
-                </a:solidFill>
-                <a:latin typeface="Helvetica Neue"/>
-              </a:rPr>
-              <a:t>Revolut</a:t>
-            </a:r>
-            <a:r>
-              <a:rPr sz="1300" b="0" dirty="0">
-                <a:solidFill>
-                  <a:srgbClr val="585868"/>
-                </a:solidFill>
-                <a:latin typeface="Helvetica Neue"/>
-              </a:rPr>
-              <a:t> · </a:t>
-            </a:r>
-            <a:r>
-              <a:rPr sz="1300" b="0" dirty="0" err="1">
-                <a:solidFill>
-                  <a:srgbClr val="585868"/>
-                </a:solidFill>
-                <a:latin typeface="Helvetica Neue"/>
-              </a:rPr>
-              <a:t>Vdk</a:t>
-            </a:r>
-            <a:endParaRPr sz="1300" b="0" dirty="0">
+              <a:t>5</a:t>
+            </a:r>
+            <a:endParaRPr sz="1000" b="0" dirty="0">
               <a:solidFill>
                 <a:srgbClr val="585868"/>
               </a:solidFill>
               <a:latin typeface="Helvetica Neue"/>
             </a:endParaRPr>
-          </a:p>
-          <a:p>
-            <a:pPr algn="l">
-              <a:lnSpc>
-                <a:spcPct val="105000"/>
-              </a:lnSpc>
-              <a:spcAft>
-                <a:spcPts val="200"/>
-              </a:spcAft>
-            </a:pPr>
-            <a:r>
-              <a:rPr sz="1500" b="1" dirty="0">
-                <a:solidFill>
-                  <a:srgbClr val="14141C"/>
-                </a:solidFill>
-                <a:latin typeface="Helvetica Neue"/>
-              </a:rPr>
-              <a:t>•  Mostly Belgian French — plus two English pages and one Dutch</a:t>
-            </a:r>
-          </a:p>
-          <a:p>
-            <a:pPr algn="l">
-              <a:lnSpc>
-                <a:spcPct val="105000"/>
-              </a:lnSpc>
-              <a:spcAft>
-                <a:spcPts val="1000"/>
-              </a:spcAft>
-            </a:pPr>
-            <a:r>
-              <a:rPr sz="1300" b="0" dirty="0">
-                <a:solidFill>
-                  <a:srgbClr val="585868"/>
-                </a:solidFill>
-                <a:latin typeface="Helvetica Neue"/>
-              </a:rPr>
-              <a:t>     Word counts and readability are within-language features, so with more than one language present the comparison drops eight of them rather than compare across languages. </a:t>
-            </a:r>
-            <a:endParaRPr lang="fr-FR" sz="1300" b="0" dirty="0">
-              <a:solidFill>
-                <a:srgbClr val="585868"/>
-              </a:solidFill>
-              <a:latin typeface="Helvetica Neue"/>
-            </a:endParaRPr>
-          </a:p>
-          <a:p>
-            <a:pPr algn="l">
-              <a:lnSpc>
-                <a:spcPct val="105000"/>
-              </a:lnSpc>
-              <a:spcAft>
-                <a:spcPts val="1000"/>
-              </a:spcAft>
-            </a:pPr>
-            <a:r>
-              <a:rPr sz="1500" b="1" dirty="0">
-                <a:solidFill>
-                  <a:srgbClr val="14141C"/>
-                </a:solidFill>
-                <a:latin typeface="Helvetica Neue"/>
-              </a:rPr>
-              <a:t>•  Split for like-for-like comparison</a:t>
-            </a:r>
-          </a:p>
-          <a:p>
-            <a:pPr algn="l">
-              <a:lnSpc>
-                <a:spcPct val="105000"/>
-              </a:lnSpc>
-              <a:spcAft>
-                <a:spcPts val="1000"/>
-              </a:spcAft>
-            </a:pPr>
-            <a:r>
-              <a:rPr sz="1300" b="0" dirty="0">
-                <a:solidFill>
-                  <a:srgbClr val="585868"/>
-                </a:solidFill>
-                <a:latin typeface="Helvetica Neue"/>
-              </a:rPr>
-              <a:t>     10 traditional banks and 4 challengers, compared one product family at a time — a mortgage page and a current-account page differ because the products differ.</a:t>
-            </a:r>
-          </a:p>
-          <a:p>
-            <a:pPr algn="l">
-              <a:lnSpc>
-                <a:spcPct val="105000"/>
-              </a:lnSpc>
-              <a:spcAft>
-                <a:spcPts val="200"/>
-              </a:spcAft>
-            </a:pPr>
-            <a:r>
-              <a:rPr sz="1500" b="1" dirty="0">
-                <a:solidFill>
-                  <a:srgbClr val="14141C"/>
-                </a:solidFill>
-                <a:latin typeface="Helvetica Neue"/>
-              </a:rPr>
-              <a:t>•  The dataset is in git, alongside the contract</a:t>
-            </a:r>
-          </a:p>
-          <a:p>
-            <a:pPr algn="l">
-              <a:lnSpc>
-                <a:spcPct val="105000"/>
-              </a:lnSpc>
-              <a:spcAft>
-                <a:spcPts val="1000"/>
-              </a:spcAft>
-            </a:pPr>
-            <a:r>
-              <a:rPr sz="1300" b="0" dirty="0">
-                <a:solidFill>
-                  <a:srgbClr val="585868"/>
-                </a:solidFill>
-                <a:latin typeface="Helvetica Neue"/>
-              </a:rPr>
-              <a:t>     Captures, datasets and outputs are tracked, so any figure on a slide traces back to the exact committed run that produced it.</a:t>
-            </a:r>
-          </a:p>
-          <a:p>
-            <a:pPr algn="l">
-              <a:lnSpc>
-                <a:spcPct val="105000"/>
-              </a:lnSpc>
-              <a:spcAft>
-                <a:spcPts val="200"/>
-              </a:spcAft>
-            </a:pPr>
-            <a:endParaRPr sz="1300" b="0" dirty="0">
-              <a:solidFill>
-                <a:srgbClr val="585868"/>
-              </a:solidFill>
-              <a:latin typeface="Helvetica Neue"/>
-            </a:endParaRPr>
-          </a:p>
-          <a:p>
-            <a:pPr algn="l">
-              <a:lnSpc>
-                <a:spcPct val="105000"/>
-              </a:lnSpc>
-              <a:spcAft>
-                <a:spcPts val="0"/>
-              </a:spcAft>
-            </a:pPr>
-            <a:r>
-              <a:rPr sz="1250" b="0" dirty="0">
-                <a:solidFill>
-                  <a:srgbClr val="585868"/>
-                </a:solidFill>
-                <a:latin typeface="Helvetica Neue"/>
-              </a:rPr>
-              <a:t>A snapshot is the honest shape for a finding: true for one dataset, one capture date, one scope.</a:t>
-            </a:r>
-          </a:p>
-        </p:txBody>
-      </p:sp>
-      <p:sp>
-        <p:nvSpPr>
-          <p:cNvPr id="5" name="TextBox 4"/>
-          <p:cNvSpPr txBox="1"/>
-          <p:nvPr/>
-        </p:nvSpPr>
-        <p:spPr>
-          <a:xfrm>
-            <a:off x="548640" y="6400800"/>
-            <a:ext cx="8229600" cy="274320"/>
-          </a:xfrm>
-          <a:prstGeom prst="rect">
-            <a:avLst/>
-          </a:prstGeom>
-          <a:noFill/>
-        </p:spPr>
-        <p:txBody>
-          <a:bodyPr wrap="square">
-            <a:spAutoFit/>
-          </a:bodyPr>
-          <a:lstStyle/>
-          <a:p>
-            <a:pPr algn="l">
-              <a:lnSpc>
-                <a:spcPct val="105000"/>
-              </a:lnSpc>
-              <a:spcAft>
-                <a:spcPts val="600"/>
-              </a:spcAft>
-            </a:pPr>
-            <a:r>
-              <a:rPr sz="1000" b="0">
-                <a:solidFill>
-                  <a:srgbClr val="585868"/>
-                </a:solidFill>
-                <a:latin typeface="Helvetica Neue"/>
-              </a:rPr>
-              <a:t>Banking Campaigns Comparator · ING DACI / Customer AI · September 2026</a:t>
-            </a:r>
-          </a:p>
-        </p:txBody>
-      </p:sp>
-      <p:sp>
-        <p:nvSpPr>
-          <p:cNvPr id="6" name="TextBox 5"/>
-          <p:cNvSpPr txBox="1"/>
-          <p:nvPr/>
-        </p:nvSpPr>
-        <p:spPr>
-          <a:xfrm>
-            <a:off x="11094415" y="6400800"/>
-            <a:ext cx="548640" cy="274320"/>
-          </a:xfrm>
-          <a:prstGeom prst="rect">
-            <a:avLst/>
-          </a:prstGeom>
-          <a:noFill/>
-        </p:spPr>
-        <p:txBody>
-          <a:bodyPr wrap="square">
-            <a:spAutoFit/>
-          </a:bodyPr>
-          <a:lstStyle/>
-          <a:p>
-            <a:pPr algn="r">
-              <a:lnSpc>
-                <a:spcPct val="105000"/>
-              </a:lnSpc>
-              <a:spcAft>
-                <a:spcPts val="600"/>
-              </a:spcAft>
-            </a:pPr>
-            <a:r>
-              <a:rPr sz="1000" b="0">
-                <a:solidFill>
-                  <a:srgbClr val="585868"/>
-                </a:solidFill>
-                <a:latin typeface="Helvetica Neue"/>
-              </a:rPr>
-              <a:t>5</a:t>
-            </a:r>
           </a:p>
         </p:txBody>
       </p:sp>
@@ -23527,7 +23443,7 @@
                 </a:solidFill>
                 <a:latin typeface="Helvetica Neue"/>
               </a:rPr>
-              <a:t>Rubric scoring: one human judge, and a model measured against it</a:t>
+              <a:t>The dataset behind this analysis</a:t>
             </a:r>
           </a:p>
         </p:txBody>
@@ -23540,7 +23456,7 @@
         </p:nvSpPr>
         <p:spPr>
           <a:xfrm>
-            <a:off x="548640" y="1371600"/>
+            <a:off x="548640" y="1115568"/>
             <a:ext cx="1463040" cy="64008"/>
           </a:xfrm>
           <a:prstGeom prst="rect">
@@ -23586,7 +23502,7 @@
         <p:spPr>
           <a:xfrm>
             <a:off x="685800" y="1463040"/>
-            <a:ext cx="10881360" cy="4754880"/>
+            <a:ext cx="10881360" cy="3464025"/>
           </a:xfrm>
           <a:prstGeom prst="rect">
             <a:avLst/>
@@ -23608,13 +23524,13 @@
               </a:spcAft>
             </a:pPr>
             <a:r>
-              <a:rPr sz="1500" b="1">
+              <a:rPr sz="1500" b="1" dirty="0">
                 <a:solidFill>
                   <a:srgbClr val="14141C"/>
                 </a:solidFill>
                 <a:latin typeface="Helvetica Neue"/>
               </a:rPr>
-              <a:t>•  13 features are judgements, not measurements</a:t>
+              <a:t>•  51 pages scored across 6 product families. This comparison: the 18 current-account pages, 14 banks, 33 comparable features</a:t>
             </a:r>
           </a:p>
           <a:p>
@@ -23627,14 +23543,155 @@
               </a:spcAft>
             </a:pPr>
             <a:r>
-              <a:rPr sz="1300" b="0">
+              <a:rPr sz="1300" b="0" dirty="0">
                 <a:solidFill>
                   <a:srgbClr val="585868"/>
                 </a:solidFill>
                 <a:latin typeface="Helvetica Neue"/>
               </a:rPr>
-              <a:t>     Clarity of the offer, layout archetype, AIDA coverage, persuasion levers — scored against a written scale, one sheet per rater.</a:t>
-            </a:r>
+              <a:t>     </a:t>
+            </a:r>
+            <a:r>
+              <a:rPr sz="1300" b="0" dirty="0" err="1">
+                <a:solidFill>
+                  <a:srgbClr val="585868"/>
+                </a:solidFill>
+                <a:latin typeface="Helvetica Neue"/>
+              </a:rPr>
+              <a:t>Argenta</a:t>
+            </a:r>
+            <a:r>
+              <a:rPr sz="1300" b="0" dirty="0">
+                <a:solidFill>
+                  <a:srgbClr val="585868"/>
+                </a:solidFill>
+                <a:latin typeface="Helvetica Neue"/>
+              </a:rPr>
+              <a:t> · Belfius · </a:t>
+            </a:r>
+            <a:r>
+              <a:rPr sz="1300" b="0" dirty="0" err="1">
+                <a:solidFill>
+                  <a:srgbClr val="585868"/>
+                </a:solidFill>
+                <a:latin typeface="Helvetica Neue"/>
+              </a:rPr>
+              <a:t>Beobank</a:t>
+            </a:r>
+            <a:r>
+              <a:rPr sz="1300" b="0" dirty="0">
+                <a:solidFill>
+                  <a:srgbClr val="585868"/>
+                </a:solidFill>
+                <a:latin typeface="Helvetica Neue"/>
+              </a:rPr>
+              <a:t> · BNP Paribas Fortis · </a:t>
+            </a:r>
+            <a:r>
+              <a:rPr sz="1300" b="0" dirty="0" err="1">
+                <a:solidFill>
+                  <a:srgbClr val="585868"/>
+                </a:solidFill>
+                <a:latin typeface="Helvetica Neue"/>
+              </a:rPr>
+              <a:t>bunq</a:t>
+            </a:r>
+            <a:r>
+              <a:rPr sz="1300" b="0" dirty="0">
+                <a:solidFill>
+                  <a:srgbClr val="585868"/>
+                </a:solidFill>
+                <a:latin typeface="Helvetica Neue"/>
+              </a:rPr>
+              <a:t> · CBC · </a:t>
+            </a:r>
+            <a:r>
+              <a:rPr sz="1300" b="0" dirty="0" err="1">
+                <a:solidFill>
+                  <a:srgbClr val="585868"/>
+                </a:solidFill>
+                <a:latin typeface="Helvetica Neue"/>
+              </a:rPr>
+              <a:t>Crelan</a:t>
+            </a:r>
+            <a:r>
+              <a:rPr sz="1300" b="0" dirty="0">
+                <a:solidFill>
+                  <a:srgbClr val="585868"/>
+                </a:solidFill>
+                <a:latin typeface="Helvetica Neue"/>
+              </a:rPr>
+              <a:t> · </a:t>
+            </a:r>
+            <a:r>
+              <a:rPr sz="1300" b="0" dirty="0" err="1">
+                <a:solidFill>
+                  <a:srgbClr val="585868"/>
+                </a:solidFill>
+                <a:latin typeface="Helvetica Neue"/>
+              </a:rPr>
+              <a:t>Hellobank</a:t>
+            </a:r>
+            <a:r>
+              <a:rPr sz="1300" b="0" dirty="0">
+                <a:solidFill>
+                  <a:srgbClr val="585868"/>
+                </a:solidFill>
+                <a:latin typeface="Helvetica Neue"/>
+              </a:rPr>
+              <a:t> · ING · KBC · </a:t>
+            </a:r>
+            <a:r>
+              <a:rPr sz="1300" b="0" dirty="0" err="1">
+                <a:solidFill>
+                  <a:srgbClr val="585868"/>
+                </a:solidFill>
+                <a:latin typeface="Helvetica Neue"/>
+              </a:rPr>
+              <a:t>Keytrade</a:t>
+            </a:r>
+            <a:r>
+              <a:rPr sz="1300" b="0" dirty="0">
+                <a:solidFill>
+                  <a:srgbClr val="585868"/>
+                </a:solidFill>
+                <a:latin typeface="Helvetica Neue"/>
+              </a:rPr>
+              <a:t> · N26 · </a:t>
+            </a:r>
+            <a:r>
+              <a:rPr sz="1300" b="0" dirty="0" err="1">
+                <a:solidFill>
+                  <a:srgbClr val="585868"/>
+                </a:solidFill>
+                <a:latin typeface="Helvetica Neue"/>
+              </a:rPr>
+              <a:t>Revolut</a:t>
+            </a:r>
+            <a:r>
+              <a:rPr sz="1300" b="0" dirty="0">
+                <a:solidFill>
+                  <a:srgbClr val="585868"/>
+                </a:solidFill>
+                <a:latin typeface="Helvetica Neue"/>
+              </a:rPr>
+              <a:t> · </a:t>
+            </a:r>
+            <a:r>
+              <a:rPr sz="1300" b="0" dirty="0" err="1">
+                <a:solidFill>
+                  <a:srgbClr val="585868"/>
+                </a:solidFill>
+                <a:latin typeface="Helvetica Neue"/>
+              </a:rPr>
+              <a:t>Vdk</a:t>
+            </a:r>
+            <a:endParaRPr sz="1300" b="0" dirty="0">
+              <a:solidFill>
+                <a:srgbClr val="585868"/>
+              </a:solidFill>
+              <a:latin typeface="Helvetica Neue"/>
+            </a:endParaRPr>
           </a:p>
           <a:p>
             <a:pPr algn="l">
@@ -23646,13 +23703,13 @@
               </a:spcAft>
             </a:pPr>
             <a:r>
-              <a:rPr sz="1500" b="1">
+              <a:rPr sz="1500" b="1" dirty="0">
                 <a:solidFill>
                   <a:srgbClr val="14141C"/>
                 </a:solidFill>
                 <a:latin typeface="Helvetica Neue"/>
               </a:rPr>
-              <a:t>•  One human judge for this pass, stated plainly</a:t>
+              <a:t>•  Mostly Belgian French — plus two English pages and one Dutch</a:t>
             </a:r>
           </a:p>
           <a:p>
@@ -23665,13 +23722,57 @@
               </a:spcAft>
             </a:pPr>
             <a:r>
-              <a:rPr sz="1300" b="0">
+              <a:rPr sz="1300" b="0" dirty="0">
                 <a:solidFill>
                   <a:srgbClr val="585868"/>
                 </a:solidFill>
                 <a:latin typeface="Helvetica Neue"/>
               </a:rPr>
-              <a:t>     Every judged feature on all 51 pages comes from one sheet. Earlier passes split pages between raters; this one does not, and we say so rather than presenting a single opinion as a consensus.</a:t>
+              <a:t>     Word counts and readability are within-language features, so with more than one language present the comparison drops eight of them rather than compare across languages. </a:t>
+            </a:r>
+            <a:endParaRPr lang="fr-FR" sz="1300" b="0" dirty="0">
+              <a:solidFill>
+                <a:srgbClr val="585868"/>
+              </a:solidFill>
+              <a:latin typeface="Helvetica Neue"/>
+            </a:endParaRPr>
+          </a:p>
+          <a:p>
+            <a:pPr algn="l">
+              <a:lnSpc>
+                <a:spcPct val="105000"/>
+              </a:lnSpc>
+              <a:spcAft>
+                <a:spcPts val="1000"/>
+              </a:spcAft>
+            </a:pPr>
+            <a:r>
+              <a:rPr sz="1500" b="1" dirty="0">
+                <a:solidFill>
+                  <a:srgbClr val="14141C"/>
+                </a:solidFill>
+                <a:latin typeface="Helvetica Neue"/>
+              </a:rPr>
+              <a:t>•  Split for like-for-like comparison</a:t>
+            </a:r>
+          </a:p>
+          <a:p>
+            <a:pPr algn="l">
+              <a:lnSpc>
+                <a:spcPct val="105000"/>
+              </a:lnSpc>
+              <a:spcAft>
+                <a:spcPts val="1000"/>
+              </a:spcAft>
+            </a:pPr>
+            <a:r>
+              <a:rPr sz="1300" b="0" dirty="0">
+                <a:solidFill>
+                  <a:srgbClr val="585868"/>
+                </a:solidFill>
+                <a:latin typeface="Helvetica Neue"/>
+              </a:rPr>
+              <a:t>     10 traditional banks and 4 challengers, compared one product family at a time — a mortgage page and a current-account page differ because the products differ.</a:t>
             </a:r>
           </a:p>
           <a:p>
@@ -23684,13 +23785,13 @@
               </a:spcAft>
             </a:pPr>
             <a:r>
-              <a:rPr sz="1500" b="1">
+              <a:rPr sz="1500" b="1" dirty="0">
                 <a:solidFill>
                   <a:srgbClr val="14141C"/>
                 </a:solidFill>
                 <a:latin typeface="Helvetica Neue"/>
               </a:rPr>
-              <a:t>•  A model sheet exists, and it is not a second opinion</a:t>
+              <a:t>•  The dataset is in git, alongside the contract</a:t>
             </a:r>
           </a:p>
           <a:p>
@@ -23703,13 +23804,13 @@
               </a:spcAft>
             </a:pPr>
             <a:r>
-              <a:rPr sz="1300" b="0">
+              <a:rPr sz="1300" b="0" dirty="0">
                 <a:solidFill>
                   <a:srgbClr val="585868"/>
                 </a:solidFill>
                 <a:latin typeface="Helvetica Neue"/>
               </a:rPr>
-              <a:t>     50 pages, written to its own file, never into a human sheet - a pre-filled sheet gets rubber-stamped. But the pinned model has no vision, and 12 of the 13 judged features are declared in the dictionary as judged from the screenshot.</a:t>
+              <a:t>     Captures, datasets and outputs are tracked, so any figure on a slide traces back to the exact committed run that produced it.</a:t>
             </a:r>
           </a:p>
           <a:p>
@@ -23721,71 +23822,30 @@
                 <a:spcPts val="200"/>
               </a:spcAft>
             </a:pPr>
-            <a:r>
-              <a:rPr sz="1500" b="1">
-                <a:solidFill>
-                  <a:srgbClr val="14141C"/>
-                </a:solidFill>
-                <a:latin typeface="Helvetica Neue"/>
-              </a:rPr>
-              <a:t>•  Only one was scored from text, and that was a choice we can now revisit</a:t>
-            </a:r>
-          </a:p>
-          <a:p>
-            <a:pPr algn="l">
-              <a:lnSpc>
-                <a:spcPct val="105000"/>
-              </a:lnSpc>
-              <a:spcAft>
-                <a:spcPts val="1000"/>
-              </a:spcAft>
-            </a:pPr>
-            <a:r>
-              <a:rPr sz="1300" b="0">
+            <a:endParaRPr sz="1300" b="0" dirty="0">
+              <a:solidFill>
+                <a:srgbClr val="585868"/>
+              </a:solidFill>
+              <a:latin typeface="Helvetica Neue"/>
+            </a:endParaRPr>
+          </a:p>
+          <a:p>
+            <a:pPr algn="l">
+              <a:lnSpc>
+                <a:spcPct val="105000"/>
+              </a:lnSpc>
+              <a:spcAft>
+                <a:spcPts val="0"/>
+              </a:spcAft>
+            </a:pPr>
+            <a:r>
+              <a:rPr sz="1250" b="0" dirty="0">
                 <a:solidFill>
                   <a:srgbClr val="585868"/>
                 </a:solidFill>
                 <a:latin typeface="Helvetica Neue"/>
               </a:rPr>
-              <a:t>     formality_score is the one the dictionary sources from html_text, and there the model lands within one point of the human 73% of the time. Its scores on the twelve visual features answer a question the text alone cannot settle — on value_prop_clarity it ranked the pages close to the opposite of the human. Tested since: the pinned model returns nothing at all when handed an image. OCR is the route we have not used, and it is a real one — it returns each word with its position and type size, which is most of what rate prominence, layout and mobile-first actually ask.</a:t>
-            </a:r>
-          </a:p>
-          <a:p>
-            <a:pPr algn="l">
-              <a:lnSpc>
-                <a:spcPct val="105000"/>
-              </a:lnSpc>
-              <a:spcAft>
-                <a:spcPts val="200"/>
-              </a:spcAft>
-            </a:pPr>
-            <a:r>
-              <a:rPr sz="1500" b="1">
-                <a:solidFill>
-                  <a:srgbClr val="14141C"/>
-                </a:solidFill>
-                <a:latin typeface="Helvetica Neue"/>
-              </a:rPr>
-              <a:t>•  So the model sheet is kept as a reference, not used as a rater</a:t>
-            </a:r>
-          </a:p>
-          <a:p>
-            <a:pPr algn="l">
-              <a:lnSpc>
-                <a:spcPct val="105000"/>
-              </a:lnSpc>
-              <a:spcAft>
-                <a:spcPts val="1000"/>
-              </a:spcAft>
-            </a:pPr>
-            <a:r>
-              <a:rPr sz="1300" b="0">
-                <a:solidFill>
-                  <a:srgbClr val="585868"/>
-                </a:solidFill>
-                <a:latin typeface="Helvetica Neue"/>
-              </a:rPr>
-              <a:t>     Averaging it into the human scores would import guesses as judgements. One named human judge, said out loud, is more honest than a consensus that was never there.</a:t>
+              <a:t>A snapshot is the honest shape for a finding: true for one dataset, one capture date, one scope.</a:t>
             </a:r>
           </a:p>
         </p:txBody>
@@ -23840,8 +23900,8 @@
         </p:nvSpPr>
         <p:spPr>
           <a:xfrm>
-            <a:off x="11094415" y="6400800"/>
-            <a:ext cx="548640" cy="274320"/>
+            <a:off x="11094720" y="6400800"/>
+            <a:ext cx="548640" cy="242695"/>
           </a:xfrm>
           <a:prstGeom prst="rect">
             <a:avLst/>
@@ -23863,7 +23923,7 @@
               </a:spcAft>
             </a:pPr>
             <a:r>
-              <a:rPr sz="1000" b="0">
+              <a:rPr lang="fr-FR" sz="1000" dirty="0">
                 <a:solidFill>
                   <a:srgbClr val="585868"/>
                 </a:solidFill>
@@ -23936,7 +23996,7 @@
                 </a:solidFill>
                 <a:latin typeface="Helvetica Neue"/>
               </a:rPr>
-              <a:t>Strategic context and positioning</a:t>
+              <a:t>Rubric scoring: one human judge, and a model measured against it</a:t>
             </a:r>
           </a:p>
         </p:txBody>
@@ -23949,7 +24009,7 @@
         </p:nvSpPr>
         <p:spPr>
           <a:xfrm>
-            <a:off x="548640" y="1115568"/>
+            <a:off x="548640" y="1371600"/>
             <a:ext cx="1463040" cy="64008"/>
           </a:xfrm>
           <a:prstGeom prst="rect">
@@ -23995,7 +24055,7 @@
         <p:spPr>
           <a:xfrm>
             <a:off x="685800" y="1463040"/>
-            <a:ext cx="10881360" cy="3821367"/>
+            <a:ext cx="10881360" cy="4754880"/>
           </a:xfrm>
           <a:prstGeom prst="rect">
             <a:avLst/>
@@ -24017,13 +24077,13 @@
               </a:spcAft>
             </a:pPr>
             <a:r>
-              <a:rPr sz="1500" b="1" dirty="0">
+              <a:rPr sz="1500" b="1">
                 <a:solidFill>
                   <a:srgbClr val="14141C"/>
                 </a:solidFill>
                 <a:latin typeface="Helvetica Neue"/>
               </a:rPr>
-              <a:t>•  The hybrid model</a:t>
+              <a:t>•  13 features are judgements, not measurements</a:t>
             </a:r>
           </a:p>
           <a:p>
@@ -24036,13 +24096,13 @@
               </a:spcAft>
             </a:pPr>
             <a:r>
-              <a:rPr sz="1300" b="0" dirty="0">
+              <a:rPr sz="1300" b="0">
                 <a:solidFill>
                   <a:srgbClr val="585868"/>
                 </a:solidFill>
                 <a:latin typeface="Helvetica Neue"/>
               </a:rPr>
-              <a:t>     ING blends the direct, feature-focused, mobile-first tone of a neobank with the institutional weight of a Tier-1 retail bank — regulatory authority and an established brand. </a:t>
+              <a:t>     Clarity of the offer, layout archetype, AIDA coverage, persuasion levers — scored against a written scale, one sheet per rater.</a:t>
             </a:r>
           </a:p>
           <a:p>
@@ -24055,13 +24115,13 @@
               </a:spcAft>
             </a:pPr>
             <a:r>
-              <a:rPr sz="1500" b="1" dirty="0">
+              <a:rPr sz="1500" b="1">
                 <a:solidFill>
                   <a:srgbClr val="14141C"/>
                 </a:solidFill>
                 <a:latin typeface="Helvetica Neue"/>
               </a:rPr>
-              <a:t>•  A level playing field on regulation</a:t>
+              <a:t>•  One human judge for this pass, stated plainly</a:t>
             </a:r>
           </a:p>
           <a:p>
@@ -24074,13 +24134,13 @@
               </a:spcAft>
             </a:pPr>
             <a:r>
-              <a:rPr sz="1300" b="0" dirty="0">
+              <a:rPr sz="1300" b="0">
                 <a:solidFill>
                   <a:srgbClr val="585868"/>
                 </a:solidFill>
                 <a:latin typeface="Helvetica Neue"/>
               </a:rPr>
-              <a:t>     Neobanks like Revolut hold the same European banking licenses and face the same Belgian compliance checks — including the mandatory CCP credit-registry query for consumer lending. Their speed comes from modern architecture, no branch network, and faster decision loops — not lighter rules.</a:t>
+              <a:t>     Every judged feature on all 51 pages comes from one sheet. Earlier passes split pages between raters; this one does not, and we say so rather than presenting a single opinion as a consensus.</a:t>
             </a:r>
           </a:p>
           <a:p>
@@ -24093,13 +24153,13 @@
               </a:spcAft>
             </a:pPr>
             <a:r>
-              <a:rPr sz="1500" b="1" dirty="0">
+              <a:rPr sz="1500" b="1">
                 <a:solidFill>
                   <a:srgbClr val="14141C"/>
                 </a:solidFill>
                 <a:latin typeface="Helvetica Neue"/>
               </a:rPr>
-              <a:t>•  Different monetization engines</a:t>
+              <a:t>•  A model sheet exists, and it is not a second opinion</a:t>
             </a:r>
           </a:p>
           <a:p>
@@ -24112,13 +24172,13 @@
               </a:spcAft>
             </a:pPr>
             <a:r>
-              <a:rPr sz="1300" b="0" dirty="0">
+              <a:rPr sz="1300" b="0">
                 <a:solidFill>
                   <a:srgbClr val="585868"/>
                 </a:solidFill>
                 <a:latin typeface="Helvetica Neue"/>
               </a:rPr>
-              <a:t>     Traditional banks have long used the basic current account as a loss leader — a produit d'appel — to acquire clients and monetize later through mortgages, insurance and wealth management. Neobanks flip that: transparent freemium tiers, paid subscriptions, and transactional FX / fee income, upfront.</a:t>
+              <a:t>     50 pages, written to its own file, never into a human sheet - a pre-filled sheet gets rubber-stamped. But the pinned model has no vision, and 12 of the 13 judged features are declared in the dictionary as judged from the screenshot.</a:t>
             </a:r>
           </a:p>
           <a:p>
@@ -24131,32 +24191,70 @@
               </a:spcAft>
             </a:pPr>
             <a:r>
-              <a:rPr sz="1500" b="1" dirty="0">
+              <a:rPr sz="1500" b="1">
                 <a:solidFill>
                   <a:srgbClr val="14141C"/>
                 </a:solidFill>
                 <a:latin typeface="Helvetica Neue"/>
               </a:rPr>
-              <a:t>•  Who each side is chasing</a:t>
-            </a:r>
-          </a:p>
-          <a:p>
-            <a:pPr algn="l">
-              <a:lnSpc>
-                <a:spcPct val="105000"/>
-              </a:lnSpc>
-              <a:spcAft>
-                <a:spcPts val="0"/>
-              </a:spcAft>
-            </a:pPr>
-            <a:r>
-              <a:rPr sz="1300" b="0" dirty="0">
+              <a:t>•  Only one was scored from text, and that was a choice we can now revisit</a:t>
+            </a:r>
+          </a:p>
+          <a:p>
+            <a:pPr algn="l">
+              <a:lnSpc>
+                <a:spcPct val="105000"/>
+              </a:lnSpc>
+              <a:spcAft>
+                <a:spcPts val="1000"/>
+              </a:spcAft>
+            </a:pPr>
+            <a:r>
+              <a:rPr sz="1300" b="0">
                 <a:solidFill>
                   <a:srgbClr val="585868"/>
                 </a:solidFill>
                 <a:latin typeface="Helvetica Neue"/>
               </a:rPr>
-              <a:t>     Neobanks win volume among young adults, digital nomads and casual spenders. ING's acquisition budget targets high lifetime-value segments instead: first-time investors, expats and high-net-worth individuals, and first-time buyers in mortgage and real estate. Professional and business banking is out of scope for this comparison — retail only.</a:t>
+              <a:t>     formality_score is the one the dictionary sources from html_text, and there the model lands within one point of the human 73% of the time. Its scores on the twelve visual features answer a question the text alone cannot settle — on value_prop_clarity it ranked the pages close to the opposite of the human. Tested since: the pinned model returns nothing at all when handed an image. OCR is the route we have not used, and it is a real one — it returns each word with its position and type size, which is most of what rate prominence, layout and mobile-first actually ask.</a:t>
+            </a:r>
+          </a:p>
+          <a:p>
+            <a:pPr algn="l">
+              <a:lnSpc>
+                <a:spcPct val="105000"/>
+              </a:lnSpc>
+              <a:spcAft>
+                <a:spcPts val="200"/>
+              </a:spcAft>
+            </a:pPr>
+            <a:r>
+              <a:rPr sz="1500" b="1">
+                <a:solidFill>
+                  <a:srgbClr val="14141C"/>
+                </a:solidFill>
+                <a:latin typeface="Helvetica Neue"/>
+              </a:rPr>
+              <a:t>•  So the model sheet is kept as a reference, not used as a rater</a:t>
+            </a:r>
+          </a:p>
+          <a:p>
+            <a:pPr algn="l">
+              <a:lnSpc>
+                <a:spcPct val="105000"/>
+              </a:lnSpc>
+              <a:spcAft>
+                <a:spcPts val="1000"/>
+              </a:spcAft>
+            </a:pPr>
+            <a:r>
+              <a:rPr sz="1300" b="0">
+                <a:solidFill>
+                  <a:srgbClr val="585868"/>
+                </a:solidFill>
+                <a:latin typeface="Helvetica Neue"/>
+              </a:rPr>
+              <a:t>     Averaging it into the human scores would import guesses as judgements. One named human judge, said out loud, is more honest than a consensus that was never there.</a:t>
             </a:r>
           </a:p>
         </p:txBody>
@@ -24212,7 +24310,7 @@
         <p:spPr>
           <a:xfrm>
             <a:off x="11094415" y="6400800"/>
-            <a:ext cx="548640" cy="274320"/>
+            <a:ext cx="548640" cy="242695"/>
           </a:xfrm>
           <a:prstGeom prst="rect">
             <a:avLst/>
@@ -24234,7 +24332,7 @@
               </a:spcAft>
             </a:pPr>
             <a:r>
-              <a:rPr sz="1000" b="0">
+              <a:rPr lang="fr-FR" sz="1000" dirty="0">
                 <a:solidFill>
                   <a:srgbClr val="585868"/>
                 </a:solidFill>
@@ -24242,6 +24340,12 @@
               </a:rPr>
               <a:t>7</a:t>
             </a:r>
+            <a:endParaRPr sz="1000" b="0" dirty="0">
+              <a:solidFill>
+                <a:srgbClr val="585868"/>
+              </a:solidFill>
+              <a:latin typeface="Helvetica Neue"/>
+            </a:endParaRPr>
           </a:p>
         </p:txBody>
       </p:sp>

</xml_diff>

<commit_message>
chore: test network block, bank-facts tests, drop the unused none sentinel
Ported from fix/none-sentinel-and-deck-count (5 Oct), which never reached main.
tests/conftest.py blocks every socket so no test can reach the network;
tests/test_banks.py covers banks.py, which had no test. The none sentinel was
never an allowed value of persuasion_levers or accent_locations and appears in
zero cells, so derive.py and lever_frequency stop filtering it; counted both
ways, the 51 rows of campaigns_scored.csv agree. Deck slide 22 now says 33
compared features, as slide 17 does. README and the deep dive keep main's
current text.
</commit_message>
<xml_diff>
--- a/docs/Banking_Campaigns_Comparator.pptx
+++ b/docs/Banking_Campaigns_Comparator.pptx
@@ -16105,7 +16105,7 @@
                 </a:solidFill>
                 <a:latin typeface="Helvetica Neue"/>
               </a:rPr>
-              <a:t>•  104 declared features, 36 actually compared</a:t>
+              <a:t>•  104 declared features, 33 actually compared</a:t>
             </a:r>
           </a:p>
           <a:p>
@@ -16124,7 +16124,7 @@
                 </a:solidFill>
                 <a:latin typeface="Helvetica Neue"/>
               </a:rPr>
-              <a:t>     Nothing is hidden in that reduction — the run prints it: 18 provenance fields that identify a page rather than describe a campaign, 4 free-text identifiers no two pages share, 8 within_language features that stop being comparable once the set spans three languages, 27 categorical or list features a euclidean distance cannot take raw, 2 missing on at least one bank, 8 identical everywhere, and 1 withdrawn because its capture is missing what it counts.</a:t>
+              <a:t>     Nothing is hidden in that reduction — the run prints it: 18 provenance fields that identify a page rather than describe a campaign, 4 free-text identifiers no two pages share, 8 within_language features that stop being comparable once the set spans three languages, 1 within_capture_window feature that is valid for its capture date only, 5 withdrawn because the rule does not reproduce what the feature claims to measure, 27 categorical or list features a euclidean distance cannot take raw, and 8 identical everywhere.</a:t>
             </a:r>
           </a:p>
           <a:p>

</xml_diff>